<commit_message>
docs: add speaker notes to pptx and Q&A prep document
Co-Authored-By: Claude Fable 5 <noreply@anthropic.com>
</commit_message>
<xml_diff>
--- a/docs/presentation/cloud-holdem-발표.pptx
+++ b/docs/presentation/cloud-holdem-발표.pptx
@@ -515,7 +515,8 @@
           <a:p>
             <a:r>
               <a:rPr lang="en-US" dirty="0"/>
-              <a:t/>
+              <a:t>안녕하세요. AWS ECS 기반 실시간 멀티플레이어 텍사스 홀덤, "Cloud Hold'em" 프로젝트 발표를 시작하겠습니다.
+이 프로젝트는 단순히 게임을 만드는 것이 아니라, "실시간 게임 서버를 AWS 위에서 확장 가능하고 안정적으로 운영하려면 어떻게 설계해야 하는가"를 목표로 진행했습니다.</a:t>
             </a:r>
             <a:endParaRPr lang="en-US" dirty="0"/>
           </a:p>
@@ -603,7 +604,10 @@
           <a:p>
             <a:r>
               <a:rPr lang="en-US" dirty="0"/>
-              <a:t/>
+              <a:t>보안은 최소 권한 원칙으로 설계했습니다.
+보안 그룹을 IP가 아닌 "보안 그룹 참조"로 체인을 만들었습니다. ALB는 인터넷에서 80만, EC2는 ALB에서 오는 3001만, Redis는 EC2에서 오는 6379만 받습니다. 즉 Redis는 인터넷에서 아예 도달이 불가능합니다.
+IAM은 역할을 3종으로 분리했습니다. 컨테이너가 쓰는 Task Role은 S3 쓰기만, Execution Role은 ECR pull과 로그만, Instance Role은 ECS 등록만 가능합니다.
+작업용 IAM 사용자 권한도 필요한 액션만 점진적으로 추가했는데, 예를 들어 ALB 생성이 ec2:DescribeAccountAttributes라는 숨은 권한을 요구해서 실패 메시지를 분석해 추가한 경험도 있었습니다.</a:t>
             </a:r>
             <a:endParaRPr lang="en-US" dirty="0"/>
           </a:p>
@@ -691,7 +695,10 @@
           <a:p>
             <a:r>
               <a:rPr lang="en-US" dirty="0"/>
-              <a:t/>
+              <a:t>"되는 것 같다"가 아니라 증명을 목표로 검증했습니다.
+게임 엔진과 Redis 로직에 단위·통합 테스트 44개를 TDD로 작성했고, Playwright로 실제 브라우저 4개를 자동 조작해 로컬 풀 게임을 완주시켰습니다.
+가장 의미 있는 건 프로덕션 E2E입니다 — ALB를 거쳐 4개 클라이언트가 서로 다른 태스크에 분산된 상태로 쇼다운까지 완주해서, 분산 환경 설계가 실제로 동작함을 확인했습니다.
+TDD 과정에서 베팅 라운드가 끝나지 않는 버그, 턴 타이머가 영원히 발동하지 않는 버그 같은 치명적 결함들을 배포 전에 잡았습니다.</a:t>
             </a:r>
             <a:endParaRPr lang="en-US" dirty="0"/>
           </a:p>
@@ -779,7 +786,10 @@
           <a:p>
             <a:r>
               <a:rPr lang="en-US" dirty="0"/>
-              <a:t/>
+              <a:t>실제 게임 화면입니다.
+왼쪽이 로비 — 닉네임 입력 후 방을 만들거나 열린 방에 입장합니다. 4명이 모이면 5초 카운트다운 후 자동 시작됩니다.
+오른쪽이 게임 테이블 — 내 카드만 보이고 상대 카드는 가려집니다. 블라인드가 자동 차감되고, 자기 턴에만 액션 버튼과 20초 타이머가 표시됩니다.
+쇼다운이 끝나면 칩이 정산되고 다음 핸드가 자동으로 시작됩니다.</a:t>
             </a:r>
             <a:endParaRPr lang="en-US" dirty="0"/>
           </a:p>
@@ -867,7 +877,10 @@
           <a:p>
             <a:r>
               <a:rPr lang="en-US" dirty="0"/>
-              <a:t/>
+              <a:t>이제 라이브로 보여드리겠습니다. (미리 띄워둔 탭 4개로 전환)
+순서: ① 탭 4개 접속 ② 첫 탭에서 방 만들기 ③ 나머지 입장, 카운트다운 확인 ④ 콜/체크로 빠르게 한 바퀴 돌려 플랍 공개 ⑤ 시간 여유가 있으면 탭 하나를 방치해 20초 auto-fold 시연 ⑥ 쇼다운과 칩 정산.
+* 만약 네트워크 문제가 생기면 당황하지 말고 "준비된 화면으로 대체하겠습니다" 하고 앞의 스크린샷 슬라이드로 돌아갈 것.
+* 발표 전 체크: ASG 2대 켜두기, 헬스체크 green, S3 배포 확인.</a:t>
             </a:r>
             <a:endParaRPr lang="en-US" dirty="0"/>
           </a:p>
@@ -955,7 +968,10 @@
           <a:p>
             <a:r>
               <a:rPr lang="en-US" dirty="0"/>
-              <a:t/>
+              <a:t>마지막으로 비용입니다.
+EC2 t3.small 2대, ElastiCache, ALB를 합쳐 월 약 78달러 수준입니다. EKS로 갔다면 여기에 컨트롤 플레인 73달러가 추가됐을 겁니다.
+이번 프로젝트에서 배운 것은 — Stateless 설계와 외부 상태 저장소가 수평 확장의 열쇠라는 것, 관리형 서비스 통합이 운영 부담을 크게 줄여준다는 것, 최소 권한은 불편하지만 그 실패 메시지들이 곧 산 문서가 된다는 것, 그리고 안 쓸 때 끄는 습관이 클라우드 비용 관리의 시작이라는 점입니다.
+이상으로 발표를 마치겠습니다. 감사합니다. 질문 받겠습니다.</a:t>
             </a:r>
             <a:endParaRPr lang="en-US" dirty="0"/>
           </a:p>
@@ -1043,7 +1059,10 @@
           <a:p>
             <a:r>
               <a:rPr lang="en-US" dirty="0"/>
-              <a:t/>
+              <a:t>먼저 어떤 서비스인지 간단히 소개하겠습니다.
+4인용 텍사스 홀덤 웹 게임이고, 회원가입 없이 닉네임만 입력하면 바로 방을 만들고 친구들과 플레이할 수 있습니다.
+기술 스택은 백엔드 Node.js의 ws 라이브러리, 프론트엔드 React, 상태 저장소로 Redis를 사용했습니다.
+오늘 발표의 초점은 게임 로직보다는 오른쪽 화면의 이 게임을 "AWS 위에서 어떻게 운영하는가" — 즉 컨테이너 오케스트레이션, 상태 관리, 오토스케일링입니다.</a:t>
             </a:r>
             <a:endParaRPr lang="en-US" dirty="0"/>
           </a:p>
@@ -1131,7 +1150,12 @@
           <a:p>
             <a:r>
               <a:rPr lang="en-US" dirty="0"/>
-              <a:t/>
+              <a:t>게임 서버는 일반적인 웹 서버와 요구사항이 다릅니다.
+첫째, HTTP 요청-응답이 아니라 WebSocket으로 연결을 계속 유지해야 합니다. 상대가 베팅하면 내 화면이 즉시 갱신되어야 하니까요.
+둘째, 동시 접속이 늘어나면 서버를 수평으로 늘릴 수 있어야 하고,
+셋째, 서버 한 대가 죽어도 진행 중인 게임이 사라지면 안 됩니다.
+그래서 내린 핵심 설계 결정이 이것입니다: 서버는 완전한 Stateless로 만들고, 게임 상태는 전부 ElastiCache Redis에 둔다.
+이 결정 하나로 sticky session이 필요 없어지고, 어느 컨테이너가 어느 플레이어를 처리해도 상관없는 구조가 됩니다.</a:t>
             </a:r>
             <a:endParaRPr lang="en-US" dirty="0"/>
           </a:p>
@@ -1219,7 +1243,12 @@
           <a:p>
             <a:r>
               <a:rPr lang="en-US" dirty="0"/>
-              <a:t/>
+              <a:t>전체 아키텍처입니다. 왼쪽 플레이어부터 흐름을 따라가면 —
+브라우저는 먼저 S3 버킷에서 React 정적 파일을 로드합니다. 별도 웹서버 없이 S3 정적 호스팅만으로 충분합니다.
+게임 통신은 WebSocket으로 ALB를 거쳐 ECS 클러스터의 태스크로 연결됩니다. 가운데 보라색 영역이 ECS 클러스터인데, EC2 Auto Scaling Group 위에서 Node.js 컨테이너가 태스크로 돌고 있습니다.
+모든 태스크는 오른쪽의 ElastiCache Redis 하나를 바라봅니다. 게임 상태를 읽고 쓰고, Pub/Sub으로 이벤트를 주고받습니다.
+완료된 게임 기록은 S3 히스토리 버킷에 저장됩니다.
+하단의 보안 그룹 체인은 보안 슬라이드에서 다시 설명하겠습니다.</a:t>
             </a:r>
             <a:endParaRPr lang="en-US" dirty="0"/>
           </a:p>
@@ -1307,7 +1336,10 @@
           <a:p>
             <a:r>
               <a:rPr lang="en-US" dirty="0"/>
-              <a:t/>
+              <a:t>컨테이너 오케스트레이션 도구로 처음에는 쿠버네티스, EKS를 계획했습니다.
+그런데 EKS는 워커 노드와 별개로 컨트롤 플레인 비용만 월 73달러가 고정으로 나가고, 매니페스트·Helm 등 학습 곡선도 가파릅니다. 게임 서버 컨테이너 2~4개를 돌리는 프로젝트에는 과한 복잡도라고 판단했습니다.
+그래서 ECS로 전환했습니다. 클러스터 관리 비용이 없고, ALB·오토스케일링·CloudWatch와의 통합이 네이티브로 제공됩니다. Fargate가 아닌 EC2 타입을 선택해 비용을 더 줄이고 ASG를 직접 제어하는 경험도 얻었습니다.
+배운 점은 — 기술 선택은 유행이 아니라 규모에 맞는 복잡도로 해야 한다는 것입니다.</a:t>
             </a:r>
             <a:endParaRPr lang="en-US" dirty="0"/>
           </a:p>
@@ -1395,7 +1427,11 @@
           <a:p>
             <a:r>
               <a:rPr lang="en-US" dirty="0"/>
-              <a:t/>
+              <a:t>이 아키텍처의 심장은 상태 관리입니다.
+카드 덱, 팟, 현재 턴, 심지어 턴 타이머의 마감 시각까지 게임 상태 전부가 Redis에 있습니다. 서버 메모리에는 아무것도 없습니다.
+같은 게임의 플레이어 4명이 서로 다른 태스크에 연결될 수 있는데, 이때 Redis Pub/Sub으로 게임 이벤트를 모든 태스크에 전달해서 각자 자기 클라이언트에게 브로드캐스트합니다.
+동시성 문제는 Lua 스크립트로 해결했습니다. 상태 조회, 턴 검증, 업데이트를 Redis 안에서 원자적으로 실행해서 두 액션이 동시에 들어와도 안전합니다.
+이게 말로만이 아니라는 걸 증명하기 위해, 실제로 4개 클라이언트를 ALB로 분산 접속시켜 풀 게임을 완주시켰습니다.</a:t>
             </a:r>
             <a:endParaRPr lang="en-US" dirty="0"/>
           </a:p>
@@ -1483,7 +1519,11 @@
           <a:p>
             <a:r>
               <a:rPr lang="en-US" dirty="0"/>
-              <a:t/>
+              <a:t>배포 파이프라인입니다.
+node:20-alpine 기반 56메가바이트 이미지를 ECR에 푸시하고, Task Definition을 등록한 뒤 ECS 서비스가 롤링 배포합니다.
+awsvpc 네트워크 모드라서 태스크마다 자체 IP와 보안 그룹을 갖습니다.
+롤링 배포는 minimumHealthy 100%로 설정해서, 새 태스크가 헬스체크를 통과한 후에만 구버전을 내립니다. 실제로 발표 준비 중 버그 수정을 무중단으로 배포했습니다.
+재배포는 이미지 푸시 후 명령 한 줄이면 끝납니다.</a:t>
             </a:r>
             <a:endParaRPr lang="en-US" dirty="0"/>
           </a:p>
@@ -1571,7 +1611,10 @@
           <a:p>
             <a:r>
               <a:rPr lang="en-US" dirty="0"/>
-              <a:t/>
+              <a:t>ALB 설정에서 가장 중요한 건 idle timeout입니다.
+기본값 60초를 그대로 두면 플레이어가 1분만 가만히 있어도 WebSocket이 끊깁니다. 3600초로 늘리는 이 설정 한 줄이 WebSocket 서비스의 핵심입니다.
+타깃 타입은 ip로 설정해 awsvpc 태스크의 ENI로 직접 라우팅하고, 30초마다 /health 경로로 헬스체크를 합니다.
+NLB가 아닌 ALB를 쓴 이유는 — L7 헬스체크와 WebSocket 업그레이드 처리, 그리고 이 규모에서의 운영 단순함 때문입니다.</a:t>
             </a:r>
             <a:endParaRPr lang="en-US" dirty="0"/>
           </a:p>
@@ -1659,7 +1702,11 @@
           <a:p>
             <a:r>
               <a:rPr lang="en-US" dirty="0"/>
-              <a:t/>
+              <a:t>오토스케일링은 2단 구조입니다.
+1단은 서비스 레벨 — 태스크의 평균 CPU가 70%를 넘으면 ECS가 태스크 수를 2개에서 최대 8개까지 늘립니다.
+2단은 인프라 레벨 — 늘어난 태스크가 들어갈 EC2 자리가 부족하면, Capacity Provider가 ASG를 조정해 EC2 자체를 2대에서 4대까지 증설합니다.
+오른쪽 흐름처럼 트래픽 증가 → 태스크 증설 → 자리 부족 → EC2 증설이 전부 자동입니다.
+반대로 한가해지면 역순으로 줄어들고, 실습 중에는 비용 절약을 위해 desired를 0으로 내려두기도 했습니다.</a:t>
             </a:r>
             <a:endParaRPr lang="en-US" dirty="0"/>
           </a:p>
@@ -2034,7 +2081,7 @@
       </p:grpSpPr>
       <p:sp>
         <p:nvSpPr>
-          <p:cNvPr id="2" name="Text 0"/>
+          <p:cNvPr id="3" name="Text 0"/>
           <p:cNvSpPr/>
           <p:nvPr/>
         </p:nvSpPr>
@@ -2073,7 +2120,7 @@
       </p:sp>
       <p:sp>
         <p:nvSpPr>
-          <p:cNvPr id="3" name="Text 1"/>
+          <p:cNvPr id="4" name="Text 1"/>
           <p:cNvSpPr/>
           <p:nvPr/>
         </p:nvSpPr>
@@ -2112,7 +2159,7 @@
       </p:sp>
       <p:sp>
         <p:nvSpPr>
-          <p:cNvPr id="4" name="Text 2"/>
+          <p:cNvPr id="5" name="Text 2"/>
           <p:cNvSpPr/>
           <p:nvPr/>
         </p:nvSpPr>
@@ -2151,7 +2198,7 @@
       </p:sp>
       <p:sp>
         <p:nvSpPr>
-          <p:cNvPr id="5" name="Text 3"/>
+          <p:cNvPr id="6" name="Text 3"/>
           <p:cNvSpPr/>
           <p:nvPr/>
         </p:nvSpPr>
@@ -2222,7 +2269,7 @@
       </p:grpSpPr>
       <p:sp>
         <p:nvSpPr>
-          <p:cNvPr id="2" name="Text 0"/>
+          <p:cNvPr id="3" name="Text 0"/>
           <p:cNvSpPr/>
           <p:nvPr/>
         </p:nvSpPr>
@@ -2261,7 +2308,7 @@
       </p:sp>
       <p:sp>
         <p:nvSpPr>
-          <p:cNvPr id="3" name="Text 1"/>
+          <p:cNvPr id="4" name="Text 1"/>
           <p:cNvSpPr/>
           <p:nvPr/>
         </p:nvSpPr>
@@ -2300,7 +2347,7 @@
       </p:sp>
       <p:sp>
         <p:nvSpPr>
-          <p:cNvPr id="4" name="Shape 2"/>
+          <p:cNvPr id="5" name="Shape 2"/>
           <p:cNvSpPr/>
           <p:nvPr/>
         </p:nvSpPr>
@@ -2327,7 +2374,7 @@
       </p:sp>
       <p:sp>
         <p:nvSpPr>
-          <p:cNvPr id="5" name="Text 3"/>
+          <p:cNvPr id="6" name="Text 3"/>
           <p:cNvSpPr/>
           <p:nvPr/>
         </p:nvSpPr>
@@ -2436,7 +2483,7 @@
       </p:sp>
       <p:sp>
         <p:nvSpPr>
-          <p:cNvPr id="6" name="Text 4"/>
+          <p:cNvPr id="7" name="Text 4"/>
           <p:cNvSpPr/>
           <p:nvPr/>
         </p:nvSpPr>
@@ -2752,7 +2799,7 @@
       </p:grpSpPr>
       <p:sp>
         <p:nvSpPr>
-          <p:cNvPr id="2" name="Text 0"/>
+          <p:cNvPr id="3" name="Text 0"/>
           <p:cNvSpPr/>
           <p:nvPr/>
         </p:nvSpPr>
@@ -2791,7 +2838,7 @@
       </p:sp>
       <p:sp>
         <p:nvSpPr>
-          <p:cNvPr id="3" name="Text 1"/>
+          <p:cNvPr id="4" name="Text 1"/>
           <p:cNvSpPr/>
           <p:nvPr/>
         </p:nvSpPr>
@@ -2830,7 +2877,7 @@
       </p:sp>
       <p:sp>
         <p:nvSpPr>
-          <p:cNvPr id="4" name="Text 2"/>
+          <p:cNvPr id="5" name="Text 2"/>
           <p:cNvSpPr/>
           <p:nvPr/>
         </p:nvSpPr>
@@ -3080,7 +3127,7 @@
       </p:sp>
       <p:sp>
         <p:nvSpPr>
-          <p:cNvPr id="5" name="Shape 3"/>
+          <p:cNvPr id="6" name="Shape 3"/>
           <p:cNvSpPr/>
           <p:nvPr/>
         </p:nvSpPr>
@@ -3107,7 +3154,7 @@
       </p:sp>
       <p:sp>
         <p:nvSpPr>
-          <p:cNvPr id="6" name="Text 4"/>
+          <p:cNvPr id="7" name="Text 4"/>
           <p:cNvSpPr/>
           <p:nvPr/>
         </p:nvSpPr>
@@ -3146,7 +3193,7 @@
       </p:sp>
       <p:sp>
         <p:nvSpPr>
-          <p:cNvPr id="7" name="Text 5"/>
+          <p:cNvPr id="8" name="Text 5"/>
           <p:cNvSpPr/>
           <p:nvPr/>
         </p:nvSpPr>
@@ -3220,7 +3267,7 @@
       </p:grpSpPr>
       <p:sp>
         <p:nvSpPr>
-          <p:cNvPr id="2" name="Text 0"/>
+          <p:cNvPr id="3" name="Text 0"/>
           <p:cNvSpPr/>
           <p:nvPr/>
         </p:nvSpPr>
@@ -3259,7 +3306,7 @@
       </p:sp>
       <p:sp>
         <p:nvSpPr>
-          <p:cNvPr id="3" name="Text 1"/>
+          <p:cNvPr id="4" name="Text 1"/>
           <p:cNvSpPr/>
           <p:nvPr/>
         </p:nvSpPr>
@@ -3298,7 +3345,7 @@
       </p:sp>
       <p:pic>
         <p:nvPicPr>
-          <p:cNvPr id="4" name="Image 0" descr="/home/dakori/github/cloud_holdem/docs/presentation/assets/lobby.png">    </p:cNvPr>
+          <p:cNvPr id="5" name="Image 0" descr="/home/dakori/github/cloud_holdem/docs/presentation/assets/lobby.png">    </p:cNvPr>
           <p:cNvPicPr>
             <a:picLocks noChangeAspect="1"/>
           </p:cNvPicPr>
@@ -3322,7 +3369,7 @@
       </p:pic>
       <p:pic>
         <p:nvPicPr>
-          <p:cNvPr id="5" name="Image 1" descr="/home/dakori/github/cloud_holdem/docs/presentation/assets/game-table.png">    </p:cNvPr>
+          <p:cNvPr id="6" name="Image 1" descr="/home/dakori/github/cloud_holdem/docs/presentation/assets/game-table.png">    </p:cNvPr>
           <p:cNvPicPr>
             <a:picLocks noChangeAspect="1"/>
           </p:cNvPicPr>
@@ -3346,7 +3393,7 @@
       </p:pic>
       <p:sp>
         <p:nvSpPr>
-          <p:cNvPr id="6" name="Text 2"/>
+          <p:cNvPr id="7" name="Text 2"/>
           <p:cNvSpPr/>
           <p:nvPr/>
         </p:nvSpPr>
@@ -3417,7 +3464,7 @@
       </p:grpSpPr>
       <p:sp>
         <p:nvSpPr>
-          <p:cNvPr id="2" name="Text 0"/>
+          <p:cNvPr id="3" name="Text 0"/>
           <p:cNvSpPr/>
           <p:nvPr/>
         </p:nvSpPr>
@@ -3456,7 +3503,7 @@
       </p:sp>
       <p:sp>
         <p:nvSpPr>
-          <p:cNvPr id="3" name="Text 1"/>
+          <p:cNvPr id="4" name="Text 1"/>
           <p:cNvSpPr/>
           <p:nvPr/>
         </p:nvSpPr>
@@ -3495,7 +3542,7 @@
       </p:sp>
       <p:sp>
         <p:nvSpPr>
-          <p:cNvPr id="4" name="Shape 2"/>
+          <p:cNvPr id="5" name="Shape 2"/>
           <p:cNvSpPr/>
           <p:nvPr/>
         </p:nvSpPr>
@@ -3515,7 +3562,7 @@
       </p:sp>
       <p:sp>
         <p:nvSpPr>
-          <p:cNvPr id="5" name="Text 3"/>
+          <p:cNvPr id="6" name="Text 3"/>
           <p:cNvSpPr/>
           <p:nvPr/>
         </p:nvSpPr>
@@ -3551,7 +3598,7 @@
       </p:sp>
       <p:sp>
         <p:nvSpPr>
-          <p:cNvPr id="6" name="Text 4"/>
+          <p:cNvPr id="7" name="Text 4"/>
           <p:cNvSpPr/>
           <p:nvPr/>
         </p:nvSpPr>
@@ -3590,7 +3637,7 @@
       </p:sp>
       <p:sp>
         <p:nvSpPr>
-          <p:cNvPr id="7" name="Shape 5"/>
+          <p:cNvPr id="8" name="Shape 5"/>
           <p:cNvSpPr/>
           <p:nvPr/>
         </p:nvSpPr>
@@ -3610,7 +3657,7 @@
       </p:sp>
       <p:sp>
         <p:nvSpPr>
-          <p:cNvPr id="8" name="Text 6"/>
+          <p:cNvPr id="9" name="Text 6"/>
           <p:cNvSpPr/>
           <p:nvPr/>
         </p:nvSpPr>
@@ -3646,7 +3693,7 @@
       </p:sp>
       <p:sp>
         <p:nvSpPr>
-          <p:cNvPr id="9" name="Text 7"/>
+          <p:cNvPr id="10" name="Text 7"/>
           <p:cNvSpPr/>
           <p:nvPr/>
         </p:nvSpPr>
@@ -3685,7 +3732,7 @@
       </p:sp>
       <p:sp>
         <p:nvSpPr>
-          <p:cNvPr id="10" name="Shape 8"/>
+          <p:cNvPr id="11" name="Shape 8"/>
           <p:cNvSpPr/>
           <p:nvPr/>
         </p:nvSpPr>
@@ -3705,7 +3752,7 @@
       </p:sp>
       <p:sp>
         <p:nvSpPr>
-          <p:cNvPr id="11" name="Text 9"/>
+          <p:cNvPr id="12" name="Text 9"/>
           <p:cNvSpPr/>
           <p:nvPr/>
         </p:nvSpPr>
@@ -3741,7 +3788,7 @@
       </p:sp>
       <p:sp>
         <p:nvSpPr>
-          <p:cNvPr id="12" name="Text 10"/>
+          <p:cNvPr id="13" name="Text 10"/>
           <p:cNvSpPr/>
           <p:nvPr/>
         </p:nvSpPr>
@@ -3780,7 +3827,7 @@
       </p:sp>
       <p:sp>
         <p:nvSpPr>
-          <p:cNvPr id="13" name="Shape 11"/>
+          <p:cNvPr id="14" name="Shape 11"/>
           <p:cNvSpPr/>
           <p:nvPr/>
         </p:nvSpPr>
@@ -3800,7 +3847,7 @@
       </p:sp>
       <p:sp>
         <p:nvSpPr>
-          <p:cNvPr id="14" name="Text 12"/>
+          <p:cNvPr id="15" name="Text 12"/>
           <p:cNvSpPr/>
           <p:nvPr/>
         </p:nvSpPr>
@@ -3836,7 +3883,7 @@
       </p:sp>
       <p:sp>
         <p:nvSpPr>
-          <p:cNvPr id="15" name="Text 13"/>
+          <p:cNvPr id="16" name="Text 13"/>
           <p:cNvSpPr/>
           <p:nvPr/>
         </p:nvSpPr>
@@ -3875,7 +3922,7 @@
       </p:sp>
       <p:sp>
         <p:nvSpPr>
-          <p:cNvPr id="16" name="Shape 14"/>
+          <p:cNvPr id="17" name="Shape 14"/>
           <p:cNvSpPr/>
           <p:nvPr/>
         </p:nvSpPr>
@@ -3895,7 +3942,7 @@
       </p:sp>
       <p:sp>
         <p:nvSpPr>
-          <p:cNvPr id="17" name="Text 15"/>
+          <p:cNvPr id="18" name="Text 15"/>
           <p:cNvSpPr/>
           <p:nvPr/>
         </p:nvSpPr>
@@ -3931,7 +3978,7 @@
       </p:sp>
       <p:sp>
         <p:nvSpPr>
-          <p:cNvPr id="18" name="Text 16"/>
+          <p:cNvPr id="19" name="Text 16"/>
           <p:cNvSpPr/>
           <p:nvPr/>
         </p:nvSpPr>
@@ -3970,7 +4017,7 @@
       </p:sp>
       <p:sp>
         <p:nvSpPr>
-          <p:cNvPr id="19" name="Shape 17"/>
+          <p:cNvPr id="20" name="Shape 17"/>
           <p:cNvSpPr/>
           <p:nvPr/>
         </p:nvSpPr>
@@ -3990,7 +4037,7 @@
       </p:sp>
       <p:sp>
         <p:nvSpPr>
-          <p:cNvPr id="20" name="Text 18"/>
+          <p:cNvPr id="21" name="Text 18"/>
           <p:cNvSpPr/>
           <p:nvPr/>
         </p:nvSpPr>
@@ -4026,7 +4073,7 @@
       </p:sp>
       <p:sp>
         <p:nvSpPr>
-          <p:cNvPr id="21" name="Text 19"/>
+          <p:cNvPr id="22" name="Text 19"/>
           <p:cNvSpPr/>
           <p:nvPr/>
         </p:nvSpPr>
@@ -4065,7 +4112,7 @@
       </p:sp>
       <p:sp>
         <p:nvSpPr>
-          <p:cNvPr id="22" name="Shape 20"/>
+          <p:cNvPr id="23" name="Shape 20"/>
           <p:cNvSpPr/>
           <p:nvPr/>
         </p:nvSpPr>
@@ -4092,7 +4139,7 @@
       </p:sp>
       <p:sp>
         <p:nvSpPr>
-          <p:cNvPr id="23" name="Text 21"/>
+          <p:cNvPr id="24" name="Text 21"/>
           <p:cNvSpPr/>
           <p:nvPr/>
         </p:nvSpPr>
@@ -4131,7 +4178,7 @@
       </p:sp>
       <p:sp>
         <p:nvSpPr>
-          <p:cNvPr id="24" name="Text 22"/>
+          <p:cNvPr id="25" name="Text 22"/>
           <p:cNvSpPr/>
           <p:nvPr/>
         </p:nvSpPr>
@@ -4323,7 +4370,7 @@
       </p:grpSpPr>
       <p:sp>
         <p:nvSpPr>
-          <p:cNvPr id="2" name="Text 0"/>
+          <p:cNvPr id="3" name="Text 0"/>
           <p:cNvSpPr/>
           <p:nvPr/>
         </p:nvSpPr>
@@ -4362,7 +4409,7 @@
       </p:sp>
       <p:sp>
         <p:nvSpPr>
-          <p:cNvPr id="3" name="Text 1"/>
+          <p:cNvPr id="4" name="Text 1"/>
           <p:cNvSpPr/>
           <p:nvPr/>
         </p:nvSpPr>
@@ -5657,7 +5704,7 @@
       </p:graphicFrame>
       <p:sp>
         <p:nvSpPr>
-          <p:cNvPr id="5" name="Text 2"/>
+          <p:cNvPr id="6" name="Text 2"/>
           <p:cNvSpPr/>
           <p:nvPr/>
         </p:nvSpPr>
@@ -5890,7 +5937,7 @@
       </p:sp>
       <p:sp>
         <p:nvSpPr>
-          <p:cNvPr id="6" name="Text 3"/>
+          <p:cNvPr id="7" name="Text 3"/>
           <p:cNvSpPr/>
           <p:nvPr/>
         </p:nvSpPr>
@@ -5961,7 +6008,7 @@
       </p:grpSpPr>
       <p:sp>
         <p:nvSpPr>
-          <p:cNvPr id="2" name="Text 0"/>
+          <p:cNvPr id="3" name="Text 0"/>
           <p:cNvSpPr/>
           <p:nvPr/>
         </p:nvSpPr>
@@ -6000,7 +6047,7 @@
       </p:sp>
       <p:sp>
         <p:nvSpPr>
-          <p:cNvPr id="3" name="Text 1"/>
+          <p:cNvPr id="4" name="Text 1"/>
           <p:cNvSpPr/>
           <p:nvPr/>
         </p:nvSpPr>
@@ -6039,7 +6086,7 @@
       </p:sp>
       <p:sp>
         <p:nvSpPr>
-          <p:cNvPr id="4" name="Text 2"/>
+          <p:cNvPr id="5" name="Text 2"/>
           <p:cNvSpPr/>
           <p:nvPr/>
         </p:nvSpPr>
@@ -6306,7 +6353,7 @@
       </p:sp>
       <p:sp>
         <p:nvSpPr>
-          <p:cNvPr id="5" name="Shape 3"/>
+          <p:cNvPr id="6" name="Shape 3"/>
           <p:cNvSpPr/>
           <p:nvPr/>
         </p:nvSpPr>
@@ -6333,7 +6380,7 @@
       </p:sp>
       <p:sp>
         <p:nvSpPr>
-          <p:cNvPr id="6" name="Text 4"/>
+          <p:cNvPr id="7" name="Text 4"/>
           <p:cNvSpPr/>
           <p:nvPr/>
         </p:nvSpPr>
@@ -6372,7 +6419,7 @@
       </p:sp>
       <p:sp>
         <p:nvSpPr>
-          <p:cNvPr id="7" name="Text 5"/>
+          <p:cNvPr id="8" name="Text 5"/>
           <p:cNvSpPr/>
           <p:nvPr/>
         </p:nvSpPr>
@@ -6414,7 +6461,7 @@
       </p:sp>
       <p:pic>
         <p:nvPicPr>
-          <p:cNvPr id="8" name="Image 0" descr="/home/dakori/github/cloud_holdem/docs/presentation/assets/lobby.png">    </p:cNvPr>
+          <p:cNvPr id="9" name="Image 0" descr="/home/dakori/github/cloud_holdem/docs/presentation/assets/lobby.png">    </p:cNvPr>
           <p:cNvPicPr>
             <a:picLocks noChangeAspect="1"/>
           </p:cNvPicPr>
@@ -6470,7 +6517,7 @@
       </p:grpSpPr>
       <p:sp>
         <p:nvSpPr>
-          <p:cNvPr id="2" name="Text 0"/>
+          <p:cNvPr id="3" name="Text 0"/>
           <p:cNvSpPr/>
           <p:nvPr/>
         </p:nvSpPr>
@@ -6509,7 +6556,7 @@
       </p:sp>
       <p:sp>
         <p:nvSpPr>
-          <p:cNvPr id="3" name="Text 1"/>
+          <p:cNvPr id="4" name="Text 1"/>
           <p:cNvSpPr/>
           <p:nvPr/>
         </p:nvSpPr>
@@ -6548,7 +6595,7 @@
       </p:sp>
       <p:sp>
         <p:nvSpPr>
-          <p:cNvPr id="4" name="Text 2"/>
+          <p:cNvPr id="5" name="Text 2"/>
           <p:cNvSpPr/>
           <p:nvPr/>
         </p:nvSpPr>
@@ -6849,7 +6896,7 @@
       </p:sp>
       <p:sp>
         <p:nvSpPr>
-          <p:cNvPr id="5" name="Shape 3"/>
+          <p:cNvPr id="6" name="Shape 3"/>
           <p:cNvSpPr/>
           <p:nvPr/>
         </p:nvSpPr>
@@ -6876,7 +6923,7 @@
       </p:sp>
       <p:sp>
         <p:nvSpPr>
-          <p:cNvPr id="6" name="Text 4"/>
+          <p:cNvPr id="7" name="Text 4"/>
           <p:cNvSpPr/>
           <p:nvPr/>
         </p:nvSpPr>
@@ -6915,7 +6962,7 @@
       </p:sp>
       <p:sp>
         <p:nvSpPr>
-          <p:cNvPr id="7" name="Text 5"/>
+          <p:cNvPr id="8" name="Text 5"/>
           <p:cNvSpPr/>
           <p:nvPr/>
         </p:nvSpPr>
@@ -7009,7 +7056,7 @@
       </p:grpSpPr>
       <p:sp>
         <p:nvSpPr>
-          <p:cNvPr id="2" name="Text 0"/>
+          <p:cNvPr id="3" name="Text 0"/>
           <p:cNvSpPr/>
           <p:nvPr/>
         </p:nvSpPr>
@@ -7048,7 +7095,7 @@
       </p:sp>
       <p:sp>
         <p:nvSpPr>
-          <p:cNvPr id="3" name="Text 1"/>
+          <p:cNvPr id="4" name="Text 1"/>
           <p:cNvSpPr/>
           <p:nvPr/>
         </p:nvSpPr>
@@ -7087,7 +7134,7 @@
       </p:sp>
       <p:pic>
         <p:nvPicPr>
-          <p:cNvPr id="4" name="Image 0" descr="/home/dakori/github/cloud_holdem/docs/presentation/assets/architecture.png">    </p:cNvPr>
+          <p:cNvPr id="5" name="Image 0" descr="/home/dakori/github/cloud_holdem/docs/presentation/assets/architecture.png">    </p:cNvPr>
           <p:cNvPicPr>
             <a:picLocks noChangeAspect="1"/>
           </p:cNvPicPr>
@@ -7143,7 +7190,7 @@
       </p:grpSpPr>
       <p:sp>
         <p:nvSpPr>
-          <p:cNvPr id="2" name="Text 0"/>
+          <p:cNvPr id="3" name="Text 0"/>
           <p:cNvSpPr/>
           <p:nvPr/>
         </p:nvSpPr>
@@ -7182,7 +7229,7 @@
       </p:sp>
       <p:sp>
         <p:nvSpPr>
-          <p:cNvPr id="3" name="Text 1"/>
+          <p:cNvPr id="4" name="Text 1"/>
           <p:cNvSpPr/>
           <p:nvPr/>
         </p:nvSpPr>
@@ -7221,7 +7268,7 @@
       </p:sp>
       <p:sp>
         <p:nvSpPr>
-          <p:cNvPr id="4" name="Shape 2"/>
+          <p:cNvPr id="5" name="Shape 2"/>
           <p:cNvSpPr/>
           <p:nvPr/>
         </p:nvSpPr>
@@ -7248,7 +7295,7 @@
       </p:sp>
       <p:sp>
         <p:nvSpPr>
-          <p:cNvPr id="5" name="Text 3"/>
+          <p:cNvPr id="6" name="Text 3"/>
           <p:cNvSpPr/>
           <p:nvPr/>
         </p:nvSpPr>
@@ -7287,7 +7334,7 @@
       </p:sp>
       <p:sp>
         <p:nvSpPr>
-          <p:cNvPr id="6" name="Text 4"/>
+          <p:cNvPr id="7" name="Text 4"/>
           <p:cNvSpPr/>
           <p:nvPr/>
         </p:nvSpPr>
@@ -7369,7 +7416,7 @@
       </p:sp>
       <p:sp>
         <p:nvSpPr>
-          <p:cNvPr id="7" name="Shape 5"/>
+          <p:cNvPr id="8" name="Shape 5"/>
           <p:cNvSpPr/>
           <p:nvPr/>
         </p:nvSpPr>
@@ -7396,7 +7443,7 @@
       </p:sp>
       <p:sp>
         <p:nvSpPr>
-          <p:cNvPr id="8" name="Text 6"/>
+          <p:cNvPr id="9" name="Text 6"/>
           <p:cNvSpPr/>
           <p:nvPr/>
         </p:nvSpPr>
@@ -7435,7 +7482,7 @@
       </p:sp>
       <p:sp>
         <p:nvSpPr>
-          <p:cNvPr id="9" name="Text 7"/>
+          <p:cNvPr id="10" name="Text 7"/>
           <p:cNvSpPr/>
           <p:nvPr/>
         </p:nvSpPr>
@@ -7537,7 +7584,7 @@
       </p:sp>
       <p:sp>
         <p:nvSpPr>
-          <p:cNvPr id="10" name="Text 8"/>
+          <p:cNvPr id="11" name="Text 8"/>
           <p:cNvSpPr/>
           <p:nvPr/>
         </p:nvSpPr>
@@ -7608,7 +7655,7 @@
       </p:grpSpPr>
       <p:sp>
         <p:nvSpPr>
-          <p:cNvPr id="2" name="Text 0"/>
+          <p:cNvPr id="3" name="Text 0"/>
           <p:cNvSpPr/>
           <p:nvPr/>
         </p:nvSpPr>
@@ -7647,7 +7694,7 @@
       </p:sp>
       <p:sp>
         <p:nvSpPr>
-          <p:cNvPr id="3" name="Text 1"/>
+          <p:cNvPr id="4" name="Text 1"/>
           <p:cNvSpPr/>
           <p:nvPr/>
         </p:nvSpPr>
@@ -7686,7 +7733,7 @@
       </p:sp>
       <p:sp>
         <p:nvSpPr>
-          <p:cNvPr id="4" name="Text 2"/>
+          <p:cNvPr id="5" name="Text 2"/>
           <p:cNvSpPr/>
           <p:nvPr/>
         </p:nvSpPr>
@@ -7970,7 +8017,7 @@
       </p:sp>
       <p:sp>
         <p:nvSpPr>
-          <p:cNvPr id="5" name="Shape 3"/>
+          <p:cNvPr id="6" name="Shape 3"/>
           <p:cNvSpPr/>
           <p:nvPr/>
         </p:nvSpPr>
@@ -7997,7 +8044,7 @@
       </p:sp>
       <p:sp>
         <p:nvSpPr>
-          <p:cNvPr id="6" name="Text 4"/>
+          <p:cNvPr id="7" name="Text 4"/>
           <p:cNvSpPr/>
           <p:nvPr/>
         </p:nvSpPr>
@@ -8036,7 +8083,7 @@
       </p:sp>
       <p:sp>
         <p:nvSpPr>
-          <p:cNvPr id="7" name="Text 5"/>
+          <p:cNvPr id="8" name="Text 5"/>
           <p:cNvSpPr/>
           <p:nvPr/>
         </p:nvSpPr>
@@ -8159,7 +8206,7 @@
       </p:grpSpPr>
       <p:sp>
         <p:nvSpPr>
-          <p:cNvPr id="2" name="Text 0"/>
+          <p:cNvPr id="3" name="Text 0"/>
           <p:cNvSpPr/>
           <p:nvPr/>
         </p:nvSpPr>
@@ -8198,7 +8245,7 @@
       </p:sp>
       <p:sp>
         <p:nvSpPr>
-          <p:cNvPr id="3" name="Text 1"/>
+          <p:cNvPr id="4" name="Text 1"/>
           <p:cNvSpPr/>
           <p:nvPr/>
         </p:nvSpPr>
@@ -8237,7 +8284,7 @@
       </p:sp>
       <p:sp>
         <p:nvSpPr>
-          <p:cNvPr id="4" name="Shape 2"/>
+          <p:cNvPr id="5" name="Shape 2"/>
           <p:cNvSpPr/>
           <p:nvPr/>
         </p:nvSpPr>
@@ -8264,7 +8311,7 @@
       </p:sp>
       <p:sp>
         <p:nvSpPr>
-          <p:cNvPr id="5" name="Text 3"/>
+          <p:cNvPr id="6" name="Text 3"/>
           <p:cNvSpPr/>
           <p:nvPr/>
         </p:nvSpPr>
@@ -8401,7 +8448,7 @@
       </p:sp>
       <p:sp>
         <p:nvSpPr>
-          <p:cNvPr id="6" name="Text 4"/>
+          <p:cNvPr id="7" name="Text 4"/>
           <p:cNvSpPr/>
           <p:nvPr/>
         </p:nvSpPr>
@@ -8700,7 +8747,7 @@
       </p:grpSpPr>
       <p:sp>
         <p:nvSpPr>
-          <p:cNvPr id="2" name="Text 0"/>
+          <p:cNvPr id="3" name="Text 0"/>
           <p:cNvSpPr/>
           <p:nvPr/>
         </p:nvSpPr>
@@ -8739,7 +8786,7 @@
       </p:sp>
       <p:sp>
         <p:nvSpPr>
-          <p:cNvPr id="3" name="Text 1"/>
+          <p:cNvPr id="4" name="Text 1"/>
           <p:cNvSpPr/>
           <p:nvPr/>
         </p:nvSpPr>
@@ -8778,7 +8825,7 @@
       </p:sp>
       <p:sp>
         <p:nvSpPr>
-          <p:cNvPr id="4" name="Text 2"/>
+          <p:cNvPr id="5" name="Text 2"/>
           <p:cNvSpPr/>
           <p:nvPr/>
         </p:nvSpPr>
@@ -9062,7 +9109,7 @@
       </p:sp>
       <p:sp>
         <p:nvSpPr>
-          <p:cNvPr id="5" name="Shape 3"/>
+          <p:cNvPr id="6" name="Shape 3"/>
           <p:cNvSpPr/>
           <p:nvPr/>
         </p:nvSpPr>
@@ -9089,7 +9136,7 @@
       </p:sp>
       <p:sp>
         <p:nvSpPr>
-          <p:cNvPr id="6" name="Text 4"/>
+          <p:cNvPr id="7" name="Text 4"/>
           <p:cNvSpPr/>
           <p:nvPr/>
         </p:nvSpPr>
@@ -9128,7 +9175,7 @@
       </p:sp>
       <p:sp>
         <p:nvSpPr>
-          <p:cNvPr id="7" name="Text 5"/>
+          <p:cNvPr id="8" name="Text 5"/>
           <p:cNvSpPr/>
           <p:nvPr/>
         </p:nvSpPr>
@@ -9202,7 +9249,7 @@
       </p:grpSpPr>
       <p:sp>
         <p:nvSpPr>
-          <p:cNvPr id="2" name="Text 0"/>
+          <p:cNvPr id="3" name="Text 0"/>
           <p:cNvSpPr/>
           <p:nvPr/>
         </p:nvSpPr>
@@ -9241,7 +9288,7 @@
       </p:sp>
       <p:sp>
         <p:nvSpPr>
-          <p:cNvPr id="3" name="Text 1"/>
+          <p:cNvPr id="4" name="Text 1"/>
           <p:cNvSpPr/>
           <p:nvPr/>
         </p:nvSpPr>
@@ -9280,7 +9327,7 @@
       </p:sp>
       <p:sp>
         <p:nvSpPr>
-          <p:cNvPr id="4" name="Shape 2"/>
+          <p:cNvPr id="5" name="Shape 2"/>
           <p:cNvSpPr/>
           <p:nvPr/>
         </p:nvSpPr>
@@ -9307,7 +9354,7 @@
       </p:sp>
       <p:sp>
         <p:nvSpPr>
-          <p:cNvPr id="5" name="Text 3"/>
+          <p:cNvPr id="6" name="Text 3"/>
           <p:cNvSpPr/>
           <p:nvPr/>
         </p:nvSpPr>
@@ -9346,7 +9393,7 @@
       </p:sp>
       <p:sp>
         <p:nvSpPr>
-          <p:cNvPr id="6" name="Text 4"/>
+          <p:cNvPr id="7" name="Text 4"/>
           <p:cNvSpPr/>
           <p:nvPr/>
         </p:nvSpPr>
@@ -9428,7 +9475,7 @@
       </p:sp>
       <p:sp>
         <p:nvSpPr>
-          <p:cNvPr id="7" name="Shape 5"/>
+          <p:cNvPr id="8" name="Shape 5"/>
           <p:cNvSpPr/>
           <p:nvPr/>
         </p:nvSpPr>
@@ -9455,7 +9502,7 @@
       </p:sp>
       <p:sp>
         <p:nvSpPr>
-          <p:cNvPr id="8" name="Text 6"/>
+          <p:cNvPr id="9" name="Text 6"/>
           <p:cNvSpPr/>
           <p:nvPr/>
         </p:nvSpPr>
@@ -9494,7 +9541,7 @@
       </p:sp>
       <p:sp>
         <p:nvSpPr>
-          <p:cNvPr id="9" name="Text 7"/>
+          <p:cNvPr id="10" name="Text 7"/>
           <p:cNvSpPr/>
           <p:nvPr/>
         </p:nvSpPr>
@@ -9576,7 +9623,7 @@
       </p:sp>
       <p:sp>
         <p:nvSpPr>
-          <p:cNvPr id="10" name="Shape 8"/>
+          <p:cNvPr id="11" name="Shape 8"/>
           <p:cNvSpPr/>
           <p:nvPr/>
         </p:nvSpPr>
@@ -9603,7 +9650,7 @@
       </p:sp>
       <p:sp>
         <p:nvSpPr>
-          <p:cNvPr id="11" name="Text 9"/>
+          <p:cNvPr id="12" name="Text 9"/>
           <p:cNvSpPr/>
           <p:nvPr/>
         </p:nvSpPr>
@@ -9642,7 +9689,7 @@
       </p:sp>
       <p:sp>
         <p:nvSpPr>
-          <p:cNvPr id="12" name="Text 10"/>
+          <p:cNvPr id="13" name="Text 10"/>
           <p:cNvSpPr/>
           <p:nvPr/>
         </p:nvSpPr>

</xml_diff>

<commit_message>
docs: add S3 storage slide to presentation (15 slides)
Co-Authored-By: Claude Fable 5 <noreply@anthropic.com>
</commit_message>
<xml_diff>
--- a/docs/presentation/cloud-holdem-발표.pptx
+++ b/docs/presentation/cloud-holdem-발표.pptx
@@ -19,9 +19,10 @@
     <p:sldId id="267" r:id="rId13"/>
     <p:sldId id="268" r:id="rId14"/>
     <p:sldId id="269" r:id="rId15"/>
+    <p:sldId id="270" r:id="rId16"/>
   </p:sldIdLst>
   <p:notesMasterIdLst>
-    <p:notesMasterId r:id="rId16"/>
+    <p:notesMasterId r:id="rId17"/>
   </p:notesMasterIdLst>
   <p:sldSz cx="12188952" cy="6858000"/>
   <p:notesSz cx="6858000" cy="12188952"/>
@@ -604,10 +605,11 @@
           <a:p>
             <a:r>
               <a:rPr lang="en-US" dirty="0"/>
-              <a:t>보안은 최소 권한 원칙으로 설계했습니다.
-보안 그룹을 IP가 아닌 "보안 그룹 참조"로 체인을 만들었습니다. ALB는 인터넷에서 80만, EC2는 ALB에서 오는 3001만, Redis는 EC2에서 오는 6379만 받습니다. 즉 Redis는 인터넷에서 아예 도달이 불가능합니다.
-IAM은 역할을 3종으로 분리했습니다. 컨테이너가 쓰는 Task Role은 S3 쓰기만, Execution Role은 ECR pull과 로그만, Instance Role은 ECS 등록만 가능합니다.
-작업용 IAM 사용자 권한도 필요한 액션만 점진적으로 추가했는데, 예를 들어 ALB 생성이 ec2:DescribeAccountAttributes라는 숨은 권한을 요구해서 실패 메시지를 분석해 추가한 경험도 있었습니다.</a:t>
+              <a:t>오토스케일링은 2단 구조입니다.
+1단은 서비스 레벨 — 태스크의 평균 CPU가 70%를 넘으면 ECS가 태스크 수를 2개에서 최대 8개까지 늘립니다.
+2단은 인프라 레벨 — 늘어난 태스크가 들어갈 EC2 자리가 부족하면, Capacity Provider가 ASG를 조정해 EC2 자체를 2대에서 4대까지 증설합니다.
+오른쪽 흐름처럼 트래픽 증가 → 태스크 증설 → 자리 부족 → EC2 증설이 전부 자동입니다.
+반대로 한가해지면 역순으로 줄어들고, 실습 중에는 비용 절약을 위해 desired를 0으로 내려두기도 했습니다.</a:t>
             </a:r>
             <a:endParaRPr lang="en-US" dirty="0"/>
           </a:p>
@@ -695,10 +697,10 @@
           <a:p>
             <a:r>
               <a:rPr lang="en-US" dirty="0"/>
-              <a:t>"되는 것 같다"가 아니라 증명을 목표로 검증했습니다.
-게임 엔진과 Redis 로직에 단위·통합 테스트 44개를 TDD로 작성했고, Playwright로 실제 브라우저 4개를 자동 조작해 로컬 풀 게임을 완주시켰습니다.
-가장 의미 있는 건 프로덕션 E2E입니다 — ALB를 거쳐 4개 클라이언트가 서로 다른 태스크에 분산된 상태로 쇼다운까지 완주해서, 분산 환경 설계가 실제로 동작함을 확인했습니다.
-TDD 과정에서 베팅 라운드가 끝나지 않는 버그, 턴 타이머가 영원히 발동하지 않는 버그 같은 치명적 결함들을 배포 전에 잡았습니다.</a:t>
+              <a:t>보안은 최소 권한 원칙으로 설계했습니다.
+보안 그룹을 IP가 아닌 "보안 그룹 참조"로 체인을 만들었습니다. ALB는 인터넷에서 80만, EC2는 ALB에서 오는 3001만, Redis는 EC2에서 오는 6379만 받습니다. 즉 Redis는 인터넷에서 아예 도달이 불가능합니다.
+IAM은 역할을 3종으로 분리했습니다. 컨테이너가 쓰는 Task Role은 S3 쓰기만, Execution Role은 ECR pull과 로그만, Instance Role은 ECS 등록만 가능합니다.
+작업용 IAM 사용자 권한도 필요한 액션만 점진적으로 추가했는데, 예를 들어 ALB 생성이 ec2:DescribeAccountAttributes라는 숨은 권한을 요구해서 실패 메시지를 분석해 추가한 경험도 있었습니다.</a:t>
             </a:r>
             <a:endParaRPr lang="en-US" dirty="0"/>
           </a:p>
@@ -786,10 +788,10 @@
           <a:p>
             <a:r>
               <a:rPr lang="en-US" dirty="0"/>
-              <a:t>실제 게임 화면입니다.
-왼쪽이 로비 — 닉네임 입력 후 방을 만들거나 열린 방에 입장합니다. 4명이 모이면 5초 카운트다운 후 자동 시작됩니다.
-오른쪽이 게임 테이블 — 내 카드만 보이고 상대 카드는 가려집니다. 블라인드가 자동 차감되고, 자기 턴에만 액션 버튼과 20초 타이머가 표시됩니다.
-쇼다운이 끝나면 칩이 정산되고 다음 핸드가 자동으로 시작됩니다.</a:t>
+              <a:t>"되는 것 같다"가 아니라 증명을 목표로 검증했습니다.
+게임 엔진과 Redis 로직에 단위·통합 테스트 44개를 TDD로 작성했고, Playwright로 실제 브라우저 4개를 자동 조작해 로컬 풀 게임을 완주시켰습니다.
+가장 의미 있는 건 프로덕션 E2E입니다 — ALB를 거쳐 4개 클라이언트가 서로 다른 태스크에 분산된 상태로 쇼다운까지 완주해서, 분산 환경 설계가 실제로 동작함을 확인했습니다.
+TDD 과정에서 베팅 라운드가 끝나지 않는 버그, 턴 타이머가 영원히 발동하지 않는 버그 같은 치명적 결함들을 배포 전에 잡았습니다.</a:t>
             </a:r>
             <a:endParaRPr lang="en-US" dirty="0"/>
           </a:p>
@@ -877,10 +879,10 @@
           <a:p>
             <a:r>
               <a:rPr lang="en-US" dirty="0"/>
-              <a:t>이제 라이브로 보여드리겠습니다. (미리 띄워둔 탭 4개로 전환)
-순서: ① 탭 4개 접속 ② 첫 탭에서 방 만들기 ③ 나머지 입장, 카운트다운 확인 ④ 콜/체크로 빠르게 한 바퀴 돌려 플랍 공개 ⑤ 시간 여유가 있으면 탭 하나를 방치해 20초 auto-fold 시연 ⑥ 쇼다운과 칩 정산.
-* 만약 네트워크 문제가 생기면 당황하지 말고 "준비된 화면으로 대체하겠습니다" 하고 앞의 스크린샷 슬라이드로 돌아갈 것.
-* 발표 전 체크: ASG 2대 켜두기, 헬스체크 green, S3 배포 확인.</a:t>
+              <a:t>실제 게임 화면입니다.
+왼쪽이 로비 — 닉네임 입력 후 방을 만들거나 열린 방에 입장합니다. 4명이 모이면 5초 카운트다운 후 자동 시작됩니다.
+오른쪽이 게임 테이블 — 내 카드만 보이고 상대 카드는 가려집니다. 블라인드가 자동 차감되고, 자기 턴에만 액션 버튼과 20초 타이머가 표시됩니다.
+쇼다운이 끝나면 칩이 정산되고 다음 핸드가 자동으로 시작됩니다.</a:t>
             </a:r>
             <a:endParaRPr lang="en-US" dirty="0"/>
           </a:p>
@@ -968,10 +970,10 @@
           <a:p>
             <a:r>
               <a:rPr lang="en-US" dirty="0"/>
-              <a:t>마지막으로 비용입니다.
-EC2 t3.small 2대, ElastiCache, ALB를 합쳐 월 약 78달러 수준입니다. EKS로 갔다면 여기에 컨트롤 플레인 73달러가 추가됐을 겁니다.
-이번 프로젝트에서 배운 것은 — Stateless 설계와 외부 상태 저장소가 수평 확장의 열쇠라는 것, 관리형 서비스 통합이 운영 부담을 크게 줄여준다는 것, 최소 권한은 불편하지만 그 실패 메시지들이 곧 산 문서가 된다는 것, 그리고 안 쓸 때 끄는 습관이 클라우드 비용 관리의 시작이라는 점입니다.
-이상으로 발표를 마치겠습니다. 감사합니다. 질문 받겠습니다.</a:t>
+              <a:t>이제 라이브로 보여드리겠습니다. (미리 띄워둔 탭 4개로 전환)
+순서: ① 탭 4개 접속 ② 첫 탭에서 방 만들기 ③ 나머지 입장, 카운트다운 확인 ④ 콜/체크로 빠르게 한 바퀴 돌려 플랍 공개 ⑤ 시간 여유가 있으면 탭 하나를 방치해 20초 auto-fold 시연 ⑥ 쇼다운과 칩 정산.
+* 만약 네트워크 문제가 생기면 당황하지 말고 "준비된 화면으로 대체하겠습니다" 하고 앞의 스크린샷 슬라이드로 돌아갈 것.
+* 발표 전 체크: ASG 2대 켜두기, 헬스체크 green, S3 배포 확인.</a:t>
             </a:r>
             <a:endParaRPr lang="en-US" dirty="0"/>
           </a:p>
@@ -995,6 +997,97 @@
             <a:fld id="{F7021451-1387-4CA6-816F-3879F97B5CBC}" type="slidenum">
               <a:rPr lang="en-US"/>
               <a:t>14</a:t>
+            </a:fld>
+            <a:endParaRPr lang="en-US"/>
+          </a:p>
+        </p:txBody>
+      </p:sp>
+    </p:spTree>
+    <p:extLst>
+      <p:ext uri="{BB962C8B-B14F-4D97-AF65-F5344CB8AC3E}">
+        <p14:creationId xmlns:p14="http://schemas.microsoft.com/office/powerpoint/2010/main" val="1024086991"/>
+      </p:ext>
+    </p:extLst>
+  </p:cSld>
+  <p:clrMapOvr>
+    <a:masterClrMapping/>
+  </p:clrMapOvr>
+</p:notes>
+</file>
+
+<file path=ppt/notesSlides/notesSlide15.xml><?xml version="1.0" encoding="utf-8"?>
+<p:notes xmlns:a="http://schemas.openxmlformats.org/drawingml/2006/main" xmlns:r="http://schemas.openxmlformats.org/officeDocument/2006/relationships" xmlns:p="http://schemas.openxmlformats.org/presentationml/2006/main">
+  <p:cSld>
+    <p:spTree>
+      <p:nvGrpSpPr>
+        <p:cNvPr id="1" name=""/>
+        <p:cNvGrpSpPr/>
+        <p:nvPr/>
+      </p:nvGrpSpPr>
+      <p:grpSpPr>
+        <a:xfrm>
+          <a:off x="0" y="0"/>
+          <a:ext cx="0" cy="0"/>
+          <a:chOff x="0" y="0"/>
+          <a:chExt cx="0" cy="0"/>
+        </a:xfrm>
+      </p:grpSpPr>
+      <p:sp>
+        <p:nvSpPr>
+          <p:cNvPr id="2" name="Slide Image Placeholder 1"/>
+          <p:cNvSpPr>
+            <a:spLocks noGrp="1" noRot="1" noChangeAspect="1"/>
+          </p:cNvSpPr>
+          <p:nvPr>
+            <p:ph type="sldImg"/>
+          </p:nvPr>
+        </p:nvSpPr>
+        <p:spPr/>
+      </p:sp>
+      <p:sp>
+        <p:nvSpPr>
+          <p:cNvPr id="3" name="Notes Placeholder 2"/>
+          <p:cNvSpPr>
+            <a:spLocks noGrp="1"/>
+          </p:cNvSpPr>
+          <p:nvPr>
+            <p:ph type="body" idx="1"/>
+          </p:nvPr>
+        </p:nvSpPr>
+        <p:spPr/>
+        <p:txBody>
+          <a:bodyPr/>
+          <a:lstStyle/>
+          <a:p>
+            <a:r>
+              <a:rPr lang="en-US" dirty="0"/>
+              <a:t>마지막으로 비용입니다.
+EC2 t3.small 2대, ElastiCache, ALB를 합쳐 월 약 78달러 수준입니다. EKS로 갔다면 여기에 컨트롤 플레인 73달러가 추가됐을 겁니다.
+이번 프로젝트에서 배운 것은 — Stateless 설계와 외부 상태 저장소가 수평 확장의 열쇠라는 것, 관리형 서비스 통합이 운영 부담을 크게 줄여준다는 것, 최소 권한은 불편하지만 그 실패 메시지들이 곧 산 문서가 된다는 것, 그리고 안 쓸 때 끄는 습관이 클라우드 비용 관리의 시작이라는 점입니다.
+이상으로 발표를 마치겠습니다. 감사합니다. 질문 받겠습니다.</a:t>
+            </a:r>
+            <a:endParaRPr lang="en-US" dirty="0"/>
+          </a:p>
+        </p:txBody>
+      </p:sp>
+      <p:sp>
+        <p:nvSpPr>
+          <p:cNvPr id="4" name="Slide Number Placeholder 3"/>
+          <p:cNvSpPr>
+            <a:spLocks noGrp="1"/>
+          </p:cNvSpPr>
+          <p:nvPr>
+            <p:ph type="sldNum" sz="quarter" idx="10"/>
+          </p:nvPr>
+        </p:nvSpPr>
+        <p:spPr/>
+        <p:txBody>
+          <a:bodyPr/>
+          <a:lstStyle/>
+          <a:p>
+            <a:fld id="{F7021451-1387-4CA6-816F-3879F97B5CBC}" type="slidenum">
+              <a:rPr lang="en-US"/>
+              <a:t>15</a:t>
             </a:fld>
             <a:endParaRPr lang="en-US"/>
           </a:p>
@@ -1702,11 +1795,10 @@
           <a:p>
             <a:r>
               <a:rPr lang="en-US" dirty="0"/>
-              <a:t>오토스케일링은 2단 구조입니다.
-1단은 서비스 레벨 — 태스크의 평균 CPU가 70%를 넘으면 ECS가 태스크 수를 2개에서 최대 8개까지 늘립니다.
-2단은 인프라 레벨 — 늘어난 태스크가 들어갈 EC2 자리가 부족하면, Capacity Provider가 ASG를 조정해 EC2 자체를 2대에서 4대까지 증설합니다.
-오른쪽 흐름처럼 트래픽 증가 → 태스크 증설 → 자리 부족 → EC2 증설이 전부 자동입니다.
-반대로 한가해지면 역순으로 줄어들고, 실습 중에는 비용 절약을 위해 desired를 0으로 내려두기도 했습니다.</a:t>
+              <a:t>스토리지는 S3 버킷 두 개로 역할을 나눴습니다.
+버킷 A는 React 정적 호스팅입니다. 웹서버 없이 S3 정적 웹사이트 호스팅만으로 프론트엔드를 서빙하고, 버킷 정책으로 GetObject만 퍼블릭에 허용했습니다. 빌드할 때 ALB 주소를 환경변수로 주입하고, 배포는 aws s3 sync 한 줄입니다.
+버킷 B는 게임 히스토리입니다. 게임이 끝나면 승자와 플레이어별 최종 칩을 JSON으로 저장합니다. 컨테이너의 Task Role에는 이 버킷에 대한 PutObject 권한만 줘서 최소 권한을 지켰고, 저장이 실패해도 게임 흐름은 막지 않습니다.
+정리하면 Redis는 "지금 진행 중인 상태", S3는 "끝난 게임의 영구 기록" — 핫 데이터와 콜드 데이터를 분리한 구조입니다.</a:t>
             </a:r>
             <a:endParaRPr lang="en-US" dirty="0"/>
           </a:p>
@@ -2300,7 +2392,7 @@
                 <a:ea typeface="Noto Sans KR" pitchFamily="34" charset="-122"/>
                 <a:cs typeface="Noto Sans KR" pitchFamily="34" charset="-120"/>
               </a:rPr>
-              <a:t>09 — SECURITY</a:t>
+              <a:t>09 — AUTO SCALING</a:t>
             </a:r>
             <a:endParaRPr lang="en-US" sz="1300" dirty="0"/>
           </a:p>
@@ -2339,7 +2431,7 @@
                 <a:ea typeface="Noto Sans KR" pitchFamily="34" charset="-122"/>
                 <a:cs typeface="Noto Sans KR" pitchFamily="34" charset="-120"/>
               </a:rPr>
-              <a:t>최소 권한 설계</a:t>
+              <a:t>2단 Auto Scaling</a:t>
             </a:r>
             <a:endParaRPr lang="en-US" sz="3000" dirty="0"/>
           </a:p>
@@ -2354,11 +2446,159 @@
         <p:spPr>
           <a:xfrm>
             <a:off x="640080" y="1645920"/>
-            <a:ext cx="10972800" cy="822960"/>
+            <a:ext cx="5394960" cy="2103120"/>
           </a:xfrm>
           <a:prstGeom prst="roundRect">
             <a:avLst>
-              <a:gd name="adj" fmla="val 11111"/>
+              <a:gd name="adj" fmla="val 5217"/>
+            </a:avLst>
+          </a:prstGeom>
+          <a:solidFill>
+            <a:srgbClr val="111120"/>
+          </a:solidFill>
+          <a:ln w="12700">
+            <a:solidFill>
+              <a:srgbClr val="22D3EE"/>
+            </a:solidFill>
+            <a:prstDash val="solid"/>
+          </a:ln>
+        </p:spPr>
+      </p:sp>
+      <p:sp>
+        <p:nvSpPr>
+          <p:cNvPr id="6" name="Text 3"/>
+          <p:cNvSpPr/>
+          <p:nvPr/>
+        </p:nvSpPr>
+        <p:spPr>
+          <a:xfrm>
+            <a:off x="868680" y="1783080"/>
+            <a:ext cx="4937760" cy="365760"/>
+          </a:xfrm>
+          <a:prstGeom prst="rect">
+            <a:avLst/>
+          </a:prstGeom>
+          <a:noFill/>
+          <a:ln/>
+        </p:spPr>
+        <p:txBody>
+          <a:bodyPr wrap="square" rtlCol="0" anchor="ctr"/>
+          <a:lstStyle/>
+          <a:p>
+            <a:pPr indent="0" marL="0">
+              <a:buNone/>
+            </a:pPr>
+            <a:r>
+              <a:rPr lang="en-US" sz="1300" b="1" spc="200" kern="0" dirty="0">
+                <a:solidFill>
+                  <a:srgbClr val="22D3EE"/>
+                </a:solidFill>
+                <a:latin typeface="Noto Sans KR" pitchFamily="34" charset="0"/>
+                <a:ea typeface="Noto Sans KR" pitchFamily="34" charset="-122"/>
+                <a:cs typeface="Noto Sans KR" pitchFamily="34" charset="-120"/>
+              </a:rPr>
+              <a:t>① 서비스 레벨 (App Auto Scaling)</a:t>
+            </a:r>
+            <a:endParaRPr lang="en-US" sz="1300" dirty="0"/>
+          </a:p>
+        </p:txBody>
+      </p:sp>
+      <p:sp>
+        <p:nvSpPr>
+          <p:cNvPr id="7" name="Text 4"/>
+          <p:cNvSpPr/>
+          <p:nvPr/>
+        </p:nvSpPr>
+        <p:spPr>
+          <a:xfrm>
+            <a:off x="868680" y="2148840"/>
+            <a:ext cx="4937760" cy="1417320"/>
+          </a:xfrm>
+          <a:prstGeom prst="rect">
+            <a:avLst/>
+          </a:prstGeom>
+          <a:noFill/>
+          <a:ln/>
+        </p:spPr>
+        <p:txBody>
+          <a:bodyPr wrap="square" rtlCol="0" anchor="t"/>
+          <a:lstStyle/>
+          <a:p>
+            <a:pPr indent="0" marL="0">
+              <a:lnSpc>
+                <a:spcPct val="135000"/>
+              </a:lnSpc>
+              <a:buNone/>
+            </a:pPr>
+            <a:r>
+              <a:rPr lang="en-US" sz="1450" dirty="0">
+                <a:solidFill>
+                  <a:srgbClr val="E7E9FF"/>
+                </a:solidFill>
+                <a:latin typeface="Noto Sans KR" pitchFamily="34" charset="0"/>
+                <a:ea typeface="Noto Sans KR" pitchFamily="34" charset="-122"/>
+                <a:cs typeface="Noto Sans KR" pitchFamily="34" charset="-120"/>
+              </a:rPr>
+              <a:t>• ECS Service 태스크 수: 2 ~ 8개</a:t>
+            </a:r>
+            <a:endParaRPr lang="en-US" sz="1450" dirty="0"/>
+          </a:p>
+          <a:p>
+            <a:pPr indent="0" marL="0">
+              <a:lnSpc>
+                <a:spcPct val="135000"/>
+              </a:lnSpc>
+              <a:buNone/>
+            </a:pPr>
+            <a:r>
+              <a:rPr lang="en-US" sz="1450" dirty="0">
+                <a:solidFill>
+                  <a:srgbClr val="E7E9FF"/>
+                </a:solidFill>
+                <a:latin typeface="Noto Sans KR" pitchFamily="34" charset="0"/>
+                <a:ea typeface="Noto Sans KR" pitchFamily="34" charset="-122"/>
+                <a:cs typeface="Noto Sans KR" pitchFamily="34" charset="-120"/>
+              </a:rPr>
+              <a:t>• CPU 70% 타깃 트래킹</a:t>
+            </a:r>
+            <a:endParaRPr lang="en-US" sz="1450" dirty="0"/>
+          </a:p>
+          <a:p>
+            <a:pPr indent="0" marL="0">
+              <a:lnSpc>
+                <a:spcPct val="135000"/>
+              </a:lnSpc>
+              <a:buNone/>
+            </a:pPr>
+            <a:r>
+              <a:rPr lang="en-US" sz="1450" dirty="0">
+                <a:solidFill>
+                  <a:srgbClr val="E7E9FF"/>
+                </a:solidFill>
+                <a:latin typeface="Noto Sans KR" pitchFamily="34" charset="0"/>
+                <a:ea typeface="Noto Sans KR" pitchFamily="34" charset="-122"/>
+                <a:cs typeface="Noto Sans KR" pitchFamily="34" charset="-120"/>
+              </a:rPr>
+              <a:t>• scale-out 60s / scale-in 300s 쿨다운</a:t>
+            </a:r>
+            <a:endParaRPr lang="en-US" sz="1450" dirty="0"/>
+          </a:p>
+        </p:txBody>
+      </p:sp>
+      <p:sp>
+        <p:nvSpPr>
+          <p:cNvPr id="8" name="Shape 5"/>
+          <p:cNvSpPr/>
+          <p:nvPr/>
+        </p:nvSpPr>
+        <p:spPr>
+          <a:xfrm>
+            <a:off x="640080" y="3931920"/>
+            <a:ext cx="5394960" cy="2194560"/>
+          </a:xfrm>
+          <a:prstGeom prst="roundRect">
+            <a:avLst>
+              <a:gd name="adj" fmla="val 5000"/>
             </a:avLst>
           </a:prstGeom>
           <a:solidFill>
@@ -2374,14 +2614,14 @@
       </p:sp>
       <p:sp>
         <p:nvSpPr>
-          <p:cNvPr id="6" name="Text 3"/>
+          <p:cNvPr id="9" name="Text 6"/>
           <p:cNvSpPr/>
           <p:nvPr/>
         </p:nvSpPr>
         <p:spPr>
           <a:xfrm>
-            <a:off x="822960" y="1691640"/>
-            <a:ext cx="10607040" cy="731520"/>
+            <a:off x="868680" y="4069080"/>
+            <a:ext cx="4937760" cy="365760"/>
           </a:xfrm>
           <a:prstGeom prst="rect">
             <a:avLst/>
@@ -2393,11 +2633,11 @@
           <a:bodyPr wrap="square" rtlCol="0" anchor="ctr"/>
           <a:lstStyle/>
           <a:p>
-            <a:pPr algn="ctr" indent="0" marL="0">
-              <a:buNone/>
-            </a:pPr>
-            <a:r>
-              <a:rPr lang="en-US" sz="1700" b="1" dirty="0">
+            <a:pPr indent="0" marL="0">
+              <a:buNone/>
+            </a:pPr>
+            <a:r>
+              <a:rPr lang="en-US" sz="1300" b="1" spc="200" kern="0" dirty="0">
                 <a:solidFill>
                   <a:srgbClr val="A78BFA"/>
                 </a:solidFill>
@@ -2405,92 +2645,22 @@
                 <a:ea typeface="Noto Sans KR" pitchFamily="34" charset="-122"/>
                 <a:cs typeface="Noto Sans KR" pitchFamily="34" charset="-120"/>
               </a:rPr>
-              <a:t>🔒 ALB-SG</a:t>
-            </a:r>
-            <a:pPr algn="ctr" indent="0" marL="0">
-              <a:buNone/>
-            </a:pPr>
-            <a:r>
-              <a:rPr lang="en-US" sz="1700" dirty="0">
-                <a:solidFill>
-                  <a:srgbClr val="8B8FB8"/>
-                </a:solidFill>
-                <a:latin typeface="Noto Sans KR" pitchFamily="34" charset="0"/>
-                <a:ea typeface="Noto Sans KR" pitchFamily="34" charset="-122"/>
-                <a:cs typeface="Noto Sans KR" pitchFamily="34" charset="-120"/>
-              </a:rPr>
-              <a:t> (80←인터넷)  →  </a:t>
-            </a:r>
-            <a:pPr algn="ctr" indent="0" marL="0">
-              <a:buNone/>
-            </a:pPr>
-            <a:r>
-              <a:rPr lang="en-US" sz="1700" b="1" dirty="0">
-                <a:solidFill>
-                  <a:srgbClr val="22D3EE"/>
-                </a:solidFill>
-                <a:latin typeface="Noto Sans KR" pitchFamily="34" charset="0"/>
-                <a:ea typeface="Noto Sans KR" pitchFamily="34" charset="-122"/>
-                <a:cs typeface="Noto Sans KR" pitchFamily="34" charset="-120"/>
-              </a:rPr>
-              <a:t>EC2-SG</a:t>
-            </a:r>
-            <a:pPr algn="ctr" indent="0" marL="0">
-              <a:buNone/>
-            </a:pPr>
-            <a:r>
-              <a:rPr lang="en-US" sz="1700" dirty="0">
-                <a:solidFill>
-                  <a:srgbClr val="8B8FB8"/>
-                </a:solidFill>
-                <a:latin typeface="Noto Sans KR" pitchFamily="34" charset="0"/>
-                <a:ea typeface="Noto Sans KR" pitchFamily="34" charset="-122"/>
-                <a:cs typeface="Noto Sans KR" pitchFamily="34" charset="-120"/>
-              </a:rPr>
-              <a:t> (3001←ALB만)  →  </a:t>
-            </a:r>
-            <a:pPr algn="ctr" indent="0" marL="0">
-              <a:buNone/>
-            </a:pPr>
-            <a:r>
-              <a:rPr lang="en-US" sz="1700" b="1" dirty="0">
-                <a:solidFill>
-                  <a:srgbClr val="EF4444"/>
-                </a:solidFill>
-                <a:latin typeface="Noto Sans KR" pitchFamily="34" charset="0"/>
-                <a:ea typeface="Noto Sans KR" pitchFamily="34" charset="-122"/>
-                <a:cs typeface="Noto Sans KR" pitchFamily="34" charset="-120"/>
-              </a:rPr>
-              <a:t>Redis-SG</a:t>
-            </a:r>
-            <a:pPr algn="ctr" indent="0" marL="0">
-              <a:buNone/>
-            </a:pPr>
-            <a:r>
-              <a:rPr lang="en-US" sz="1700" dirty="0">
-                <a:solidFill>
-                  <a:srgbClr val="8B8FB8"/>
-                </a:solidFill>
-                <a:latin typeface="Noto Sans KR" pitchFamily="34" charset="0"/>
-                <a:ea typeface="Noto Sans KR" pitchFamily="34" charset="-122"/>
-                <a:cs typeface="Noto Sans KR" pitchFamily="34" charset="-120"/>
-              </a:rPr>
-              <a:t> (6379←EC2만)</a:t>
-            </a:r>
-            <a:endParaRPr lang="en-US" sz="1700" dirty="0"/>
-          </a:p>
-        </p:txBody>
-      </p:sp>
-      <p:sp>
-        <p:nvSpPr>
-          <p:cNvPr id="7" name="Text 4"/>
+              <a:t>② 인프라 레벨 (Capacity Provider)</a:t>
+            </a:r>
+            <a:endParaRPr lang="en-US" sz="1300" dirty="0"/>
+          </a:p>
+        </p:txBody>
+      </p:sp>
+      <p:sp>
+        <p:nvSpPr>
+          <p:cNvPr id="10" name="Text 7"/>
           <p:cNvSpPr/>
           <p:nvPr/>
         </p:nvSpPr>
         <p:spPr>
           <a:xfrm>
-            <a:off x="640080" y="2743200"/>
-            <a:ext cx="10972800" cy="4572000"/>
+            <a:off x="868680" y="4434840"/>
+            <a:ext cx="4937760" cy="1508760"/>
           </a:xfrm>
           <a:prstGeom prst="rect">
             <a:avLst/>
@@ -2504,29 +2674,12 @@
           <a:p>
             <a:pPr indent="0" marL="0">
               <a:lnSpc>
-                <a:spcPct val="145000"/>
-              </a:lnSpc>
-              <a:buNone/>
-            </a:pPr>
-            <a:r>
-              <a:rPr lang="en-US" sz="1300" dirty="0">
-                <a:solidFill>
-                  <a:srgbClr val="22D3EE"/>
-                </a:solidFill>
-                <a:latin typeface="Noto Sans KR" pitchFamily="34" charset="0"/>
-                <a:ea typeface="Noto Sans KR" pitchFamily="34" charset="-122"/>
-                <a:cs typeface="Noto Sans KR" pitchFamily="34" charset="-120"/>
-              </a:rPr>
-              <a:t>◆ </a:t>
-            </a:r>
-            <a:pPr indent="0" marL="0">
-              <a:lnSpc>
-                <a:spcPct val="145000"/>
-              </a:lnSpc>
-              <a:buNone/>
-            </a:pPr>
-            <a:r>
-              <a:rPr lang="en-US" sz="1600" b="1" dirty="0">
+                <a:spcPct val="135000"/>
+              </a:lnSpc>
+              <a:buNone/>
+            </a:pPr>
+            <a:r>
+              <a:rPr lang="en-US" sz="1450" dirty="0">
                 <a:solidFill>
                   <a:srgbClr val="E7E9FF"/>
                 </a:solidFill>
@@ -2534,68 +2687,19 @@
                 <a:ea typeface="Noto Sans KR" pitchFamily="34" charset="-122"/>
                 <a:cs typeface="Noto Sans KR" pitchFamily="34" charset="-120"/>
               </a:rPr>
-              <a:t>보안 그룹 참조 체인</a:t>
-            </a:r>
-            <a:pPr indent="0" marL="0">
-              <a:lnSpc>
-                <a:spcPct val="145000"/>
-              </a:lnSpc>
-              <a:buNone/>
-            </a:pPr>
-            <a:r>
-              <a:rPr lang="en-US" sz="1350" dirty="0">
-                <a:solidFill>
-                  <a:srgbClr val="8B8FB8"/>
-                </a:solidFill>
-                <a:latin typeface="Noto Sans KR" pitchFamily="34" charset="0"/>
-                <a:ea typeface="Noto Sans KR" pitchFamily="34" charset="-122"/>
-                <a:cs typeface="Noto Sans KR" pitchFamily="34" charset="-120"/>
-              </a:rPr>
-              <a:t>  — IP가 아닌 SG 참조로 제한. Redis는 인터넷에서 도달 불가</a:t>
-            </a:r>
-            <a:pPr indent="0" marL="0">
-              <a:lnSpc>
-                <a:spcPct val="145000"/>
-              </a:lnSpc>
-              <a:buNone/>
-            </a:pPr>
-            <a:r>
-              <a:rPr lang="en-US" sz="1300" dirty="0">
-                <a:solidFill>
-                  <a:srgbClr val="000000"/>
-                </a:solidFill>
-                <a:latin typeface="Noto Sans KR" pitchFamily="34" charset="0"/>
-                <a:ea typeface="Noto Sans KR" pitchFamily="34" charset="-122"/>
-                <a:cs typeface="Noto Sans KR" pitchFamily="34" charset="-120"/>
-              </a:rPr>
-              <a:t>
-</a:t>
-            </a:r>
-            <a:pPr indent="0" marL="0">
-              <a:lnSpc>
-                <a:spcPct val="145000"/>
-              </a:lnSpc>
-              <a:buNone/>
-            </a:pPr>
-            <a:r>
-              <a:rPr lang="en-US" sz="1300" dirty="0">
-                <a:solidFill>
-                  <a:srgbClr val="22D3EE"/>
-                </a:solidFill>
-                <a:latin typeface="Noto Sans KR" pitchFamily="34" charset="0"/>
-                <a:ea typeface="Noto Sans KR" pitchFamily="34" charset="-122"/>
-                <a:cs typeface="Noto Sans KR" pitchFamily="34" charset="-120"/>
-              </a:rPr>
-              <a:t>◆ </a:t>
-            </a:r>
-            <a:pPr indent="0" marL="0">
-              <a:lnSpc>
-                <a:spcPct val="145000"/>
-              </a:lnSpc>
-              <a:buNone/>
-            </a:pPr>
-            <a:r>
-              <a:rPr lang="en-US" sz="1600" b="1" dirty="0">
+              <a:t>• ASG: t3.small 2 ~ 4대</a:t>
+            </a:r>
+            <a:endParaRPr lang="en-US" sz="1450" dirty="0"/>
+          </a:p>
+          <a:p>
+            <a:pPr indent="0" marL="0">
+              <a:lnSpc>
+                <a:spcPct val="135000"/>
+              </a:lnSpc>
+              <a:buNone/>
+            </a:pPr>
+            <a:r>
+              <a:rPr lang="en-US" sz="1450" dirty="0">
                 <a:solidFill>
                   <a:srgbClr val="E7E9FF"/>
                 </a:solidFill>
@@ -2603,68 +2707,19 @@
                 <a:ea typeface="Noto Sans KR" pitchFamily="34" charset="-122"/>
                 <a:cs typeface="Noto Sans KR" pitchFamily="34" charset="-120"/>
               </a:rPr>
-              <a:t>IAM 역할 3종 분리</a:t>
-            </a:r>
-            <a:pPr indent="0" marL="0">
-              <a:lnSpc>
-                <a:spcPct val="145000"/>
-              </a:lnSpc>
-              <a:buNone/>
-            </a:pPr>
-            <a:r>
-              <a:rPr lang="en-US" sz="1350" dirty="0">
-                <a:solidFill>
-                  <a:srgbClr val="8B8FB8"/>
-                </a:solidFill>
-                <a:latin typeface="Noto Sans KR" pitchFamily="34" charset="0"/>
-                <a:ea typeface="Noto Sans KR" pitchFamily="34" charset="-122"/>
-                <a:cs typeface="Noto Sans KR" pitchFamily="34" charset="-120"/>
-              </a:rPr>
-              <a:t>  — Task Role(S3 쓰기만) / Execution Role(ECR pull·로그) / Instance Role(ECS 등록)</a:t>
-            </a:r>
-            <a:pPr indent="0" marL="0">
-              <a:lnSpc>
-                <a:spcPct val="145000"/>
-              </a:lnSpc>
-              <a:buNone/>
-            </a:pPr>
-            <a:r>
-              <a:rPr lang="en-US" sz="1300" dirty="0">
-                <a:solidFill>
-                  <a:srgbClr val="000000"/>
-                </a:solidFill>
-                <a:latin typeface="Noto Sans KR" pitchFamily="34" charset="0"/>
-                <a:ea typeface="Noto Sans KR" pitchFamily="34" charset="-122"/>
-                <a:cs typeface="Noto Sans KR" pitchFamily="34" charset="-120"/>
-              </a:rPr>
-              <a:t>
-</a:t>
-            </a:r>
-            <a:pPr indent="0" marL="0">
-              <a:lnSpc>
-                <a:spcPct val="145000"/>
-              </a:lnSpc>
-              <a:buNone/>
-            </a:pPr>
-            <a:r>
-              <a:rPr lang="en-US" sz="1300" dirty="0">
-                <a:solidFill>
-                  <a:srgbClr val="22D3EE"/>
-                </a:solidFill>
-                <a:latin typeface="Noto Sans KR" pitchFamily="34" charset="0"/>
-                <a:ea typeface="Noto Sans KR" pitchFamily="34" charset="-122"/>
-                <a:cs typeface="Noto Sans KR" pitchFamily="34" charset="-120"/>
-              </a:rPr>
-              <a:t>◆ </a:t>
-            </a:r>
-            <a:pPr indent="0" marL="0">
-              <a:lnSpc>
-                <a:spcPct val="145000"/>
-              </a:lnSpc>
-              <a:buNone/>
-            </a:pPr>
-            <a:r>
-              <a:rPr lang="en-US" sz="1600" b="1" dirty="0">
+              <a:t>• 타깃 capacity 80% — 태스크가 못 들어가면 EC2 자동 증설</a:t>
+            </a:r>
+            <a:endParaRPr lang="en-US" sz="1450" dirty="0"/>
+          </a:p>
+          <a:p>
+            <a:pPr indent="0" marL="0">
+              <a:lnSpc>
+                <a:spcPct val="135000"/>
+              </a:lnSpc>
+              <a:buNone/>
+            </a:pPr>
+            <a:r>
+              <a:rPr lang="en-US" sz="1450" dirty="0">
                 <a:solidFill>
                   <a:srgbClr val="E7E9FF"/>
                 </a:solidFill>
@@ -2672,68 +2727,107 @@
                 <a:ea typeface="Noto Sans KR" pitchFamily="34" charset="-122"/>
                 <a:cs typeface="Noto Sans KR" pitchFamily="34" charset="-120"/>
               </a:rPr>
-              <a:t>IAM 사용자도 최소 권한</a:t>
-            </a:r>
-            <a:pPr indent="0" marL="0">
-              <a:lnSpc>
-                <a:spcPct val="145000"/>
-              </a:lnSpc>
-              <a:buNone/>
-            </a:pPr>
-            <a:r>
-              <a:rPr lang="en-US" sz="1350" dirty="0">
-                <a:solidFill>
-                  <a:srgbClr val="8B8FB8"/>
-                </a:solidFill>
-                <a:latin typeface="Noto Sans KR" pitchFamily="34" charset="0"/>
-                <a:ea typeface="Noto Sans KR" pitchFamily="34" charset="-122"/>
-                <a:cs typeface="Noto Sans KR" pitchFamily="34" charset="-120"/>
-              </a:rPr>
-              <a:t>  — 필요한 액션만 명시한 정책 파일을 관리하며 점진적으로 요청</a:t>
-            </a:r>
-            <a:pPr indent="0" marL="0">
-              <a:lnSpc>
-                <a:spcPct val="145000"/>
-              </a:lnSpc>
-              <a:buNone/>
-            </a:pPr>
-            <a:r>
-              <a:rPr lang="en-US" sz="1300" dirty="0">
-                <a:solidFill>
-                  <a:srgbClr val="000000"/>
-                </a:solidFill>
-                <a:latin typeface="Noto Sans KR" pitchFamily="34" charset="0"/>
-                <a:ea typeface="Noto Sans KR" pitchFamily="34" charset="-122"/>
-                <a:cs typeface="Noto Sans KR" pitchFamily="34" charset="-120"/>
-              </a:rPr>
-              <a:t>
-</a:t>
-            </a:r>
-            <a:pPr indent="0" marL="0">
-              <a:lnSpc>
-                <a:spcPct val="145000"/>
-              </a:lnSpc>
-              <a:buNone/>
-            </a:pPr>
-            <a:r>
-              <a:rPr lang="en-US" sz="1300" dirty="0">
-                <a:solidFill>
-                  <a:srgbClr val="22D3EE"/>
-                </a:solidFill>
-                <a:latin typeface="Noto Sans KR" pitchFamily="34" charset="0"/>
-                <a:ea typeface="Noto Sans KR" pitchFamily="34" charset="-122"/>
-                <a:cs typeface="Noto Sans KR" pitchFamily="34" charset="-120"/>
-              </a:rPr>
-              <a:t>◆ </a:t>
-            </a:r>
-            <a:pPr indent="0" marL="0">
-              <a:lnSpc>
-                <a:spcPct val="145000"/>
-              </a:lnSpc>
-              <a:buNone/>
-            </a:pPr>
-            <a:r>
-              <a:rPr lang="en-US" sz="1600" b="1" dirty="0">
+              <a:t>• 관리형 스케일링: ECS가 ASG를 직접 조정</a:t>
+            </a:r>
+            <a:endParaRPr lang="en-US" sz="1450" dirty="0"/>
+          </a:p>
+        </p:txBody>
+      </p:sp>
+      <p:sp>
+        <p:nvSpPr>
+          <p:cNvPr id="11" name="Shape 8"/>
+          <p:cNvSpPr/>
+          <p:nvPr/>
+        </p:nvSpPr>
+        <p:spPr>
+          <a:xfrm>
+            <a:off x="6309360" y="1645920"/>
+            <a:ext cx="5394960" cy="4480560"/>
+          </a:xfrm>
+          <a:prstGeom prst="roundRect">
+            <a:avLst>
+              <a:gd name="adj" fmla="val 2449"/>
+            </a:avLst>
+          </a:prstGeom>
+          <a:solidFill>
+            <a:srgbClr val="111120"/>
+          </a:solidFill>
+          <a:ln w="12700">
+            <a:solidFill>
+              <a:srgbClr val="34D399"/>
+            </a:solidFill>
+            <a:prstDash val="solid"/>
+          </a:ln>
+        </p:spPr>
+      </p:sp>
+      <p:sp>
+        <p:nvSpPr>
+          <p:cNvPr id="12" name="Text 9"/>
+          <p:cNvSpPr/>
+          <p:nvPr/>
+        </p:nvSpPr>
+        <p:spPr>
+          <a:xfrm>
+            <a:off x="6537960" y="1783080"/>
+            <a:ext cx="4937760" cy="365760"/>
+          </a:xfrm>
+          <a:prstGeom prst="rect">
+            <a:avLst/>
+          </a:prstGeom>
+          <a:noFill/>
+          <a:ln/>
+        </p:spPr>
+        <p:txBody>
+          <a:bodyPr wrap="square" rtlCol="0" anchor="ctr"/>
+          <a:lstStyle/>
+          <a:p>
+            <a:pPr indent="0" marL="0">
+              <a:buNone/>
+            </a:pPr>
+            <a:r>
+              <a:rPr lang="en-US" sz="1300" b="1" spc="200" kern="0" dirty="0">
+                <a:solidFill>
+                  <a:srgbClr val="34D399"/>
+                </a:solidFill>
+                <a:latin typeface="Noto Sans KR" pitchFamily="34" charset="0"/>
+                <a:ea typeface="Noto Sans KR" pitchFamily="34" charset="-122"/>
+                <a:cs typeface="Noto Sans KR" pitchFamily="34" charset="-120"/>
+              </a:rPr>
+              <a:t>동작 흐름</a:t>
+            </a:r>
+            <a:endParaRPr lang="en-US" sz="1300" dirty="0"/>
+          </a:p>
+        </p:txBody>
+      </p:sp>
+      <p:sp>
+        <p:nvSpPr>
+          <p:cNvPr id="13" name="Text 10"/>
+          <p:cNvSpPr/>
+          <p:nvPr/>
+        </p:nvSpPr>
+        <p:spPr>
+          <a:xfrm>
+            <a:off x="6537960" y="2148840"/>
+            <a:ext cx="4937760" cy="3794760"/>
+          </a:xfrm>
+          <a:prstGeom prst="rect">
+            <a:avLst/>
+          </a:prstGeom>
+          <a:noFill/>
+          <a:ln/>
+        </p:spPr>
+        <p:txBody>
+          <a:bodyPr wrap="square" rtlCol="0" anchor="t"/>
+          <a:lstStyle/>
+          <a:p>
+            <a:pPr indent="0" marL="0">
+              <a:lnSpc>
+                <a:spcPct val="135000"/>
+              </a:lnSpc>
+              <a:buNone/>
+            </a:pPr>
+            <a:r>
+              <a:rPr lang="en-US" sz="1450" dirty="0">
                 <a:solidFill>
                   <a:srgbClr val="E7E9FF"/>
                 </a:solidFill>
@@ -2741,27 +2835,138 @@
                 <a:ea typeface="Noto Sans KR" pitchFamily="34" charset="-122"/>
                 <a:cs typeface="Noto Sans KR" pitchFamily="34" charset="-120"/>
               </a:rPr>
-              <a:t>예: CreateLoadBalancer의 숨은 의존 권한을 실패 → 분석 → 추가로 해결</a:t>
-            </a:r>
-            <a:pPr indent="0" marL="0">
-              <a:lnSpc>
-                <a:spcPct val="145000"/>
-              </a:lnSpc>
-              <a:buNone/>
-            </a:pPr>
-            <a:r>
-              <a:rPr lang="en-US" sz="1300" dirty="0">
-                <a:solidFill>
-                  <a:srgbClr val="000000"/>
-                </a:solidFill>
-                <a:latin typeface="Noto Sans KR" pitchFamily="34" charset="0"/>
-                <a:ea typeface="Noto Sans KR" pitchFamily="34" charset="-122"/>
-                <a:cs typeface="Noto Sans KR" pitchFamily="34" charset="-120"/>
-              </a:rPr>
-              <a:t>
-</a:t>
-            </a:r>
-            <a:endParaRPr lang="en-US" sz="1300" dirty="0"/>
+              <a:t>트래픽 증가</a:t>
+            </a:r>
+            <a:endParaRPr lang="en-US" sz="1450" dirty="0"/>
+          </a:p>
+          <a:p>
+            <a:pPr indent="0" marL="0">
+              <a:lnSpc>
+                <a:spcPct val="135000"/>
+              </a:lnSpc>
+              <a:buNone/>
+            </a:pPr>
+            <a:r>
+              <a:rPr lang="en-US" sz="1450" dirty="0">
+                <a:solidFill>
+                  <a:srgbClr val="E7E9FF"/>
+                </a:solidFill>
+                <a:latin typeface="Noto Sans KR" pitchFamily="34" charset="0"/>
+                <a:ea typeface="Noto Sans KR" pitchFamily="34" charset="-122"/>
+                <a:cs typeface="Noto Sans KR" pitchFamily="34" charset="-120"/>
+              </a:rPr>
+              <a:t>→ 태스크 CPU 70% 초과</a:t>
+            </a:r>
+            <a:endParaRPr lang="en-US" sz="1450" dirty="0"/>
+          </a:p>
+          <a:p>
+            <a:pPr indent="0" marL="0">
+              <a:lnSpc>
+                <a:spcPct val="135000"/>
+              </a:lnSpc>
+              <a:buNone/>
+            </a:pPr>
+            <a:r>
+              <a:rPr lang="en-US" sz="1450" dirty="0">
+                <a:solidFill>
+                  <a:srgbClr val="E7E9FF"/>
+                </a:solidFill>
+                <a:latin typeface="Noto Sans KR" pitchFamily="34" charset="0"/>
+                <a:ea typeface="Noto Sans KR" pitchFamily="34" charset="-122"/>
+                <a:cs typeface="Noto Sans KR" pitchFamily="34" charset="-120"/>
+              </a:rPr>
+              <a:t>→ 태스크 증설 (서비스 레벨)</a:t>
+            </a:r>
+            <a:endParaRPr lang="en-US" sz="1450" dirty="0"/>
+          </a:p>
+          <a:p>
+            <a:pPr indent="0" marL="0">
+              <a:lnSpc>
+                <a:spcPct val="135000"/>
+              </a:lnSpc>
+              <a:buNone/>
+            </a:pPr>
+            <a:r>
+              <a:rPr lang="en-US" sz="1450" dirty="0">
+                <a:solidFill>
+                  <a:srgbClr val="E7E9FF"/>
+                </a:solidFill>
+                <a:latin typeface="Noto Sans KR" pitchFamily="34" charset="0"/>
+                <a:ea typeface="Noto Sans KR" pitchFamily="34" charset="-122"/>
+                <a:cs typeface="Noto Sans KR" pitchFamily="34" charset="-120"/>
+              </a:rPr>
+              <a:t>→ EC2에 빈 자리 부족</a:t>
+            </a:r>
+            <a:endParaRPr lang="en-US" sz="1450" dirty="0"/>
+          </a:p>
+          <a:p>
+            <a:pPr indent="0" marL="0">
+              <a:lnSpc>
+                <a:spcPct val="135000"/>
+              </a:lnSpc>
+              <a:buNone/>
+            </a:pPr>
+            <a:r>
+              <a:rPr lang="en-US" sz="1450" dirty="0">
+                <a:solidFill>
+                  <a:srgbClr val="E7E9FF"/>
+                </a:solidFill>
+                <a:latin typeface="Noto Sans KR" pitchFamily="34" charset="0"/>
+                <a:ea typeface="Noto Sans KR" pitchFamily="34" charset="-122"/>
+                <a:cs typeface="Noto Sans KR" pitchFamily="34" charset="-120"/>
+              </a:rPr>
+              <a:t>→ EC2 증설 (Capacity Provider)</a:t>
+            </a:r>
+            <a:endParaRPr lang="en-US" sz="1450" dirty="0"/>
+          </a:p>
+          <a:p>
+            <a:pPr indent="0" marL="0">
+              <a:lnSpc>
+                <a:spcPct val="135000"/>
+              </a:lnSpc>
+              <a:buNone/>
+            </a:pPr>
+            <a:endParaRPr lang="en-US" sz="1450" dirty="0"/>
+          </a:p>
+          <a:p>
+            <a:pPr indent="0" marL="0">
+              <a:lnSpc>
+                <a:spcPct val="135000"/>
+              </a:lnSpc>
+              <a:buNone/>
+            </a:pPr>
+            <a:r>
+              <a:rPr lang="en-US" sz="1450" dirty="0">
+                <a:solidFill>
+                  <a:srgbClr val="E7E9FF"/>
+                </a:solidFill>
+                <a:latin typeface="Noto Sans KR" pitchFamily="34" charset="0"/>
+                <a:ea typeface="Noto Sans KR" pitchFamily="34" charset="-122"/>
+                <a:cs typeface="Noto Sans KR" pitchFamily="34" charset="-120"/>
+              </a:rPr>
+              <a:t>반대로 한가하면 역순 축소</a:t>
+            </a:r>
+            <a:endParaRPr lang="en-US" sz="1450" dirty="0"/>
+          </a:p>
+          <a:p>
+            <a:pPr indent="0" marL="0">
+              <a:lnSpc>
+                <a:spcPct val="135000"/>
+              </a:lnSpc>
+              <a:buNone/>
+            </a:pPr>
+            <a:r>
+              <a:rPr lang="en-US" sz="1450" dirty="0">
+                <a:solidFill>
+                  <a:srgbClr val="E7E9FF"/>
+                </a:solidFill>
+                <a:latin typeface="Noto Sans KR" pitchFamily="34" charset="0"/>
+                <a:ea typeface="Noto Sans KR" pitchFamily="34" charset="-122"/>
+                <a:cs typeface="Noto Sans KR" pitchFamily="34" charset="-120"/>
+              </a:rPr>
+              <a:t>실습 중에는 비용 절약을 위해 desired 0으로 내려두기도</a:t>
+            </a:r>
+            <a:endParaRPr lang="en-US" sz="1450" dirty="0"/>
           </a:p>
         </p:txBody>
       </p:sp>
@@ -2830,7 +3035,7 @@
                 <a:ea typeface="Noto Sans KR" pitchFamily="34" charset="-122"/>
                 <a:cs typeface="Noto Sans KR" pitchFamily="34" charset="-120"/>
               </a:rPr>
-              <a:t>10 — VERIFICATION</a:t>
+              <a:t>10 — SECURITY</a:t>
             </a:r>
             <a:endParaRPr lang="en-US" sz="1300" dirty="0"/>
           </a:p>
@@ -2869,7 +3074,7 @@
                 <a:ea typeface="Noto Sans KR" pitchFamily="34" charset="-122"/>
                 <a:cs typeface="Noto Sans KR" pitchFamily="34" charset="-120"/>
               </a:rPr>
-              <a:t>검증 — "되는 것 같다"가 아니라 증명</a:t>
+              <a:t>최소 권한 설계</a:t>
             </a:r>
             <a:endParaRPr lang="en-US" sz="3000" dirty="0"/>
           </a:p>
@@ -2877,268 +3082,18 @@
       </p:sp>
       <p:sp>
         <p:nvSpPr>
-          <p:cNvPr id="5" name="Text 2"/>
+          <p:cNvPr id="5" name="Shape 2"/>
           <p:cNvSpPr/>
           <p:nvPr/>
         </p:nvSpPr>
         <p:spPr>
           <a:xfrm>
             <a:off x="640080" y="1645920"/>
-            <a:ext cx="10972800" cy="4572000"/>
-          </a:xfrm>
-          <a:prstGeom prst="rect">
-            <a:avLst/>
-          </a:prstGeom>
-          <a:noFill/>
-          <a:ln/>
-        </p:spPr>
-        <p:txBody>
-          <a:bodyPr wrap="square" rtlCol="0" anchor="t"/>
-          <a:lstStyle/>
-          <a:p>
-            <a:pPr indent="0" marL="0">
-              <a:lnSpc>
-                <a:spcPct val="145000"/>
-              </a:lnSpc>
-              <a:buNone/>
-            </a:pPr>
-            <a:r>
-              <a:rPr lang="en-US" sz="1350" dirty="0">
-                <a:solidFill>
-                  <a:srgbClr val="22D3EE"/>
-                </a:solidFill>
-                <a:latin typeface="Noto Sans KR" pitchFamily="34" charset="0"/>
-                <a:ea typeface="Noto Sans KR" pitchFamily="34" charset="-122"/>
-                <a:cs typeface="Noto Sans KR" pitchFamily="34" charset="-120"/>
-              </a:rPr>
-              <a:t>◆ </a:t>
-            </a:r>
-            <a:pPr indent="0" marL="0">
-              <a:lnSpc>
-                <a:spcPct val="145000"/>
-              </a:lnSpc>
-              <a:buNone/>
-            </a:pPr>
-            <a:r>
-              <a:rPr lang="en-US" sz="1650" b="1" dirty="0">
-                <a:solidFill>
-                  <a:srgbClr val="E7E9FF"/>
-                </a:solidFill>
-                <a:latin typeface="Noto Sans KR" pitchFamily="34" charset="0"/>
-                <a:ea typeface="Noto Sans KR" pitchFamily="34" charset="-122"/>
-                <a:cs typeface="Noto Sans KR" pitchFamily="34" charset="-120"/>
-              </a:rPr>
-              <a:t>단위/통합 테스트 44개</a:t>
-            </a:r>
-            <a:pPr indent="0" marL="0">
-              <a:lnSpc>
-                <a:spcPct val="145000"/>
-              </a:lnSpc>
-              <a:buNone/>
-            </a:pPr>
-            <a:r>
-              <a:rPr lang="en-US" sz="1400" dirty="0">
-                <a:solidFill>
-                  <a:srgbClr val="8B8FB8"/>
-                </a:solidFill>
-                <a:latin typeface="Noto Sans KR" pitchFamily="34" charset="0"/>
-                <a:ea typeface="Noto Sans KR" pitchFamily="34" charset="-122"/>
-                <a:cs typeface="Noto Sans KR" pitchFamily="34" charset="-120"/>
-              </a:rPr>
-              <a:t>  — 게임 엔진, Redis 타이머, WS 연결 종료 처리</a:t>
-            </a:r>
-            <a:pPr indent="0" marL="0">
-              <a:lnSpc>
-                <a:spcPct val="145000"/>
-              </a:lnSpc>
-              <a:buNone/>
-            </a:pPr>
-            <a:r>
-              <a:rPr lang="en-US" sz="1350" dirty="0">
-                <a:solidFill>
-                  <a:srgbClr val="000000"/>
-                </a:solidFill>
-                <a:latin typeface="Noto Sans KR" pitchFamily="34" charset="0"/>
-                <a:ea typeface="Noto Sans KR" pitchFamily="34" charset="-122"/>
-                <a:cs typeface="Noto Sans KR" pitchFamily="34" charset="-120"/>
-              </a:rPr>
-              <a:t>
-</a:t>
-            </a:r>
-            <a:pPr indent="0" marL="0">
-              <a:lnSpc>
-                <a:spcPct val="145000"/>
-              </a:lnSpc>
-              <a:buNone/>
-            </a:pPr>
-            <a:r>
-              <a:rPr lang="en-US" sz="1350" dirty="0">
-                <a:solidFill>
-                  <a:srgbClr val="22D3EE"/>
-                </a:solidFill>
-                <a:latin typeface="Noto Sans KR" pitchFamily="34" charset="0"/>
-                <a:ea typeface="Noto Sans KR" pitchFamily="34" charset="-122"/>
-                <a:cs typeface="Noto Sans KR" pitchFamily="34" charset="-120"/>
-              </a:rPr>
-              <a:t>◆ </a:t>
-            </a:r>
-            <a:pPr indent="0" marL="0">
-              <a:lnSpc>
-                <a:spcPct val="145000"/>
-              </a:lnSpc>
-              <a:buNone/>
-            </a:pPr>
-            <a:r>
-              <a:rPr lang="en-US" sz="1650" b="1" dirty="0">
-                <a:solidFill>
-                  <a:srgbClr val="E7E9FF"/>
-                </a:solidFill>
-                <a:latin typeface="Noto Sans KR" pitchFamily="34" charset="0"/>
-                <a:ea typeface="Noto Sans KR" pitchFamily="34" charset="-122"/>
-                <a:cs typeface="Noto Sans KR" pitchFamily="34" charset="-120"/>
-              </a:rPr>
-              <a:t>로컬 E2E: 실제 브라우저 4개 자동 조작 → 풀 게임 완주 (Playwright)</a:t>
-            </a:r>
-            <a:pPr indent="0" marL="0">
-              <a:lnSpc>
-                <a:spcPct val="145000"/>
-              </a:lnSpc>
-              <a:buNone/>
-            </a:pPr>
-            <a:r>
-              <a:rPr lang="en-US" sz="1350" dirty="0">
-                <a:solidFill>
-                  <a:srgbClr val="000000"/>
-                </a:solidFill>
-                <a:latin typeface="Noto Sans KR" pitchFamily="34" charset="0"/>
-                <a:ea typeface="Noto Sans KR" pitchFamily="34" charset="-122"/>
-                <a:cs typeface="Noto Sans KR" pitchFamily="34" charset="-120"/>
-              </a:rPr>
-              <a:t>
-</a:t>
-            </a:r>
-            <a:pPr indent="0" marL="0">
-              <a:lnSpc>
-                <a:spcPct val="145000"/>
-              </a:lnSpc>
-              <a:buNone/>
-            </a:pPr>
-            <a:r>
-              <a:rPr lang="en-US" sz="1350" dirty="0">
-                <a:solidFill>
-                  <a:srgbClr val="22D3EE"/>
-                </a:solidFill>
-                <a:latin typeface="Noto Sans KR" pitchFamily="34" charset="0"/>
-                <a:ea typeface="Noto Sans KR" pitchFamily="34" charset="-122"/>
-                <a:cs typeface="Noto Sans KR" pitchFamily="34" charset="-120"/>
-              </a:rPr>
-              <a:t>◆ </a:t>
-            </a:r>
-            <a:pPr indent="0" marL="0">
-              <a:lnSpc>
-                <a:spcPct val="145000"/>
-              </a:lnSpc>
-              <a:buNone/>
-            </a:pPr>
-            <a:r>
-              <a:rPr lang="en-US" sz="1650" b="1" dirty="0">
-                <a:solidFill>
-                  <a:srgbClr val="E7E9FF"/>
-                </a:solidFill>
-                <a:latin typeface="Noto Sans KR" pitchFamily="34" charset="0"/>
-                <a:ea typeface="Noto Sans KR" pitchFamily="34" charset="-122"/>
-                <a:cs typeface="Noto Sans KR" pitchFamily="34" charset="-120"/>
-              </a:rPr>
-              <a:t>프로덕션 E2E: ALB 경유 4클라이언트 → 멀티 태스크 분산 환경에서 쇼다운까지</a:t>
-            </a:r>
-            <a:pPr indent="0" marL="0">
-              <a:lnSpc>
-                <a:spcPct val="145000"/>
-              </a:lnSpc>
-              <a:buNone/>
-            </a:pPr>
-            <a:r>
-              <a:rPr lang="en-US" sz="1350" dirty="0">
-                <a:solidFill>
-                  <a:srgbClr val="000000"/>
-                </a:solidFill>
-                <a:latin typeface="Noto Sans KR" pitchFamily="34" charset="0"/>
-                <a:ea typeface="Noto Sans KR" pitchFamily="34" charset="-122"/>
-                <a:cs typeface="Noto Sans KR" pitchFamily="34" charset="-120"/>
-              </a:rPr>
-              <a:t>
-</a:t>
-            </a:r>
-            <a:pPr indent="0" marL="0">
-              <a:lnSpc>
-                <a:spcPct val="145000"/>
-              </a:lnSpc>
-              <a:buNone/>
-            </a:pPr>
-            <a:r>
-              <a:rPr lang="en-US" sz="1350" dirty="0">
-                <a:solidFill>
-                  <a:srgbClr val="22D3EE"/>
-                </a:solidFill>
-                <a:latin typeface="Noto Sans KR" pitchFamily="34" charset="0"/>
-                <a:ea typeface="Noto Sans KR" pitchFamily="34" charset="-122"/>
-                <a:cs typeface="Noto Sans KR" pitchFamily="34" charset="-120"/>
-              </a:rPr>
-              <a:t>◆ </a:t>
-            </a:r>
-            <a:pPr indent="0" marL="0">
-              <a:lnSpc>
-                <a:spcPct val="145000"/>
-              </a:lnSpc>
-              <a:buNone/>
-            </a:pPr>
-            <a:r>
-              <a:rPr lang="en-US" sz="1650" b="1" dirty="0">
-                <a:solidFill>
-                  <a:srgbClr val="E7E9FF"/>
-                </a:solidFill>
-                <a:latin typeface="Noto Sans KR" pitchFamily="34" charset="0"/>
-                <a:ea typeface="Noto Sans KR" pitchFamily="34" charset="-122"/>
-                <a:cs typeface="Noto Sans KR" pitchFamily="34" charset="-120"/>
-              </a:rPr>
-              <a:t>ALB 헬스체크 OK · 타깃 2/2 healthy · 롤링 배포 무중단 확인</a:t>
-            </a:r>
-            <a:pPr indent="0" marL="0">
-              <a:lnSpc>
-                <a:spcPct val="145000"/>
-              </a:lnSpc>
-              <a:buNone/>
-            </a:pPr>
-            <a:r>
-              <a:rPr lang="en-US" sz="1350" dirty="0">
-                <a:solidFill>
-                  <a:srgbClr val="000000"/>
-                </a:solidFill>
-                <a:latin typeface="Noto Sans KR" pitchFamily="34" charset="0"/>
-                <a:ea typeface="Noto Sans KR" pitchFamily="34" charset="-122"/>
-                <a:cs typeface="Noto Sans KR" pitchFamily="34" charset="-120"/>
-              </a:rPr>
-              <a:t>
-</a:t>
-            </a:r>
-            <a:endParaRPr lang="en-US" sz="1350" dirty="0"/>
-          </a:p>
-        </p:txBody>
-      </p:sp>
-      <p:sp>
-        <p:nvSpPr>
-          <p:cNvPr id="6" name="Shape 3"/>
-          <p:cNvSpPr/>
-          <p:nvPr/>
-        </p:nvSpPr>
-        <p:spPr>
-          <a:xfrm>
-            <a:off x="640080" y="4480560"/>
-            <a:ext cx="10972800" cy="1737360"/>
+            <a:ext cx="10972800" cy="822960"/>
           </a:xfrm>
           <a:prstGeom prst="roundRect">
             <a:avLst>
-              <a:gd name="adj" fmla="val 6316"/>
+              <a:gd name="adj" fmla="val 11111"/>
             </a:avLst>
           </a:prstGeom>
           <a:solidFill>
@@ -3146,7 +3101,7 @@
           </a:solidFill>
           <a:ln w="12700">
             <a:solidFill>
-              <a:srgbClr val="F59E0B"/>
+              <a:srgbClr val="A78BFA"/>
             </a:solidFill>
             <a:prstDash val="solid"/>
           </a:ln>
@@ -3154,14 +3109,123 @@
       </p:sp>
       <p:sp>
         <p:nvSpPr>
+          <p:cNvPr id="6" name="Text 3"/>
+          <p:cNvSpPr/>
+          <p:nvPr/>
+        </p:nvSpPr>
+        <p:spPr>
+          <a:xfrm>
+            <a:off x="822960" y="1691640"/>
+            <a:ext cx="10607040" cy="731520"/>
+          </a:xfrm>
+          <a:prstGeom prst="rect">
+            <a:avLst/>
+          </a:prstGeom>
+          <a:noFill/>
+          <a:ln/>
+        </p:spPr>
+        <p:txBody>
+          <a:bodyPr wrap="square" rtlCol="0" anchor="ctr"/>
+          <a:lstStyle/>
+          <a:p>
+            <a:pPr algn="ctr" indent="0" marL="0">
+              <a:buNone/>
+            </a:pPr>
+            <a:r>
+              <a:rPr lang="en-US" sz="1700" b="1" dirty="0">
+                <a:solidFill>
+                  <a:srgbClr val="A78BFA"/>
+                </a:solidFill>
+                <a:latin typeface="Noto Sans KR" pitchFamily="34" charset="0"/>
+                <a:ea typeface="Noto Sans KR" pitchFamily="34" charset="-122"/>
+                <a:cs typeface="Noto Sans KR" pitchFamily="34" charset="-120"/>
+              </a:rPr>
+              <a:t>🔒 ALB-SG</a:t>
+            </a:r>
+            <a:pPr algn="ctr" indent="0" marL="0">
+              <a:buNone/>
+            </a:pPr>
+            <a:r>
+              <a:rPr lang="en-US" sz="1700" dirty="0">
+                <a:solidFill>
+                  <a:srgbClr val="8B8FB8"/>
+                </a:solidFill>
+                <a:latin typeface="Noto Sans KR" pitchFamily="34" charset="0"/>
+                <a:ea typeface="Noto Sans KR" pitchFamily="34" charset="-122"/>
+                <a:cs typeface="Noto Sans KR" pitchFamily="34" charset="-120"/>
+              </a:rPr>
+              <a:t> (80←인터넷)  →  </a:t>
+            </a:r>
+            <a:pPr algn="ctr" indent="0" marL="0">
+              <a:buNone/>
+            </a:pPr>
+            <a:r>
+              <a:rPr lang="en-US" sz="1700" b="1" dirty="0">
+                <a:solidFill>
+                  <a:srgbClr val="22D3EE"/>
+                </a:solidFill>
+                <a:latin typeface="Noto Sans KR" pitchFamily="34" charset="0"/>
+                <a:ea typeface="Noto Sans KR" pitchFamily="34" charset="-122"/>
+                <a:cs typeface="Noto Sans KR" pitchFamily="34" charset="-120"/>
+              </a:rPr>
+              <a:t>EC2-SG</a:t>
+            </a:r>
+            <a:pPr algn="ctr" indent="0" marL="0">
+              <a:buNone/>
+            </a:pPr>
+            <a:r>
+              <a:rPr lang="en-US" sz="1700" dirty="0">
+                <a:solidFill>
+                  <a:srgbClr val="8B8FB8"/>
+                </a:solidFill>
+                <a:latin typeface="Noto Sans KR" pitchFamily="34" charset="0"/>
+                <a:ea typeface="Noto Sans KR" pitchFamily="34" charset="-122"/>
+                <a:cs typeface="Noto Sans KR" pitchFamily="34" charset="-120"/>
+              </a:rPr>
+              <a:t> (3001←ALB만)  →  </a:t>
+            </a:r>
+            <a:pPr algn="ctr" indent="0" marL="0">
+              <a:buNone/>
+            </a:pPr>
+            <a:r>
+              <a:rPr lang="en-US" sz="1700" b="1" dirty="0">
+                <a:solidFill>
+                  <a:srgbClr val="EF4444"/>
+                </a:solidFill>
+                <a:latin typeface="Noto Sans KR" pitchFamily="34" charset="0"/>
+                <a:ea typeface="Noto Sans KR" pitchFamily="34" charset="-122"/>
+                <a:cs typeface="Noto Sans KR" pitchFamily="34" charset="-120"/>
+              </a:rPr>
+              <a:t>Redis-SG</a:t>
+            </a:r>
+            <a:pPr algn="ctr" indent="0" marL="0">
+              <a:buNone/>
+            </a:pPr>
+            <a:r>
+              <a:rPr lang="en-US" sz="1700" dirty="0">
+                <a:solidFill>
+                  <a:srgbClr val="8B8FB8"/>
+                </a:solidFill>
+                <a:latin typeface="Noto Sans KR" pitchFamily="34" charset="0"/>
+                <a:ea typeface="Noto Sans KR" pitchFamily="34" charset="-122"/>
+                <a:cs typeface="Noto Sans KR" pitchFamily="34" charset="-120"/>
+              </a:rPr>
+              <a:t> (6379←EC2만)</a:t>
+            </a:r>
+            <a:endParaRPr lang="en-US" sz="1700" dirty="0"/>
+          </a:p>
+        </p:txBody>
+      </p:sp>
+      <p:sp>
+        <p:nvSpPr>
           <p:cNvPr id="7" name="Text 4"/>
           <p:cNvSpPr/>
           <p:nvPr/>
         </p:nvSpPr>
         <p:spPr>
           <a:xfrm>
-            <a:off x="868680" y="4617720"/>
-            <a:ext cx="10515600" cy="365760"/>
+            <a:off x="640080" y="2743200"/>
+            <a:ext cx="10972800" cy="4572000"/>
           </a:xfrm>
           <a:prstGeom prst="rect">
             <a:avLst/>
@@ -3170,66 +3234,269 @@
           <a:ln/>
         </p:spPr>
         <p:txBody>
-          <a:bodyPr wrap="square" rtlCol="0" anchor="ctr"/>
-          <a:lstStyle/>
-          <a:p>
-            <a:pPr indent="0" marL="0">
-              <a:buNone/>
-            </a:pPr>
-            <a:r>
-              <a:rPr lang="en-US" sz="1300" b="1" spc="200" kern="0" dirty="0">
-                <a:solidFill>
-                  <a:srgbClr val="F59E0B"/>
-                </a:solidFill>
-                <a:latin typeface="Noto Sans KR" pitchFamily="34" charset="0"/>
-                <a:ea typeface="Noto Sans KR" pitchFamily="34" charset="-122"/>
-                <a:cs typeface="Noto Sans KR" pitchFamily="34" charset="-120"/>
-              </a:rPr>
-              <a:t>TDD로 잡은 실제 버그들</a:t>
+          <a:bodyPr wrap="square" rtlCol="0" anchor="t"/>
+          <a:lstStyle/>
+          <a:p>
+            <a:pPr indent="0" marL="0">
+              <a:lnSpc>
+                <a:spcPct val="145000"/>
+              </a:lnSpc>
+              <a:buNone/>
+            </a:pPr>
+            <a:r>
+              <a:rPr lang="en-US" sz="1300" dirty="0">
+                <a:solidFill>
+                  <a:srgbClr val="22D3EE"/>
+                </a:solidFill>
+                <a:latin typeface="Noto Sans KR" pitchFamily="34" charset="0"/>
+                <a:ea typeface="Noto Sans KR" pitchFamily="34" charset="-122"/>
+                <a:cs typeface="Noto Sans KR" pitchFamily="34" charset="-120"/>
+              </a:rPr>
+              <a:t>◆ </a:t>
+            </a:r>
+            <a:pPr indent="0" marL="0">
+              <a:lnSpc>
+                <a:spcPct val="145000"/>
+              </a:lnSpc>
+              <a:buNone/>
+            </a:pPr>
+            <a:r>
+              <a:rPr lang="en-US" sz="1600" b="1" dirty="0">
+                <a:solidFill>
+                  <a:srgbClr val="E7E9FF"/>
+                </a:solidFill>
+                <a:latin typeface="Noto Sans KR" pitchFamily="34" charset="0"/>
+                <a:ea typeface="Noto Sans KR" pitchFamily="34" charset="-122"/>
+                <a:cs typeface="Noto Sans KR" pitchFamily="34" charset="-120"/>
+              </a:rPr>
+              <a:t>보안 그룹 참조 체인</a:t>
+            </a:r>
+            <a:pPr indent="0" marL="0">
+              <a:lnSpc>
+                <a:spcPct val="145000"/>
+              </a:lnSpc>
+              <a:buNone/>
+            </a:pPr>
+            <a:r>
+              <a:rPr lang="en-US" sz="1350" dirty="0">
+                <a:solidFill>
+                  <a:srgbClr val="8B8FB8"/>
+                </a:solidFill>
+                <a:latin typeface="Noto Sans KR" pitchFamily="34" charset="0"/>
+                <a:ea typeface="Noto Sans KR" pitchFamily="34" charset="-122"/>
+                <a:cs typeface="Noto Sans KR" pitchFamily="34" charset="-120"/>
+              </a:rPr>
+              <a:t>  — IP가 아닌 SG 참조로 제한. Redis는 인터넷에서 도달 불가</a:t>
+            </a:r>
+            <a:pPr indent="0" marL="0">
+              <a:lnSpc>
+                <a:spcPct val="145000"/>
+              </a:lnSpc>
+              <a:buNone/>
+            </a:pPr>
+            <a:r>
+              <a:rPr lang="en-US" sz="1300" dirty="0">
+                <a:solidFill>
+                  <a:srgbClr val="000000"/>
+                </a:solidFill>
+                <a:latin typeface="Noto Sans KR" pitchFamily="34" charset="0"/>
+                <a:ea typeface="Noto Sans KR" pitchFamily="34" charset="-122"/>
+                <a:cs typeface="Noto Sans KR" pitchFamily="34" charset="-120"/>
+              </a:rPr>
+              <a:t>
+</a:t>
+            </a:r>
+            <a:pPr indent="0" marL="0">
+              <a:lnSpc>
+                <a:spcPct val="145000"/>
+              </a:lnSpc>
+              <a:buNone/>
+            </a:pPr>
+            <a:r>
+              <a:rPr lang="en-US" sz="1300" dirty="0">
+                <a:solidFill>
+                  <a:srgbClr val="22D3EE"/>
+                </a:solidFill>
+                <a:latin typeface="Noto Sans KR" pitchFamily="34" charset="0"/>
+                <a:ea typeface="Noto Sans KR" pitchFamily="34" charset="-122"/>
+                <a:cs typeface="Noto Sans KR" pitchFamily="34" charset="-120"/>
+              </a:rPr>
+              <a:t>◆ </a:t>
+            </a:r>
+            <a:pPr indent="0" marL="0">
+              <a:lnSpc>
+                <a:spcPct val="145000"/>
+              </a:lnSpc>
+              <a:buNone/>
+            </a:pPr>
+            <a:r>
+              <a:rPr lang="en-US" sz="1600" b="1" dirty="0">
+                <a:solidFill>
+                  <a:srgbClr val="E7E9FF"/>
+                </a:solidFill>
+                <a:latin typeface="Noto Sans KR" pitchFamily="34" charset="0"/>
+                <a:ea typeface="Noto Sans KR" pitchFamily="34" charset="-122"/>
+                <a:cs typeface="Noto Sans KR" pitchFamily="34" charset="-120"/>
+              </a:rPr>
+              <a:t>IAM 역할 3종 분리</a:t>
+            </a:r>
+            <a:pPr indent="0" marL="0">
+              <a:lnSpc>
+                <a:spcPct val="145000"/>
+              </a:lnSpc>
+              <a:buNone/>
+            </a:pPr>
+            <a:r>
+              <a:rPr lang="en-US" sz="1350" dirty="0">
+                <a:solidFill>
+                  <a:srgbClr val="8B8FB8"/>
+                </a:solidFill>
+                <a:latin typeface="Noto Sans KR" pitchFamily="34" charset="0"/>
+                <a:ea typeface="Noto Sans KR" pitchFamily="34" charset="-122"/>
+                <a:cs typeface="Noto Sans KR" pitchFamily="34" charset="-120"/>
+              </a:rPr>
+              <a:t>  — Task Role(S3 쓰기만) / Execution Role(ECR pull·로그) / Instance Role(ECS 등록)</a:t>
+            </a:r>
+            <a:pPr indent="0" marL="0">
+              <a:lnSpc>
+                <a:spcPct val="145000"/>
+              </a:lnSpc>
+              <a:buNone/>
+            </a:pPr>
+            <a:r>
+              <a:rPr lang="en-US" sz="1300" dirty="0">
+                <a:solidFill>
+                  <a:srgbClr val="000000"/>
+                </a:solidFill>
+                <a:latin typeface="Noto Sans KR" pitchFamily="34" charset="0"/>
+                <a:ea typeface="Noto Sans KR" pitchFamily="34" charset="-122"/>
+                <a:cs typeface="Noto Sans KR" pitchFamily="34" charset="-120"/>
+              </a:rPr>
+              <a:t>
+</a:t>
+            </a:r>
+            <a:pPr indent="0" marL="0">
+              <a:lnSpc>
+                <a:spcPct val="145000"/>
+              </a:lnSpc>
+              <a:buNone/>
+            </a:pPr>
+            <a:r>
+              <a:rPr lang="en-US" sz="1300" dirty="0">
+                <a:solidFill>
+                  <a:srgbClr val="22D3EE"/>
+                </a:solidFill>
+                <a:latin typeface="Noto Sans KR" pitchFamily="34" charset="0"/>
+                <a:ea typeface="Noto Sans KR" pitchFamily="34" charset="-122"/>
+                <a:cs typeface="Noto Sans KR" pitchFamily="34" charset="-120"/>
+              </a:rPr>
+              <a:t>◆ </a:t>
+            </a:r>
+            <a:pPr indent="0" marL="0">
+              <a:lnSpc>
+                <a:spcPct val="145000"/>
+              </a:lnSpc>
+              <a:buNone/>
+            </a:pPr>
+            <a:r>
+              <a:rPr lang="en-US" sz="1600" b="1" dirty="0">
+                <a:solidFill>
+                  <a:srgbClr val="E7E9FF"/>
+                </a:solidFill>
+                <a:latin typeface="Noto Sans KR" pitchFamily="34" charset="0"/>
+                <a:ea typeface="Noto Sans KR" pitchFamily="34" charset="-122"/>
+                <a:cs typeface="Noto Sans KR" pitchFamily="34" charset="-120"/>
+              </a:rPr>
+              <a:t>IAM 사용자도 최소 권한</a:t>
+            </a:r>
+            <a:pPr indent="0" marL="0">
+              <a:lnSpc>
+                <a:spcPct val="145000"/>
+              </a:lnSpc>
+              <a:buNone/>
+            </a:pPr>
+            <a:r>
+              <a:rPr lang="en-US" sz="1350" dirty="0">
+                <a:solidFill>
+                  <a:srgbClr val="8B8FB8"/>
+                </a:solidFill>
+                <a:latin typeface="Noto Sans KR" pitchFamily="34" charset="0"/>
+                <a:ea typeface="Noto Sans KR" pitchFamily="34" charset="-122"/>
+                <a:cs typeface="Noto Sans KR" pitchFamily="34" charset="-120"/>
+              </a:rPr>
+              <a:t>  — 필요한 액션만 명시한 정책 파일을 관리하며 점진적으로 요청</a:t>
+            </a:r>
+            <a:pPr indent="0" marL="0">
+              <a:lnSpc>
+                <a:spcPct val="145000"/>
+              </a:lnSpc>
+              <a:buNone/>
+            </a:pPr>
+            <a:r>
+              <a:rPr lang="en-US" sz="1300" dirty="0">
+                <a:solidFill>
+                  <a:srgbClr val="000000"/>
+                </a:solidFill>
+                <a:latin typeface="Noto Sans KR" pitchFamily="34" charset="0"/>
+                <a:ea typeface="Noto Sans KR" pitchFamily="34" charset="-122"/>
+                <a:cs typeface="Noto Sans KR" pitchFamily="34" charset="-120"/>
+              </a:rPr>
+              <a:t>
+</a:t>
+            </a:r>
+            <a:pPr indent="0" marL="0">
+              <a:lnSpc>
+                <a:spcPct val="145000"/>
+              </a:lnSpc>
+              <a:buNone/>
+            </a:pPr>
+            <a:r>
+              <a:rPr lang="en-US" sz="1300" dirty="0">
+                <a:solidFill>
+                  <a:srgbClr val="22D3EE"/>
+                </a:solidFill>
+                <a:latin typeface="Noto Sans KR" pitchFamily="34" charset="0"/>
+                <a:ea typeface="Noto Sans KR" pitchFamily="34" charset="-122"/>
+                <a:cs typeface="Noto Sans KR" pitchFamily="34" charset="-120"/>
+              </a:rPr>
+              <a:t>◆ </a:t>
+            </a:r>
+            <a:pPr indent="0" marL="0">
+              <a:lnSpc>
+                <a:spcPct val="145000"/>
+              </a:lnSpc>
+              <a:buNone/>
+            </a:pPr>
+            <a:r>
+              <a:rPr lang="en-US" sz="1600" b="1" dirty="0">
+                <a:solidFill>
+                  <a:srgbClr val="E7E9FF"/>
+                </a:solidFill>
+                <a:latin typeface="Noto Sans KR" pitchFamily="34" charset="0"/>
+                <a:ea typeface="Noto Sans KR" pitchFamily="34" charset="-122"/>
+                <a:cs typeface="Noto Sans KR" pitchFamily="34" charset="-120"/>
+              </a:rPr>
+              <a:t>예: CreateLoadBalancer의 숨은 의존 권한을 실패 → 분석 → 추가로 해결</a:t>
+            </a:r>
+            <a:pPr indent="0" marL="0">
+              <a:lnSpc>
+                <a:spcPct val="145000"/>
+              </a:lnSpc>
+              <a:buNone/>
+            </a:pPr>
+            <a:r>
+              <a:rPr lang="en-US" sz="1300" dirty="0">
+                <a:solidFill>
+                  <a:srgbClr val="000000"/>
+                </a:solidFill>
+                <a:latin typeface="Noto Sans KR" pitchFamily="34" charset="0"/>
+                <a:ea typeface="Noto Sans KR" pitchFamily="34" charset="-122"/>
+                <a:cs typeface="Noto Sans KR" pitchFamily="34" charset="-120"/>
+              </a:rPr>
+              <a:t>
+</a:t>
             </a:r>
             <a:endParaRPr lang="en-US" sz="1300" dirty="0"/>
-          </a:p>
-        </p:txBody>
-      </p:sp>
-      <p:sp>
-        <p:nvSpPr>
-          <p:cNvPr id="8" name="Text 5"/>
-          <p:cNvSpPr/>
-          <p:nvPr/>
-        </p:nvSpPr>
-        <p:spPr>
-          <a:xfrm>
-            <a:off x="868680" y="4983480"/>
-            <a:ext cx="10515600" cy="1051560"/>
-          </a:xfrm>
-          <a:prstGeom prst="rect">
-            <a:avLst/>
-          </a:prstGeom>
-          <a:noFill/>
-          <a:ln/>
-        </p:spPr>
-        <p:txBody>
-          <a:bodyPr wrap="square" rtlCol="0" anchor="t"/>
-          <a:lstStyle/>
-          <a:p>
-            <a:pPr indent="0" marL="0">
-              <a:lnSpc>
-                <a:spcPct val="135000"/>
-              </a:lnSpc>
-              <a:buNone/>
-            </a:pPr>
-            <a:r>
-              <a:rPr lang="en-US" sz="1450" dirty="0">
-                <a:solidFill>
-                  <a:srgbClr val="E7E9FF"/>
-                </a:solidFill>
-                <a:latin typeface="Noto Sans KR" pitchFamily="34" charset="0"/>
-                <a:ea typeface="Noto Sans KR" pitchFamily="34" charset="-122"/>
-                <a:cs typeface="Noto Sans KR" pitchFamily="34" charset="-120"/>
-              </a:rPr>
-              <a:t>베팅 라운드 종료 판정 누락(게임이 플랍을 못 봄) · 턴 타이머 TTL이 deadline과 동시 만료(auto-fold 불능) · 쇼다운 키커 무시(A페어=K페어 무승부) · 연결 끊김 시 유령 방 잔류</a:t>
-            </a:r>
-            <a:endParaRPr lang="en-US" sz="1450" dirty="0"/>
           </a:p>
         </p:txBody>
       </p:sp>
@@ -3298,7 +3565,7 @@
                 <a:ea typeface="Noto Sans KR" pitchFamily="34" charset="-122"/>
                 <a:cs typeface="Noto Sans KR" pitchFamily="34" charset="-120"/>
               </a:rPr>
-              <a:t>11 — DEMO (SCREENSHOTS)</a:t>
+              <a:t>11 — VERIFICATION</a:t>
             </a:r>
             <a:endParaRPr lang="en-US" sz="1300" dirty="0"/>
           </a:p>
@@ -3337,70 +3604,338 @@
                 <a:ea typeface="Noto Sans KR" pitchFamily="34" charset="-122"/>
                 <a:cs typeface="Noto Sans KR" pitchFamily="34" charset="-120"/>
               </a:rPr>
-              <a:t>게임 플레이</a:t>
+              <a:t>검증 — "되는 것 같다"가 아니라 증명</a:t>
             </a:r>
             <a:endParaRPr lang="en-US" sz="3000" dirty="0"/>
           </a:p>
         </p:txBody>
       </p:sp>
-      <p:pic>
-        <p:nvPicPr>
-          <p:cNvPr id="5" name="Image 0" descr="/home/dakori/github/cloud_holdem/docs/presentation/assets/lobby.png">    </p:cNvPr>
-          <p:cNvPicPr>
-            <a:picLocks noChangeAspect="1"/>
-          </p:cNvPicPr>
+      <p:sp>
+        <p:nvSpPr>
+          <p:cNvPr id="5" name="Text 2"/>
+          <p:cNvSpPr/>
           <p:nvPr/>
-        </p:nvPicPr>
-        <p:blipFill>
-          <a:blip r:embed="rId1"/>
-          <a:stretch>
-            <a:fillRect/>
-          </a:stretch>
-        </p:blipFill>
-        <p:spPr>
-          <a:xfrm>
-            <a:off x="640080" y="1554480"/>
-            <a:ext cx="5394960" cy="4639666"/>
+        </p:nvSpPr>
+        <p:spPr>
+          <a:xfrm>
+            <a:off x="640080" y="1645920"/>
+            <a:ext cx="10972800" cy="4572000"/>
           </a:xfrm>
           <a:prstGeom prst="rect">
             <a:avLst/>
           </a:prstGeom>
-        </p:spPr>
-      </p:pic>
-      <p:pic>
-        <p:nvPicPr>
-          <p:cNvPr id="6" name="Image 1" descr="/home/dakori/github/cloud_holdem/docs/presentation/assets/game-table.png">    </p:cNvPr>
-          <p:cNvPicPr>
-            <a:picLocks noChangeAspect="1"/>
-          </p:cNvPicPr>
+          <a:noFill/>
+          <a:ln/>
+        </p:spPr>
+        <p:txBody>
+          <a:bodyPr wrap="square" rtlCol="0" anchor="t"/>
+          <a:lstStyle/>
+          <a:p>
+            <a:pPr indent="0" marL="0">
+              <a:lnSpc>
+                <a:spcPct val="145000"/>
+              </a:lnSpc>
+              <a:buNone/>
+            </a:pPr>
+            <a:r>
+              <a:rPr lang="en-US" sz="1350" dirty="0">
+                <a:solidFill>
+                  <a:srgbClr val="22D3EE"/>
+                </a:solidFill>
+                <a:latin typeface="Noto Sans KR" pitchFamily="34" charset="0"/>
+                <a:ea typeface="Noto Sans KR" pitchFamily="34" charset="-122"/>
+                <a:cs typeface="Noto Sans KR" pitchFamily="34" charset="-120"/>
+              </a:rPr>
+              <a:t>◆ </a:t>
+            </a:r>
+            <a:pPr indent="0" marL="0">
+              <a:lnSpc>
+                <a:spcPct val="145000"/>
+              </a:lnSpc>
+              <a:buNone/>
+            </a:pPr>
+            <a:r>
+              <a:rPr lang="en-US" sz="1650" b="1" dirty="0">
+                <a:solidFill>
+                  <a:srgbClr val="E7E9FF"/>
+                </a:solidFill>
+                <a:latin typeface="Noto Sans KR" pitchFamily="34" charset="0"/>
+                <a:ea typeface="Noto Sans KR" pitchFamily="34" charset="-122"/>
+                <a:cs typeface="Noto Sans KR" pitchFamily="34" charset="-120"/>
+              </a:rPr>
+              <a:t>단위/통합 테스트 44개</a:t>
+            </a:r>
+            <a:pPr indent="0" marL="0">
+              <a:lnSpc>
+                <a:spcPct val="145000"/>
+              </a:lnSpc>
+              <a:buNone/>
+            </a:pPr>
+            <a:r>
+              <a:rPr lang="en-US" sz="1400" dirty="0">
+                <a:solidFill>
+                  <a:srgbClr val="8B8FB8"/>
+                </a:solidFill>
+                <a:latin typeface="Noto Sans KR" pitchFamily="34" charset="0"/>
+                <a:ea typeface="Noto Sans KR" pitchFamily="34" charset="-122"/>
+                <a:cs typeface="Noto Sans KR" pitchFamily="34" charset="-120"/>
+              </a:rPr>
+              <a:t>  — 게임 엔진, Redis 타이머, WS 연결 종료 처리</a:t>
+            </a:r>
+            <a:pPr indent="0" marL="0">
+              <a:lnSpc>
+                <a:spcPct val="145000"/>
+              </a:lnSpc>
+              <a:buNone/>
+            </a:pPr>
+            <a:r>
+              <a:rPr lang="en-US" sz="1350" dirty="0">
+                <a:solidFill>
+                  <a:srgbClr val="000000"/>
+                </a:solidFill>
+                <a:latin typeface="Noto Sans KR" pitchFamily="34" charset="0"/>
+                <a:ea typeface="Noto Sans KR" pitchFamily="34" charset="-122"/>
+                <a:cs typeface="Noto Sans KR" pitchFamily="34" charset="-120"/>
+              </a:rPr>
+              <a:t>
+</a:t>
+            </a:r>
+            <a:pPr indent="0" marL="0">
+              <a:lnSpc>
+                <a:spcPct val="145000"/>
+              </a:lnSpc>
+              <a:buNone/>
+            </a:pPr>
+            <a:r>
+              <a:rPr lang="en-US" sz="1350" dirty="0">
+                <a:solidFill>
+                  <a:srgbClr val="22D3EE"/>
+                </a:solidFill>
+                <a:latin typeface="Noto Sans KR" pitchFamily="34" charset="0"/>
+                <a:ea typeface="Noto Sans KR" pitchFamily="34" charset="-122"/>
+                <a:cs typeface="Noto Sans KR" pitchFamily="34" charset="-120"/>
+              </a:rPr>
+              <a:t>◆ </a:t>
+            </a:r>
+            <a:pPr indent="0" marL="0">
+              <a:lnSpc>
+                <a:spcPct val="145000"/>
+              </a:lnSpc>
+              <a:buNone/>
+            </a:pPr>
+            <a:r>
+              <a:rPr lang="en-US" sz="1650" b="1" dirty="0">
+                <a:solidFill>
+                  <a:srgbClr val="E7E9FF"/>
+                </a:solidFill>
+                <a:latin typeface="Noto Sans KR" pitchFamily="34" charset="0"/>
+                <a:ea typeface="Noto Sans KR" pitchFamily="34" charset="-122"/>
+                <a:cs typeface="Noto Sans KR" pitchFamily="34" charset="-120"/>
+              </a:rPr>
+              <a:t>로컬 E2E: 실제 브라우저 4개 자동 조작 → 풀 게임 완주 (Playwright)</a:t>
+            </a:r>
+            <a:pPr indent="0" marL="0">
+              <a:lnSpc>
+                <a:spcPct val="145000"/>
+              </a:lnSpc>
+              <a:buNone/>
+            </a:pPr>
+            <a:r>
+              <a:rPr lang="en-US" sz="1350" dirty="0">
+                <a:solidFill>
+                  <a:srgbClr val="000000"/>
+                </a:solidFill>
+                <a:latin typeface="Noto Sans KR" pitchFamily="34" charset="0"/>
+                <a:ea typeface="Noto Sans KR" pitchFamily="34" charset="-122"/>
+                <a:cs typeface="Noto Sans KR" pitchFamily="34" charset="-120"/>
+              </a:rPr>
+              <a:t>
+</a:t>
+            </a:r>
+            <a:pPr indent="0" marL="0">
+              <a:lnSpc>
+                <a:spcPct val="145000"/>
+              </a:lnSpc>
+              <a:buNone/>
+            </a:pPr>
+            <a:r>
+              <a:rPr lang="en-US" sz="1350" dirty="0">
+                <a:solidFill>
+                  <a:srgbClr val="22D3EE"/>
+                </a:solidFill>
+                <a:latin typeface="Noto Sans KR" pitchFamily="34" charset="0"/>
+                <a:ea typeface="Noto Sans KR" pitchFamily="34" charset="-122"/>
+                <a:cs typeface="Noto Sans KR" pitchFamily="34" charset="-120"/>
+              </a:rPr>
+              <a:t>◆ </a:t>
+            </a:r>
+            <a:pPr indent="0" marL="0">
+              <a:lnSpc>
+                <a:spcPct val="145000"/>
+              </a:lnSpc>
+              <a:buNone/>
+            </a:pPr>
+            <a:r>
+              <a:rPr lang="en-US" sz="1650" b="1" dirty="0">
+                <a:solidFill>
+                  <a:srgbClr val="E7E9FF"/>
+                </a:solidFill>
+                <a:latin typeface="Noto Sans KR" pitchFamily="34" charset="0"/>
+                <a:ea typeface="Noto Sans KR" pitchFamily="34" charset="-122"/>
+                <a:cs typeface="Noto Sans KR" pitchFamily="34" charset="-120"/>
+              </a:rPr>
+              <a:t>프로덕션 E2E: ALB 경유 4클라이언트 → 멀티 태스크 분산 환경에서 쇼다운까지</a:t>
+            </a:r>
+            <a:pPr indent="0" marL="0">
+              <a:lnSpc>
+                <a:spcPct val="145000"/>
+              </a:lnSpc>
+              <a:buNone/>
+            </a:pPr>
+            <a:r>
+              <a:rPr lang="en-US" sz="1350" dirty="0">
+                <a:solidFill>
+                  <a:srgbClr val="000000"/>
+                </a:solidFill>
+                <a:latin typeface="Noto Sans KR" pitchFamily="34" charset="0"/>
+                <a:ea typeface="Noto Sans KR" pitchFamily="34" charset="-122"/>
+                <a:cs typeface="Noto Sans KR" pitchFamily="34" charset="-120"/>
+              </a:rPr>
+              <a:t>
+</a:t>
+            </a:r>
+            <a:pPr indent="0" marL="0">
+              <a:lnSpc>
+                <a:spcPct val="145000"/>
+              </a:lnSpc>
+              <a:buNone/>
+            </a:pPr>
+            <a:r>
+              <a:rPr lang="en-US" sz="1350" dirty="0">
+                <a:solidFill>
+                  <a:srgbClr val="22D3EE"/>
+                </a:solidFill>
+                <a:latin typeface="Noto Sans KR" pitchFamily="34" charset="0"/>
+                <a:ea typeface="Noto Sans KR" pitchFamily="34" charset="-122"/>
+                <a:cs typeface="Noto Sans KR" pitchFamily="34" charset="-120"/>
+              </a:rPr>
+              <a:t>◆ </a:t>
+            </a:r>
+            <a:pPr indent="0" marL="0">
+              <a:lnSpc>
+                <a:spcPct val="145000"/>
+              </a:lnSpc>
+              <a:buNone/>
+            </a:pPr>
+            <a:r>
+              <a:rPr lang="en-US" sz="1650" b="1" dirty="0">
+                <a:solidFill>
+                  <a:srgbClr val="E7E9FF"/>
+                </a:solidFill>
+                <a:latin typeface="Noto Sans KR" pitchFamily="34" charset="0"/>
+                <a:ea typeface="Noto Sans KR" pitchFamily="34" charset="-122"/>
+                <a:cs typeface="Noto Sans KR" pitchFamily="34" charset="-120"/>
+              </a:rPr>
+              <a:t>ALB 헬스체크 OK · 타깃 2/2 healthy · 롤링 배포 무중단 확인</a:t>
+            </a:r>
+            <a:pPr indent="0" marL="0">
+              <a:lnSpc>
+                <a:spcPct val="145000"/>
+              </a:lnSpc>
+              <a:buNone/>
+            </a:pPr>
+            <a:r>
+              <a:rPr lang="en-US" sz="1350" dirty="0">
+                <a:solidFill>
+                  <a:srgbClr val="000000"/>
+                </a:solidFill>
+                <a:latin typeface="Noto Sans KR" pitchFamily="34" charset="0"/>
+                <a:ea typeface="Noto Sans KR" pitchFamily="34" charset="-122"/>
+                <a:cs typeface="Noto Sans KR" pitchFamily="34" charset="-120"/>
+              </a:rPr>
+              <a:t>
+</a:t>
+            </a:r>
+            <a:endParaRPr lang="en-US" sz="1350" dirty="0"/>
+          </a:p>
+        </p:txBody>
+      </p:sp>
+      <p:sp>
+        <p:nvSpPr>
+          <p:cNvPr id="6" name="Shape 3"/>
+          <p:cNvSpPr/>
           <p:nvPr/>
-        </p:nvPicPr>
-        <p:blipFill>
-          <a:blip r:embed="rId2"/>
-          <a:stretch>
-            <a:fillRect/>
-          </a:stretch>
-        </p:blipFill>
-        <p:spPr>
-          <a:xfrm>
-            <a:off x="6309360" y="1554480"/>
-            <a:ext cx="5074920" cy="4653702"/>
+        </p:nvSpPr>
+        <p:spPr>
+          <a:xfrm>
+            <a:off x="640080" y="4480560"/>
+            <a:ext cx="10972800" cy="1737360"/>
+          </a:xfrm>
+          <a:prstGeom prst="roundRect">
+            <a:avLst>
+              <a:gd name="adj" fmla="val 6316"/>
+            </a:avLst>
+          </a:prstGeom>
+          <a:solidFill>
+            <a:srgbClr val="111120"/>
+          </a:solidFill>
+          <a:ln w="12700">
+            <a:solidFill>
+              <a:srgbClr val="F59E0B"/>
+            </a:solidFill>
+            <a:prstDash val="solid"/>
+          </a:ln>
+        </p:spPr>
+      </p:sp>
+      <p:sp>
+        <p:nvSpPr>
+          <p:cNvPr id="7" name="Text 4"/>
+          <p:cNvSpPr/>
+          <p:nvPr/>
+        </p:nvSpPr>
+        <p:spPr>
+          <a:xfrm>
+            <a:off x="868680" y="4617720"/>
+            <a:ext cx="10515600" cy="365760"/>
           </a:xfrm>
           <a:prstGeom prst="rect">
             <a:avLst/>
           </a:prstGeom>
-        </p:spPr>
-      </p:pic>
-      <p:sp>
-        <p:nvSpPr>
-          <p:cNvPr id="7" name="Text 2"/>
+          <a:noFill/>
+          <a:ln/>
+        </p:spPr>
+        <p:txBody>
+          <a:bodyPr wrap="square" rtlCol="0" anchor="ctr"/>
+          <a:lstStyle/>
+          <a:p>
+            <a:pPr indent="0" marL="0">
+              <a:buNone/>
+            </a:pPr>
+            <a:r>
+              <a:rPr lang="en-US" sz="1300" b="1" spc="200" kern="0" dirty="0">
+                <a:solidFill>
+                  <a:srgbClr val="F59E0B"/>
+                </a:solidFill>
+                <a:latin typeface="Noto Sans KR" pitchFamily="34" charset="0"/>
+                <a:ea typeface="Noto Sans KR" pitchFamily="34" charset="-122"/>
+                <a:cs typeface="Noto Sans KR" pitchFamily="34" charset="-120"/>
+              </a:rPr>
+              <a:t>TDD로 잡은 실제 버그들</a:t>
+            </a:r>
+            <a:endParaRPr lang="en-US" sz="1300" dirty="0"/>
+          </a:p>
+        </p:txBody>
+      </p:sp>
+      <p:sp>
+        <p:nvSpPr>
+          <p:cNvPr id="8" name="Text 5"/>
           <p:cNvSpPr/>
           <p:nvPr/>
         </p:nvSpPr>
         <p:spPr>
           <a:xfrm>
-            <a:off x="640080" y="6400800"/>
-            <a:ext cx="10972800" cy="365760"/>
+            <a:off x="868680" y="4983480"/>
+            <a:ext cx="10515600" cy="1051560"/>
           </a:xfrm>
           <a:prstGeom prst="rect">
             <a:avLst/>
@@ -3409,24 +3944,27 @@
           <a:ln/>
         </p:spPr>
         <p:txBody>
-          <a:bodyPr wrap="square" rtlCol="0" anchor="ctr"/>
-          <a:lstStyle/>
-          <a:p>
-            <a:pPr algn="ctr" indent="0" marL="0">
-              <a:buNone/>
-            </a:pPr>
-            <a:r>
-              <a:rPr lang="en-US" sz="1300" dirty="0">
-                <a:solidFill>
-                  <a:srgbClr val="8B8FB8"/>
-                </a:solidFill>
-                <a:latin typeface="Noto Sans KR" pitchFamily="34" charset="0"/>
-                <a:ea typeface="Noto Sans KR" pitchFamily="34" charset="-122"/>
-                <a:cs typeface="Noto Sans KR" pitchFamily="34" charset="-120"/>
-              </a:rPr>
-              <a:t>로비(방 생성/입장) → 4인 자동 시작 → 블라인드/베팅 → 쇼다운 → 칩 정산 후 다음 핸드</a:t>
-            </a:r>
-            <a:endParaRPr lang="en-US" sz="1300" dirty="0"/>
+          <a:bodyPr wrap="square" rtlCol="0" anchor="t"/>
+          <a:lstStyle/>
+          <a:p>
+            <a:pPr indent="0" marL="0">
+              <a:lnSpc>
+                <a:spcPct val="135000"/>
+              </a:lnSpc>
+              <a:buNone/>
+            </a:pPr>
+            <a:r>
+              <a:rPr lang="en-US" sz="1450" dirty="0">
+                <a:solidFill>
+                  <a:srgbClr val="E7E9FF"/>
+                </a:solidFill>
+                <a:latin typeface="Noto Sans KR" pitchFamily="34" charset="0"/>
+                <a:ea typeface="Noto Sans KR" pitchFamily="34" charset="-122"/>
+                <a:cs typeface="Noto Sans KR" pitchFamily="34" charset="-120"/>
+              </a:rPr>
+              <a:t>베팅 라운드 종료 판정 누락(게임이 플랍을 못 봄) · 턴 타이머 TTL이 deadline과 동시 만료(auto-fold 불능) · 쇼다운 키커 무시(A페어=K페어 무승부) · 연결 끊김 시 유령 방 잔류</a:t>
+            </a:r>
+            <a:endParaRPr lang="en-US" sz="1450" dirty="0"/>
           </a:p>
         </p:txBody>
       </p:sp>
@@ -3495,7 +4033,7 @@
                 <a:ea typeface="Noto Sans KR" pitchFamily="34" charset="-122"/>
                 <a:cs typeface="Noto Sans KR" pitchFamily="34" charset="-120"/>
               </a:rPr>
-              <a:t>11 — LIVE DEMO</a:t>
+              <a:t>12 — DEMO (SCREENSHOTS)</a:t>
             </a:r>
             <a:endParaRPr lang="en-US" sz="1300" dirty="0"/>
           </a:p>
@@ -3534,42 +4072,70 @@
                 <a:ea typeface="Noto Sans KR" pitchFamily="34" charset="-122"/>
                 <a:cs typeface="Noto Sans KR" pitchFamily="34" charset="-120"/>
               </a:rPr>
-              <a:t>라이브 데모 🔴</a:t>
+              <a:t>게임 플레이</a:t>
             </a:r>
             <a:endParaRPr lang="en-US" sz="3000" dirty="0"/>
           </a:p>
         </p:txBody>
       </p:sp>
-      <p:sp>
-        <p:nvSpPr>
-          <p:cNvPr id="5" name="Shape 2"/>
+      <p:pic>
+        <p:nvPicPr>
+          <p:cNvPr id="5" name="Image 0" descr="/home/dakori/github/cloud_holdem/docs/presentation/assets/lobby.png">    </p:cNvPr>
+          <p:cNvPicPr>
+            <a:picLocks noChangeAspect="1"/>
+          </p:cNvPicPr>
+          <p:nvPr/>
+        </p:nvPicPr>
+        <p:blipFill>
+          <a:blip r:embed="rId1"/>
+          <a:stretch>
+            <a:fillRect/>
+          </a:stretch>
+        </p:blipFill>
+        <p:spPr>
+          <a:xfrm>
+            <a:off x="640080" y="1554480"/>
+            <a:ext cx="5394960" cy="4639666"/>
+          </a:xfrm>
+          <a:prstGeom prst="rect">
+            <a:avLst/>
+          </a:prstGeom>
+        </p:spPr>
+      </p:pic>
+      <p:pic>
+        <p:nvPicPr>
+          <p:cNvPr id="6" name="Image 1" descr="/home/dakori/github/cloud_holdem/docs/presentation/assets/game-table.png">    </p:cNvPr>
+          <p:cNvPicPr>
+            <a:picLocks noChangeAspect="1"/>
+          </p:cNvPicPr>
+          <p:nvPr/>
+        </p:nvPicPr>
+        <p:blipFill>
+          <a:blip r:embed="rId2"/>
+          <a:stretch>
+            <a:fillRect/>
+          </a:stretch>
+        </p:blipFill>
+        <p:spPr>
+          <a:xfrm>
+            <a:off x="6309360" y="1554480"/>
+            <a:ext cx="5074920" cy="4653702"/>
+          </a:xfrm>
+          <a:prstGeom prst="rect">
+            <a:avLst/>
+          </a:prstGeom>
+        </p:spPr>
+      </p:pic>
+      <p:sp>
+        <p:nvSpPr>
+          <p:cNvPr id="7" name="Text 2"/>
           <p:cNvSpPr/>
           <p:nvPr/>
         </p:nvSpPr>
         <p:spPr>
           <a:xfrm>
-            <a:off x="640080" y="1600200"/>
-            <a:ext cx="457200" cy="457200"/>
-          </a:xfrm>
-          <a:prstGeom prst="ellipse">
-            <a:avLst/>
-          </a:prstGeom>
-          <a:solidFill>
-            <a:srgbClr val="7C3AED"/>
-          </a:solidFill>
-          <a:ln/>
-        </p:spPr>
-      </p:sp>
-      <p:sp>
-        <p:nvSpPr>
-          <p:cNvPr id="6" name="Text 3"/>
-          <p:cNvSpPr/>
-          <p:nvPr/>
-        </p:nvSpPr>
-        <p:spPr>
-          <a:xfrm>
-            <a:off x="640080" y="1600200"/>
-            <a:ext cx="457200" cy="457200"/>
+            <a:off x="640080" y="6400800"/>
+            <a:ext cx="10972800" cy="365760"/>
           </a:xfrm>
           <a:prstGeom prst="rect">
             <a:avLst/>
@@ -3585,754 +4151,17 @@
               <a:buNone/>
             </a:pPr>
             <a:r>
-              <a:rPr lang="en-US" sz="1500" b="1" dirty="0">
-                <a:solidFill>
-                  <a:srgbClr val="FFFFFF"/>
-                </a:solidFill>
-              </a:rPr>
-              <a:t>1</a:t>
-            </a:r>
-            <a:endParaRPr lang="en-US" sz="1500" dirty="0"/>
-          </a:p>
-        </p:txBody>
-      </p:sp>
-      <p:sp>
-        <p:nvSpPr>
-          <p:cNvPr id="7" name="Text 4"/>
-          <p:cNvSpPr/>
-          <p:nvPr/>
-        </p:nvSpPr>
-        <p:spPr>
-          <a:xfrm>
-            <a:off x="1280160" y="1600200"/>
-            <a:ext cx="5120640" cy="548640"/>
-          </a:xfrm>
-          <a:prstGeom prst="rect">
-            <a:avLst/>
-          </a:prstGeom>
-          <a:noFill/>
-          <a:ln/>
-        </p:spPr>
-        <p:txBody>
-          <a:bodyPr wrap="square" rtlCol="0" anchor="ctr"/>
-          <a:lstStyle/>
-          <a:p>
-            <a:pPr indent="0" marL="0">
-              <a:buNone/>
-            </a:pPr>
-            <a:r>
-              <a:rPr lang="en-US" sz="1550" dirty="0">
-                <a:solidFill>
-                  <a:srgbClr val="E7E9FF"/>
-                </a:solidFill>
-                <a:latin typeface="Noto Sans KR" pitchFamily="34" charset="0"/>
-                <a:ea typeface="Noto Sans KR" pitchFamily="34" charset="-122"/>
-                <a:cs typeface="Noto Sans KR" pitchFamily="34" charset="-120"/>
-              </a:rPr>
-              <a:t>브라우저 탭 4개로 접속 (시크릿 창 혼용)</a:t>
-            </a:r>
-            <a:endParaRPr lang="en-US" sz="1550" dirty="0"/>
-          </a:p>
-        </p:txBody>
-      </p:sp>
-      <p:sp>
-        <p:nvSpPr>
-          <p:cNvPr id="8" name="Shape 5"/>
-          <p:cNvSpPr/>
-          <p:nvPr/>
-        </p:nvSpPr>
-        <p:spPr>
-          <a:xfrm>
-            <a:off x="640080" y="2350008"/>
-            <a:ext cx="457200" cy="457200"/>
-          </a:xfrm>
-          <a:prstGeom prst="ellipse">
-            <a:avLst/>
-          </a:prstGeom>
-          <a:solidFill>
-            <a:srgbClr val="7C3AED"/>
-          </a:solidFill>
-          <a:ln/>
-        </p:spPr>
-      </p:sp>
-      <p:sp>
-        <p:nvSpPr>
-          <p:cNvPr id="9" name="Text 6"/>
-          <p:cNvSpPr/>
-          <p:nvPr/>
-        </p:nvSpPr>
-        <p:spPr>
-          <a:xfrm>
-            <a:off x="640080" y="2350008"/>
-            <a:ext cx="457200" cy="457200"/>
-          </a:xfrm>
-          <a:prstGeom prst="rect">
-            <a:avLst/>
-          </a:prstGeom>
-          <a:noFill/>
-          <a:ln/>
-        </p:spPr>
-        <p:txBody>
-          <a:bodyPr wrap="square" rtlCol="0" anchor="ctr"/>
-          <a:lstStyle/>
-          <a:p>
-            <a:pPr algn="ctr" indent="0" marL="0">
-              <a:buNone/>
-            </a:pPr>
-            <a:r>
-              <a:rPr lang="en-US" sz="1500" b="1" dirty="0">
-                <a:solidFill>
-                  <a:srgbClr val="FFFFFF"/>
-                </a:solidFill>
-              </a:rPr>
-              <a:t>2</a:t>
-            </a:r>
-            <a:endParaRPr lang="en-US" sz="1500" dirty="0"/>
-          </a:p>
-        </p:txBody>
-      </p:sp>
-      <p:sp>
-        <p:nvSpPr>
-          <p:cNvPr id="10" name="Text 7"/>
-          <p:cNvSpPr/>
-          <p:nvPr/>
-        </p:nvSpPr>
-        <p:spPr>
-          <a:xfrm>
-            <a:off x="1280160" y="2350008"/>
-            <a:ext cx="5120640" cy="548640"/>
-          </a:xfrm>
-          <a:prstGeom prst="rect">
-            <a:avLst/>
-          </a:prstGeom>
-          <a:noFill/>
-          <a:ln/>
-        </p:spPr>
-        <p:txBody>
-          <a:bodyPr wrap="square" rtlCol="0" anchor="ctr"/>
-          <a:lstStyle/>
-          <a:p>
-            <a:pPr indent="0" marL="0">
-              <a:buNone/>
-            </a:pPr>
-            <a:r>
-              <a:rPr lang="en-US" sz="1550" dirty="0">
-                <a:solidFill>
-                  <a:srgbClr val="E7E9FF"/>
-                </a:solidFill>
-                <a:latin typeface="Noto Sans KR" pitchFamily="34" charset="0"/>
-                <a:ea typeface="Noto Sans KR" pitchFamily="34" charset="-122"/>
-                <a:cs typeface="Noto Sans KR" pitchFamily="34" charset="-120"/>
-              </a:rPr>
-              <a:t>탭1: 닉네임 입력 → 방 만들기</a:t>
-            </a:r>
-            <a:endParaRPr lang="en-US" sz="1550" dirty="0"/>
-          </a:p>
-        </p:txBody>
-      </p:sp>
-      <p:sp>
-        <p:nvSpPr>
-          <p:cNvPr id="11" name="Shape 8"/>
-          <p:cNvSpPr/>
-          <p:nvPr/>
-        </p:nvSpPr>
-        <p:spPr>
-          <a:xfrm>
-            <a:off x="640080" y="3099816"/>
-            <a:ext cx="457200" cy="457200"/>
-          </a:xfrm>
-          <a:prstGeom prst="ellipse">
-            <a:avLst/>
-          </a:prstGeom>
-          <a:solidFill>
-            <a:srgbClr val="7C3AED"/>
-          </a:solidFill>
-          <a:ln/>
-        </p:spPr>
-      </p:sp>
-      <p:sp>
-        <p:nvSpPr>
-          <p:cNvPr id="12" name="Text 9"/>
-          <p:cNvSpPr/>
-          <p:nvPr/>
-        </p:nvSpPr>
-        <p:spPr>
-          <a:xfrm>
-            <a:off x="640080" y="3099816"/>
-            <a:ext cx="457200" cy="457200"/>
-          </a:xfrm>
-          <a:prstGeom prst="rect">
-            <a:avLst/>
-          </a:prstGeom>
-          <a:noFill/>
-          <a:ln/>
-        </p:spPr>
-        <p:txBody>
-          <a:bodyPr wrap="square" rtlCol="0" anchor="ctr"/>
-          <a:lstStyle/>
-          <a:p>
-            <a:pPr algn="ctr" indent="0" marL="0">
-              <a:buNone/>
-            </a:pPr>
-            <a:r>
-              <a:rPr lang="en-US" sz="1500" b="1" dirty="0">
-                <a:solidFill>
-                  <a:srgbClr val="FFFFFF"/>
-                </a:solidFill>
-              </a:rPr>
-              <a:t>3</a:t>
-            </a:r>
-            <a:endParaRPr lang="en-US" sz="1500" dirty="0"/>
-          </a:p>
-        </p:txBody>
-      </p:sp>
-      <p:sp>
-        <p:nvSpPr>
-          <p:cNvPr id="13" name="Text 10"/>
-          <p:cNvSpPr/>
-          <p:nvPr/>
-        </p:nvSpPr>
-        <p:spPr>
-          <a:xfrm>
-            <a:off x="1280160" y="3099816"/>
-            <a:ext cx="5120640" cy="548640"/>
-          </a:xfrm>
-          <a:prstGeom prst="rect">
-            <a:avLst/>
-          </a:prstGeom>
-          <a:noFill/>
-          <a:ln/>
-        </p:spPr>
-        <p:txBody>
-          <a:bodyPr wrap="square" rtlCol="0" anchor="ctr"/>
-          <a:lstStyle/>
-          <a:p>
-            <a:pPr indent="0" marL="0">
-              <a:buNone/>
-            </a:pPr>
-            <a:r>
-              <a:rPr lang="en-US" sz="1550" dirty="0">
-                <a:solidFill>
-                  <a:srgbClr val="E7E9FF"/>
-                </a:solidFill>
-                <a:latin typeface="Noto Sans KR" pitchFamily="34" charset="0"/>
-                <a:ea typeface="Noto Sans KR" pitchFamily="34" charset="-122"/>
-                <a:cs typeface="Noto Sans KR" pitchFamily="34" charset="-120"/>
-              </a:rPr>
-              <a:t>탭2~4: 같은 방 입장 → 5초 카운트다운</a:t>
-            </a:r>
-            <a:endParaRPr lang="en-US" sz="1550" dirty="0"/>
-          </a:p>
-        </p:txBody>
-      </p:sp>
-      <p:sp>
-        <p:nvSpPr>
-          <p:cNvPr id="14" name="Shape 11"/>
-          <p:cNvSpPr/>
-          <p:nvPr/>
-        </p:nvSpPr>
-        <p:spPr>
-          <a:xfrm>
-            <a:off x="640080" y="3849624"/>
-            <a:ext cx="457200" cy="457200"/>
-          </a:xfrm>
-          <a:prstGeom prst="ellipse">
-            <a:avLst/>
-          </a:prstGeom>
-          <a:solidFill>
-            <a:srgbClr val="7C3AED"/>
-          </a:solidFill>
-          <a:ln/>
-        </p:spPr>
-      </p:sp>
-      <p:sp>
-        <p:nvSpPr>
-          <p:cNvPr id="15" name="Text 12"/>
-          <p:cNvSpPr/>
-          <p:nvPr/>
-        </p:nvSpPr>
-        <p:spPr>
-          <a:xfrm>
-            <a:off x="640080" y="3849624"/>
-            <a:ext cx="457200" cy="457200"/>
-          </a:xfrm>
-          <a:prstGeom prst="rect">
-            <a:avLst/>
-          </a:prstGeom>
-          <a:noFill/>
-          <a:ln/>
-        </p:spPr>
-        <p:txBody>
-          <a:bodyPr wrap="square" rtlCol="0" anchor="ctr"/>
-          <a:lstStyle/>
-          <a:p>
-            <a:pPr algn="ctr" indent="0" marL="0">
-              <a:buNone/>
-            </a:pPr>
-            <a:r>
-              <a:rPr lang="en-US" sz="1500" b="1" dirty="0">
-                <a:solidFill>
-                  <a:srgbClr val="FFFFFF"/>
-                </a:solidFill>
-              </a:rPr>
-              <a:t>4</a:t>
-            </a:r>
-            <a:endParaRPr lang="en-US" sz="1500" dirty="0"/>
-          </a:p>
-        </p:txBody>
-      </p:sp>
-      <p:sp>
-        <p:nvSpPr>
-          <p:cNvPr id="16" name="Text 13"/>
-          <p:cNvSpPr/>
-          <p:nvPr/>
-        </p:nvSpPr>
-        <p:spPr>
-          <a:xfrm>
-            <a:off x="1280160" y="3849624"/>
-            <a:ext cx="5120640" cy="548640"/>
-          </a:xfrm>
-          <a:prstGeom prst="rect">
-            <a:avLst/>
-          </a:prstGeom>
-          <a:noFill/>
-          <a:ln/>
-        </p:spPr>
-        <p:txBody>
-          <a:bodyPr wrap="square" rtlCol="0" anchor="ctr"/>
-          <a:lstStyle/>
-          <a:p>
-            <a:pPr indent="0" marL="0">
-              <a:buNone/>
-            </a:pPr>
-            <a:r>
-              <a:rPr lang="en-US" sz="1550" dirty="0">
-                <a:solidFill>
-                  <a:srgbClr val="E7E9FF"/>
-                </a:solidFill>
-                <a:latin typeface="Noto Sans KR" pitchFamily="34" charset="0"/>
-                <a:ea typeface="Noto Sans KR" pitchFamily="34" charset="-122"/>
-                <a:cs typeface="Noto Sans KR" pitchFamily="34" charset="-120"/>
-              </a:rPr>
-              <a:t>베팅 한 바퀴 (콜/체크로 빠르게) → 플랍 공개</a:t>
-            </a:r>
-            <a:endParaRPr lang="en-US" sz="1550" dirty="0"/>
-          </a:p>
-        </p:txBody>
-      </p:sp>
-      <p:sp>
-        <p:nvSpPr>
-          <p:cNvPr id="17" name="Shape 14"/>
-          <p:cNvSpPr/>
-          <p:nvPr/>
-        </p:nvSpPr>
-        <p:spPr>
-          <a:xfrm>
-            <a:off x="640080" y="4599432"/>
-            <a:ext cx="457200" cy="457200"/>
-          </a:xfrm>
-          <a:prstGeom prst="ellipse">
-            <a:avLst/>
-          </a:prstGeom>
-          <a:solidFill>
-            <a:srgbClr val="7C3AED"/>
-          </a:solidFill>
-          <a:ln/>
-        </p:spPr>
-      </p:sp>
-      <p:sp>
-        <p:nvSpPr>
-          <p:cNvPr id="18" name="Text 15"/>
-          <p:cNvSpPr/>
-          <p:nvPr/>
-        </p:nvSpPr>
-        <p:spPr>
-          <a:xfrm>
-            <a:off x="640080" y="4599432"/>
-            <a:ext cx="457200" cy="457200"/>
-          </a:xfrm>
-          <a:prstGeom prst="rect">
-            <a:avLst/>
-          </a:prstGeom>
-          <a:noFill/>
-          <a:ln/>
-        </p:spPr>
-        <p:txBody>
-          <a:bodyPr wrap="square" rtlCol="0" anchor="ctr"/>
-          <a:lstStyle/>
-          <a:p>
-            <a:pPr algn="ctr" indent="0" marL="0">
-              <a:buNone/>
-            </a:pPr>
-            <a:r>
-              <a:rPr lang="en-US" sz="1500" b="1" dirty="0">
-                <a:solidFill>
-                  <a:srgbClr val="FFFFFF"/>
-                </a:solidFill>
-              </a:rPr>
-              <a:t>5</a:t>
-            </a:r>
-            <a:endParaRPr lang="en-US" sz="1500" dirty="0"/>
-          </a:p>
-        </p:txBody>
-      </p:sp>
-      <p:sp>
-        <p:nvSpPr>
-          <p:cNvPr id="19" name="Text 16"/>
-          <p:cNvSpPr/>
-          <p:nvPr/>
-        </p:nvSpPr>
-        <p:spPr>
-          <a:xfrm>
-            <a:off x="1280160" y="4599432"/>
-            <a:ext cx="5120640" cy="548640"/>
-          </a:xfrm>
-          <a:prstGeom prst="rect">
-            <a:avLst/>
-          </a:prstGeom>
-          <a:noFill/>
-          <a:ln/>
-        </p:spPr>
-        <p:txBody>
-          <a:bodyPr wrap="square" rtlCol="0" anchor="ctr"/>
-          <a:lstStyle/>
-          <a:p>
-            <a:pPr indent="0" marL="0">
-              <a:buNone/>
-            </a:pPr>
-            <a:r>
-              <a:rPr lang="en-US" sz="1550" dirty="0">
-                <a:solidFill>
-                  <a:srgbClr val="E7E9FF"/>
-                </a:solidFill>
-                <a:latin typeface="Noto Sans KR" pitchFamily="34" charset="0"/>
-                <a:ea typeface="Noto Sans KR" pitchFamily="34" charset="-122"/>
-                <a:cs typeface="Noto Sans KR" pitchFamily="34" charset="-120"/>
-              </a:rPr>
-              <a:t>탭 하나 방치 → 20초 auto-fold 시연</a:t>
-            </a:r>
-            <a:endParaRPr lang="en-US" sz="1550" dirty="0"/>
-          </a:p>
-        </p:txBody>
-      </p:sp>
-      <p:sp>
-        <p:nvSpPr>
-          <p:cNvPr id="20" name="Shape 17"/>
-          <p:cNvSpPr/>
-          <p:nvPr/>
-        </p:nvSpPr>
-        <p:spPr>
-          <a:xfrm>
-            <a:off x="640080" y="5349240"/>
-            <a:ext cx="457200" cy="457200"/>
-          </a:xfrm>
-          <a:prstGeom prst="ellipse">
-            <a:avLst/>
-          </a:prstGeom>
-          <a:solidFill>
-            <a:srgbClr val="7C3AED"/>
-          </a:solidFill>
-          <a:ln/>
-        </p:spPr>
-      </p:sp>
-      <p:sp>
-        <p:nvSpPr>
-          <p:cNvPr id="21" name="Text 18"/>
-          <p:cNvSpPr/>
-          <p:nvPr/>
-        </p:nvSpPr>
-        <p:spPr>
-          <a:xfrm>
-            <a:off x="640080" y="5349240"/>
-            <a:ext cx="457200" cy="457200"/>
-          </a:xfrm>
-          <a:prstGeom prst="rect">
-            <a:avLst/>
-          </a:prstGeom>
-          <a:noFill/>
-          <a:ln/>
-        </p:spPr>
-        <p:txBody>
-          <a:bodyPr wrap="square" rtlCol="0" anchor="ctr"/>
-          <a:lstStyle/>
-          <a:p>
-            <a:pPr algn="ctr" indent="0" marL="0">
-              <a:buNone/>
-            </a:pPr>
-            <a:r>
-              <a:rPr lang="en-US" sz="1500" b="1" dirty="0">
-                <a:solidFill>
-                  <a:srgbClr val="FFFFFF"/>
-                </a:solidFill>
-              </a:rPr>
-              <a:t>6</a:t>
-            </a:r>
-            <a:endParaRPr lang="en-US" sz="1500" dirty="0"/>
-          </a:p>
-        </p:txBody>
-      </p:sp>
-      <p:sp>
-        <p:nvSpPr>
-          <p:cNvPr id="22" name="Text 19"/>
-          <p:cNvSpPr/>
-          <p:nvPr/>
-        </p:nvSpPr>
-        <p:spPr>
-          <a:xfrm>
-            <a:off x="1280160" y="5349240"/>
-            <a:ext cx="5120640" cy="548640"/>
-          </a:xfrm>
-          <a:prstGeom prst="rect">
-            <a:avLst/>
-          </a:prstGeom>
-          <a:noFill/>
-          <a:ln/>
-        </p:spPr>
-        <p:txBody>
-          <a:bodyPr wrap="square" rtlCol="0" anchor="ctr"/>
-          <a:lstStyle/>
-          <a:p>
-            <a:pPr indent="0" marL="0">
-              <a:buNone/>
-            </a:pPr>
-            <a:r>
-              <a:rPr lang="en-US" sz="1550" dirty="0">
-                <a:solidFill>
-                  <a:srgbClr val="E7E9FF"/>
-                </a:solidFill>
-                <a:latin typeface="Noto Sans KR" pitchFamily="34" charset="0"/>
-                <a:ea typeface="Noto Sans KR" pitchFamily="34" charset="-122"/>
-                <a:cs typeface="Noto Sans KR" pitchFamily="34" charset="-120"/>
-              </a:rPr>
-              <a:t>쇼다운 → 칩 정산 → 다음 핸드 자동 시작</a:t>
-            </a:r>
-            <a:endParaRPr lang="en-US" sz="1550" dirty="0"/>
-          </a:p>
-        </p:txBody>
-      </p:sp>
-      <p:sp>
-        <p:nvSpPr>
-          <p:cNvPr id="23" name="Shape 20"/>
-          <p:cNvSpPr/>
-          <p:nvPr/>
-        </p:nvSpPr>
-        <p:spPr>
-          <a:xfrm>
-            <a:off x="6766560" y="1600200"/>
-            <a:ext cx="4846320" cy="4480560"/>
-          </a:xfrm>
-          <a:prstGeom prst="roundRect">
-            <a:avLst>
-              <a:gd name="adj" fmla="val 2449"/>
-            </a:avLst>
-          </a:prstGeom>
-          <a:solidFill>
-            <a:srgbClr val="111120"/>
-          </a:solidFill>
-          <a:ln w="12700">
-            <a:solidFill>
-              <a:srgbClr val="22D3EE"/>
-            </a:solidFill>
-            <a:prstDash val="solid"/>
-          </a:ln>
-        </p:spPr>
-      </p:sp>
-      <p:sp>
-        <p:nvSpPr>
-          <p:cNvPr id="24" name="Text 21"/>
-          <p:cNvSpPr/>
-          <p:nvPr/>
-        </p:nvSpPr>
-        <p:spPr>
-          <a:xfrm>
-            <a:off x="6995160" y="1737360"/>
-            <a:ext cx="4389120" cy="365760"/>
-          </a:xfrm>
-          <a:prstGeom prst="rect">
-            <a:avLst/>
-          </a:prstGeom>
-          <a:noFill/>
-          <a:ln/>
-        </p:spPr>
-        <p:txBody>
-          <a:bodyPr wrap="square" rtlCol="0" anchor="ctr"/>
-          <a:lstStyle/>
-          <a:p>
-            <a:pPr indent="0" marL="0">
-              <a:buNone/>
-            </a:pPr>
-            <a:r>
-              <a:rPr lang="en-US" sz="1300" b="1" spc="200" kern="0" dirty="0">
-                <a:solidFill>
-                  <a:srgbClr val="22D3EE"/>
-                </a:solidFill>
-                <a:latin typeface="Noto Sans KR" pitchFamily="34" charset="0"/>
-                <a:ea typeface="Noto Sans KR" pitchFamily="34" charset="-122"/>
-                <a:cs typeface="Noto Sans KR" pitchFamily="34" charset="-120"/>
-              </a:rPr>
-              <a:t>접속 주소 &amp; 체크리스트</a:t>
+              <a:rPr lang="en-US" sz="1300" dirty="0">
+                <a:solidFill>
+                  <a:srgbClr val="8B8FB8"/>
+                </a:solidFill>
+                <a:latin typeface="Noto Sans KR" pitchFamily="34" charset="0"/>
+                <a:ea typeface="Noto Sans KR" pitchFamily="34" charset="-122"/>
+                <a:cs typeface="Noto Sans KR" pitchFamily="34" charset="-120"/>
+              </a:rPr>
+              <a:t>로비(방 생성/입장) → 4인 자동 시작 → 블라인드/베팅 → 쇼다운 → 칩 정산 후 다음 핸드</a:t>
             </a:r>
             <a:endParaRPr lang="en-US" sz="1300" dirty="0"/>
-          </a:p>
-        </p:txBody>
-      </p:sp>
-      <p:sp>
-        <p:nvSpPr>
-          <p:cNvPr id="25" name="Text 22"/>
-          <p:cNvSpPr/>
-          <p:nvPr/>
-        </p:nvSpPr>
-        <p:spPr>
-          <a:xfrm>
-            <a:off x="6995160" y="2103120"/>
-            <a:ext cx="4389120" cy="3794760"/>
-          </a:xfrm>
-          <a:prstGeom prst="rect">
-            <a:avLst/>
-          </a:prstGeom>
-          <a:noFill/>
-          <a:ln/>
-        </p:spPr>
-        <p:txBody>
-          <a:bodyPr wrap="square" rtlCol="0" anchor="t"/>
-          <a:lstStyle/>
-          <a:p>
-            <a:pPr indent="0" marL="0">
-              <a:lnSpc>
-                <a:spcPct val="135000"/>
-              </a:lnSpc>
-              <a:buNone/>
-            </a:pPr>
-            <a:r>
-              <a:rPr lang="en-US" sz="1450" dirty="0">
-                <a:solidFill>
-                  <a:srgbClr val="E7E9FF"/>
-                </a:solidFill>
-                <a:latin typeface="Noto Sans KR" pitchFamily="34" charset="0"/>
-                <a:ea typeface="Noto Sans KR" pitchFamily="34" charset="-122"/>
-                <a:cs typeface="Noto Sans KR" pitchFamily="34" charset="-120"/>
-              </a:rPr>
-              <a:t>http://holdem-client-026951011097.s3-website.ap-northeast-2.amazonaws.com</a:t>
-            </a:r>
-            <a:endParaRPr lang="en-US" sz="1450" dirty="0"/>
-          </a:p>
-          <a:p>
-            <a:pPr indent="0" marL="0">
-              <a:lnSpc>
-                <a:spcPct val="135000"/>
-              </a:lnSpc>
-              <a:buNone/>
-            </a:pPr>
-            <a:endParaRPr lang="en-US" sz="1450" dirty="0"/>
-          </a:p>
-          <a:p>
-            <a:pPr indent="0" marL="0">
-              <a:lnSpc>
-                <a:spcPct val="135000"/>
-              </a:lnSpc>
-              <a:buNone/>
-            </a:pPr>
-            <a:r>
-              <a:rPr lang="en-US" sz="1450" dirty="0">
-                <a:solidFill>
-                  <a:srgbClr val="E7E9FF"/>
-                </a:solidFill>
-                <a:latin typeface="Noto Sans KR" pitchFamily="34" charset="0"/>
-                <a:ea typeface="Noto Sans KR" pitchFamily="34" charset="-122"/>
-                <a:cs typeface="Noto Sans KR" pitchFamily="34" charset="-120"/>
-              </a:rPr>
-              <a:t>(백업: 로컬 데모 — localhost:5173)</a:t>
-            </a:r>
-            <a:endParaRPr lang="en-US" sz="1450" dirty="0"/>
-          </a:p>
-          <a:p>
-            <a:pPr indent="0" marL="0">
-              <a:lnSpc>
-                <a:spcPct val="135000"/>
-              </a:lnSpc>
-              <a:buNone/>
-            </a:pPr>
-            <a:endParaRPr lang="en-US" sz="1450" dirty="0"/>
-          </a:p>
-          <a:p>
-            <a:pPr indent="0" marL="0">
-              <a:lnSpc>
-                <a:spcPct val="135000"/>
-              </a:lnSpc>
-              <a:buNone/>
-            </a:pPr>
-            <a:r>
-              <a:rPr lang="en-US" sz="1450" dirty="0">
-                <a:solidFill>
-                  <a:srgbClr val="E7E9FF"/>
-                </a:solidFill>
-                <a:latin typeface="Noto Sans KR" pitchFamily="34" charset="0"/>
-                <a:ea typeface="Noto Sans KR" pitchFamily="34" charset="-122"/>
-                <a:cs typeface="Noto Sans KR" pitchFamily="34" charset="-120"/>
-              </a:rPr>
-              <a:t>발표 전 체크리스트</a:t>
-            </a:r>
-            <a:endParaRPr lang="en-US" sz="1450" dirty="0"/>
-          </a:p>
-          <a:p>
-            <a:pPr indent="0" marL="0">
-              <a:lnSpc>
-                <a:spcPct val="135000"/>
-              </a:lnSpc>
-              <a:buNone/>
-            </a:pPr>
-            <a:r>
-              <a:rPr lang="en-US" sz="1450" dirty="0">
-                <a:solidFill>
-                  <a:srgbClr val="E7E9FF"/>
-                </a:solidFill>
-                <a:latin typeface="Noto Sans KR" pitchFamily="34" charset="0"/>
-                <a:ea typeface="Noto Sans KR" pitchFamily="34" charset="-122"/>
-                <a:cs typeface="Noto Sans KR" pitchFamily="34" charset="-120"/>
-              </a:rPr>
-              <a:t>• ASG desired 2로 켜두기 (~5분)</a:t>
-            </a:r>
-            <a:endParaRPr lang="en-US" sz="1450" dirty="0"/>
-          </a:p>
-          <a:p>
-            <a:pPr indent="0" marL="0">
-              <a:lnSpc>
-                <a:spcPct val="135000"/>
-              </a:lnSpc>
-              <a:buNone/>
-            </a:pPr>
-            <a:r>
-              <a:rPr lang="en-US" sz="1450" dirty="0">
-                <a:solidFill>
-                  <a:srgbClr val="E7E9FF"/>
-                </a:solidFill>
-                <a:latin typeface="Noto Sans KR" pitchFamily="34" charset="0"/>
-                <a:ea typeface="Noto Sans KR" pitchFamily="34" charset="-122"/>
-                <a:cs typeface="Noto Sans KR" pitchFamily="34" charset="-120"/>
-              </a:rPr>
-              <a:t>• ALB 헬스체크 green 확인</a:t>
-            </a:r>
-            <a:endParaRPr lang="en-US" sz="1450" dirty="0"/>
-          </a:p>
-          <a:p>
-            <a:pPr indent="0" marL="0">
-              <a:lnSpc>
-                <a:spcPct val="135000"/>
-              </a:lnSpc>
-              <a:buNone/>
-            </a:pPr>
-            <a:r>
-              <a:rPr lang="en-US" sz="1450" dirty="0">
-                <a:solidFill>
-                  <a:srgbClr val="E7E9FF"/>
-                </a:solidFill>
-                <a:latin typeface="Noto Sans KR" pitchFamily="34" charset="0"/>
-                <a:ea typeface="Noto Sans KR" pitchFamily="34" charset="-122"/>
-                <a:cs typeface="Noto Sans KR" pitchFamily="34" charset="-120"/>
-              </a:rPr>
-              <a:t>• 프론트 S3 배포 완료 확인</a:t>
-            </a:r>
-            <a:endParaRPr lang="en-US" sz="1450" dirty="0"/>
           </a:p>
         </p:txBody>
       </p:sp>
@@ -4401,7 +4230,7 @@
                 <a:ea typeface="Noto Sans KR" pitchFamily="34" charset="-122"/>
                 <a:cs typeface="Noto Sans KR" pitchFamily="34" charset="-120"/>
               </a:rPr>
-              <a:t>12 — COST &amp; LESSONS</a:t>
+              <a:t>12 — LIVE DEMO</a:t>
             </a:r>
             <a:endParaRPr lang="en-US" sz="1300" dirty="0"/>
           </a:p>
@@ -4440,6 +4269,912 @@
                 <a:ea typeface="Noto Sans KR" pitchFamily="34" charset="-122"/>
                 <a:cs typeface="Noto Sans KR" pitchFamily="34" charset="-120"/>
               </a:rPr>
+              <a:t>라이브 데모 🔴</a:t>
+            </a:r>
+            <a:endParaRPr lang="en-US" sz="3000" dirty="0"/>
+          </a:p>
+        </p:txBody>
+      </p:sp>
+      <p:sp>
+        <p:nvSpPr>
+          <p:cNvPr id="5" name="Shape 2"/>
+          <p:cNvSpPr/>
+          <p:nvPr/>
+        </p:nvSpPr>
+        <p:spPr>
+          <a:xfrm>
+            <a:off x="640080" y="1600200"/>
+            <a:ext cx="457200" cy="457200"/>
+          </a:xfrm>
+          <a:prstGeom prst="ellipse">
+            <a:avLst/>
+          </a:prstGeom>
+          <a:solidFill>
+            <a:srgbClr val="7C3AED"/>
+          </a:solidFill>
+          <a:ln/>
+        </p:spPr>
+      </p:sp>
+      <p:sp>
+        <p:nvSpPr>
+          <p:cNvPr id="6" name="Text 3"/>
+          <p:cNvSpPr/>
+          <p:nvPr/>
+        </p:nvSpPr>
+        <p:spPr>
+          <a:xfrm>
+            <a:off x="640080" y="1600200"/>
+            <a:ext cx="457200" cy="457200"/>
+          </a:xfrm>
+          <a:prstGeom prst="rect">
+            <a:avLst/>
+          </a:prstGeom>
+          <a:noFill/>
+          <a:ln/>
+        </p:spPr>
+        <p:txBody>
+          <a:bodyPr wrap="square" rtlCol="0" anchor="ctr"/>
+          <a:lstStyle/>
+          <a:p>
+            <a:pPr algn="ctr" indent="0" marL="0">
+              <a:buNone/>
+            </a:pPr>
+            <a:r>
+              <a:rPr lang="en-US" sz="1500" b="1" dirty="0">
+                <a:solidFill>
+                  <a:srgbClr val="FFFFFF"/>
+                </a:solidFill>
+              </a:rPr>
+              <a:t>1</a:t>
+            </a:r>
+            <a:endParaRPr lang="en-US" sz="1500" dirty="0"/>
+          </a:p>
+        </p:txBody>
+      </p:sp>
+      <p:sp>
+        <p:nvSpPr>
+          <p:cNvPr id="7" name="Text 4"/>
+          <p:cNvSpPr/>
+          <p:nvPr/>
+        </p:nvSpPr>
+        <p:spPr>
+          <a:xfrm>
+            <a:off x="1280160" y="1600200"/>
+            <a:ext cx="5120640" cy="548640"/>
+          </a:xfrm>
+          <a:prstGeom prst="rect">
+            <a:avLst/>
+          </a:prstGeom>
+          <a:noFill/>
+          <a:ln/>
+        </p:spPr>
+        <p:txBody>
+          <a:bodyPr wrap="square" rtlCol="0" anchor="ctr"/>
+          <a:lstStyle/>
+          <a:p>
+            <a:pPr indent="0" marL="0">
+              <a:buNone/>
+            </a:pPr>
+            <a:r>
+              <a:rPr lang="en-US" sz="1550" dirty="0">
+                <a:solidFill>
+                  <a:srgbClr val="E7E9FF"/>
+                </a:solidFill>
+                <a:latin typeface="Noto Sans KR" pitchFamily="34" charset="0"/>
+                <a:ea typeface="Noto Sans KR" pitchFamily="34" charset="-122"/>
+                <a:cs typeface="Noto Sans KR" pitchFamily="34" charset="-120"/>
+              </a:rPr>
+              <a:t>브라우저 탭 4개로 접속 (시크릿 창 혼용)</a:t>
+            </a:r>
+            <a:endParaRPr lang="en-US" sz="1550" dirty="0"/>
+          </a:p>
+        </p:txBody>
+      </p:sp>
+      <p:sp>
+        <p:nvSpPr>
+          <p:cNvPr id="8" name="Shape 5"/>
+          <p:cNvSpPr/>
+          <p:nvPr/>
+        </p:nvSpPr>
+        <p:spPr>
+          <a:xfrm>
+            <a:off x="640080" y="2350008"/>
+            <a:ext cx="457200" cy="457200"/>
+          </a:xfrm>
+          <a:prstGeom prst="ellipse">
+            <a:avLst/>
+          </a:prstGeom>
+          <a:solidFill>
+            <a:srgbClr val="7C3AED"/>
+          </a:solidFill>
+          <a:ln/>
+        </p:spPr>
+      </p:sp>
+      <p:sp>
+        <p:nvSpPr>
+          <p:cNvPr id="9" name="Text 6"/>
+          <p:cNvSpPr/>
+          <p:nvPr/>
+        </p:nvSpPr>
+        <p:spPr>
+          <a:xfrm>
+            <a:off x="640080" y="2350008"/>
+            <a:ext cx="457200" cy="457200"/>
+          </a:xfrm>
+          <a:prstGeom prst="rect">
+            <a:avLst/>
+          </a:prstGeom>
+          <a:noFill/>
+          <a:ln/>
+        </p:spPr>
+        <p:txBody>
+          <a:bodyPr wrap="square" rtlCol="0" anchor="ctr"/>
+          <a:lstStyle/>
+          <a:p>
+            <a:pPr algn="ctr" indent="0" marL="0">
+              <a:buNone/>
+            </a:pPr>
+            <a:r>
+              <a:rPr lang="en-US" sz="1500" b="1" dirty="0">
+                <a:solidFill>
+                  <a:srgbClr val="FFFFFF"/>
+                </a:solidFill>
+              </a:rPr>
+              <a:t>2</a:t>
+            </a:r>
+            <a:endParaRPr lang="en-US" sz="1500" dirty="0"/>
+          </a:p>
+        </p:txBody>
+      </p:sp>
+      <p:sp>
+        <p:nvSpPr>
+          <p:cNvPr id="10" name="Text 7"/>
+          <p:cNvSpPr/>
+          <p:nvPr/>
+        </p:nvSpPr>
+        <p:spPr>
+          <a:xfrm>
+            <a:off x="1280160" y="2350008"/>
+            <a:ext cx="5120640" cy="548640"/>
+          </a:xfrm>
+          <a:prstGeom prst="rect">
+            <a:avLst/>
+          </a:prstGeom>
+          <a:noFill/>
+          <a:ln/>
+        </p:spPr>
+        <p:txBody>
+          <a:bodyPr wrap="square" rtlCol="0" anchor="ctr"/>
+          <a:lstStyle/>
+          <a:p>
+            <a:pPr indent="0" marL="0">
+              <a:buNone/>
+            </a:pPr>
+            <a:r>
+              <a:rPr lang="en-US" sz="1550" dirty="0">
+                <a:solidFill>
+                  <a:srgbClr val="E7E9FF"/>
+                </a:solidFill>
+                <a:latin typeface="Noto Sans KR" pitchFamily="34" charset="0"/>
+                <a:ea typeface="Noto Sans KR" pitchFamily="34" charset="-122"/>
+                <a:cs typeface="Noto Sans KR" pitchFamily="34" charset="-120"/>
+              </a:rPr>
+              <a:t>탭1: 닉네임 입력 → 방 만들기</a:t>
+            </a:r>
+            <a:endParaRPr lang="en-US" sz="1550" dirty="0"/>
+          </a:p>
+        </p:txBody>
+      </p:sp>
+      <p:sp>
+        <p:nvSpPr>
+          <p:cNvPr id="11" name="Shape 8"/>
+          <p:cNvSpPr/>
+          <p:nvPr/>
+        </p:nvSpPr>
+        <p:spPr>
+          <a:xfrm>
+            <a:off x="640080" y="3099816"/>
+            <a:ext cx="457200" cy="457200"/>
+          </a:xfrm>
+          <a:prstGeom prst="ellipse">
+            <a:avLst/>
+          </a:prstGeom>
+          <a:solidFill>
+            <a:srgbClr val="7C3AED"/>
+          </a:solidFill>
+          <a:ln/>
+        </p:spPr>
+      </p:sp>
+      <p:sp>
+        <p:nvSpPr>
+          <p:cNvPr id="12" name="Text 9"/>
+          <p:cNvSpPr/>
+          <p:nvPr/>
+        </p:nvSpPr>
+        <p:spPr>
+          <a:xfrm>
+            <a:off x="640080" y="3099816"/>
+            <a:ext cx="457200" cy="457200"/>
+          </a:xfrm>
+          <a:prstGeom prst="rect">
+            <a:avLst/>
+          </a:prstGeom>
+          <a:noFill/>
+          <a:ln/>
+        </p:spPr>
+        <p:txBody>
+          <a:bodyPr wrap="square" rtlCol="0" anchor="ctr"/>
+          <a:lstStyle/>
+          <a:p>
+            <a:pPr algn="ctr" indent="0" marL="0">
+              <a:buNone/>
+            </a:pPr>
+            <a:r>
+              <a:rPr lang="en-US" sz="1500" b="1" dirty="0">
+                <a:solidFill>
+                  <a:srgbClr val="FFFFFF"/>
+                </a:solidFill>
+              </a:rPr>
+              <a:t>3</a:t>
+            </a:r>
+            <a:endParaRPr lang="en-US" sz="1500" dirty="0"/>
+          </a:p>
+        </p:txBody>
+      </p:sp>
+      <p:sp>
+        <p:nvSpPr>
+          <p:cNvPr id="13" name="Text 10"/>
+          <p:cNvSpPr/>
+          <p:nvPr/>
+        </p:nvSpPr>
+        <p:spPr>
+          <a:xfrm>
+            <a:off x="1280160" y="3099816"/>
+            <a:ext cx="5120640" cy="548640"/>
+          </a:xfrm>
+          <a:prstGeom prst="rect">
+            <a:avLst/>
+          </a:prstGeom>
+          <a:noFill/>
+          <a:ln/>
+        </p:spPr>
+        <p:txBody>
+          <a:bodyPr wrap="square" rtlCol="0" anchor="ctr"/>
+          <a:lstStyle/>
+          <a:p>
+            <a:pPr indent="0" marL="0">
+              <a:buNone/>
+            </a:pPr>
+            <a:r>
+              <a:rPr lang="en-US" sz="1550" dirty="0">
+                <a:solidFill>
+                  <a:srgbClr val="E7E9FF"/>
+                </a:solidFill>
+                <a:latin typeface="Noto Sans KR" pitchFamily="34" charset="0"/>
+                <a:ea typeface="Noto Sans KR" pitchFamily="34" charset="-122"/>
+                <a:cs typeface="Noto Sans KR" pitchFamily="34" charset="-120"/>
+              </a:rPr>
+              <a:t>탭2~4: 같은 방 입장 → 5초 카운트다운</a:t>
+            </a:r>
+            <a:endParaRPr lang="en-US" sz="1550" dirty="0"/>
+          </a:p>
+        </p:txBody>
+      </p:sp>
+      <p:sp>
+        <p:nvSpPr>
+          <p:cNvPr id="14" name="Shape 11"/>
+          <p:cNvSpPr/>
+          <p:nvPr/>
+        </p:nvSpPr>
+        <p:spPr>
+          <a:xfrm>
+            <a:off x="640080" y="3849624"/>
+            <a:ext cx="457200" cy="457200"/>
+          </a:xfrm>
+          <a:prstGeom prst="ellipse">
+            <a:avLst/>
+          </a:prstGeom>
+          <a:solidFill>
+            <a:srgbClr val="7C3AED"/>
+          </a:solidFill>
+          <a:ln/>
+        </p:spPr>
+      </p:sp>
+      <p:sp>
+        <p:nvSpPr>
+          <p:cNvPr id="15" name="Text 12"/>
+          <p:cNvSpPr/>
+          <p:nvPr/>
+        </p:nvSpPr>
+        <p:spPr>
+          <a:xfrm>
+            <a:off x="640080" y="3849624"/>
+            <a:ext cx="457200" cy="457200"/>
+          </a:xfrm>
+          <a:prstGeom prst="rect">
+            <a:avLst/>
+          </a:prstGeom>
+          <a:noFill/>
+          <a:ln/>
+        </p:spPr>
+        <p:txBody>
+          <a:bodyPr wrap="square" rtlCol="0" anchor="ctr"/>
+          <a:lstStyle/>
+          <a:p>
+            <a:pPr algn="ctr" indent="0" marL="0">
+              <a:buNone/>
+            </a:pPr>
+            <a:r>
+              <a:rPr lang="en-US" sz="1500" b="1" dirty="0">
+                <a:solidFill>
+                  <a:srgbClr val="FFFFFF"/>
+                </a:solidFill>
+              </a:rPr>
+              <a:t>4</a:t>
+            </a:r>
+            <a:endParaRPr lang="en-US" sz="1500" dirty="0"/>
+          </a:p>
+        </p:txBody>
+      </p:sp>
+      <p:sp>
+        <p:nvSpPr>
+          <p:cNvPr id="16" name="Text 13"/>
+          <p:cNvSpPr/>
+          <p:nvPr/>
+        </p:nvSpPr>
+        <p:spPr>
+          <a:xfrm>
+            <a:off x="1280160" y="3849624"/>
+            <a:ext cx="5120640" cy="548640"/>
+          </a:xfrm>
+          <a:prstGeom prst="rect">
+            <a:avLst/>
+          </a:prstGeom>
+          <a:noFill/>
+          <a:ln/>
+        </p:spPr>
+        <p:txBody>
+          <a:bodyPr wrap="square" rtlCol="0" anchor="ctr"/>
+          <a:lstStyle/>
+          <a:p>
+            <a:pPr indent="0" marL="0">
+              <a:buNone/>
+            </a:pPr>
+            <a:r>
+              <a:rPr lang="en-US" sz="1550" dirty="0">
+                <a:solidFill>
+                  <a:srgbClr val="E7E9FF"/>
+                </a:solidFill>
+                <a:latin typeface="Noto Sans KR" pitchFamily="34" charset="0"/>
+                <a:ea typeface="Noto Sans KR" pitchFamily="34" charset="-122"/>
+                <a:cs typeface="Noto Sans KR" pitchFamily="34" charset="-120"/>
+              </a:rPr>
+              <a:t>베팅 한 바퀴 (콜/체크로 빠르게) → 플랍 공개</a:t>
+            </a:r>
+            <a:endParaRPr lang="en-US" sz="1550" dirty="0"/>
+          </a:p>
+        </p:txBody>
+      </p:sp>
+      <p:sp>
+        <p:nvSpPr>
+          <p:cNvPr id="17" name="Shape 14"/>
+          <p:cNvSpPr/>
+          <p:nvPr/>
+        </p:nvSpPr>
+        <p:spPr>
+          <a:xfrm>
+            <a:off x="640080" y="4599432"/>
+            <a:ext cx="457200" cy="457200"/>
+          </a:xfrm>
+          <a:prstGeom prst="ellipse">
+            <a:avLst/>
+          </a:prstGeom>
+          <a:solidFill>
+            <a:srgbClr val="7C3AED"/>
+          </a:solidFill>
+          <a:ln/>
+        </p:spPr>
+      </p:sp>
+      <p:sp>
+        <p:nvSpPr>
+          <p:cNvPr id="18" name="Text 15"/>
+          <p:cNvSpPr/>
+          <p:nvPr/>
+        </p:nvSpPr>
+        <p:spPr>
+          <a:xfrm>
+            <a:off x="640080" y="4599432"/>
+            <a:ext cx="457200" cy="457200"/>
+          </a:xfrm>
+          <a:prstGeom prst="rect">
+            <a:avLst/>
+          </a:prstGeom>
+          <a:noFill/>
+          <a:ln/>
+        </p:spPr>
+        <p:txBody>
+          <a:bodyPr wrap="square" rtlCol="0" anchor="ctr"/>
+          <a:lstStyle/>
+          <a:p>
+            <a:pPr algn="ctr" indent="0" marL="0">
+              <a:buNone/>
+            </a:pPr>
+            <a:r>
+              <a:rPr lang="en-US" sz="1500" b="1" dirty="0">
+                <a:solidFill>
+                  <a:srgbClr val="FFFFFF"/>
+                </a:solidFill>
+              </a:rPr>
+              <a:t>5</a:t>
+            </a:r>
+            <a:endParaRPr lang="en-US" sz="1500" dirty="0"/>
+          </a:p>
+        </p:txBody>
+      </p:sp>
+      <p:sp>
+        <p:nvSpPr>
+          <p:cNvPr id="19" name="Text 16"/>
+          <p:cNvSpPr/>
+          <p:nvPr/>
+        </p:nvSpPr>
+        <p:spPr>
+          <a:xfrm>
+            <a:off x="1280160" y="4599432"/>
+            <a:ext cx="5120640" cy="548640"/>
+          </a:xfrm>
+          <a:prstGeom prst="rect">
+            <a:avLst/>
+          </a:prstGeom>
+          <a:noFill/>
+          <a:ln/>
+        </p:spPr>
+        <p:txBody>
+          <a:bodyPr wrap="square" rtlCol="0" anchor="ctr"/>
+          <a:lstStyle/>
+          <a:p>
+            <a:pPr indent="0" marL="0">
+              <a:buNone/>
+            </a:pPr>
+            <a:r>
+              <a:rPr lang="en-US" sz="1550" dirty="0">
+                <a:solidFill>
+                  <a:srgbClr val="E7E9FF"/>
+                </a:solidFill>
+                <a:latin typeface="Noto Sans KR" pitchFamily="34" charset="0"/>
+                <a:ea typeface="Noto Sans KR" pitchFamily="34" charset="-122"/>
+                <a:cs typeface="Noto Sans KR" pitchFamily="34" charset="-120"/>
+              </a:rPr>
+              <a:t>탭 하나 방치 → 20초 auto-fold 시연</a:t>
+            </a:r>
+            <a:endParaRPr lang="en-US" sz="1550" dirty="0"/>
+          </a:p>
+        </p:txBody>
+      </p:sp>
+      <p:sp>
+        <p:nvSpPr>
+          <p:cNvPr id="20" name="Shape 17"/>
+          <p:cNvSpPr/>
+          <p:nvPr/>
+        </p:nvSpPr>
+        <p:spPr>
+          <a:xfrm>
+            <a:off x="640080" y="5349240"/>
+            <a:ext cx="457200" cy="457200"/>
+          </a:xfrm>
+          <a:prstGeom prst="ellipse">
+            <a:avLst/>
+          </a:prstGeom>
+          <a:solidFill>
+            <a:srgbClr val="7C3AED"/>
+          </a:solidFill>
+          <a:ln/>
+        </p:spPr>
+      </p:sp>
+      <p:sp>
+        <p:nvSpPr>
+          <p:cNvPr id="21" name="Text 18"/>
+          <p:cNvSpPr/>
+          <p:nvPr/>
+        </p:nvSpPr>
+        <p:spPr>
+          <a:xfrm>
+            <a:off x="640080" y="5349240"/>
+            <a:ext cx="457200" cy="457200"/>
+          </a:xfrm>
+          <a:prstGeom prst="rect">
+            <a:avLst/>
+          </a:prstGeom>
+          <a:noFill/>
+          <a:ln/>
+        </p:spPr>
+        <p:txBody>
+          <a:bodyPr wrap="square" rtlCol="0" anchor="ctr"/>
+          <a:lstStyle/>
+          <a:p>
+            <a:pPr algn="ctr" indent="0" marL="0">
+              <a:buNone/>
+            </a:pPr>
+            <a:r>
+              <a:rPr lang="en-US" sz="1500" b="1" dirty="0">
+                <a:solidFill>
+                  <a:srgbClr val="FFFFFF"/>
+                </a:solidFill>
+              </a:rPr>
+              <a:t>6</a:t>
+            </a:r>
+            <a:endParaRPr lang="en-US" sz="1500" dirty="0"/>
+          </a:p>
+        </p:txBody>
+      </p:sp>
+      <p:sp>
+        <p:nvSpPr>
+          <p:cNvPr id="22" name="Text 19"/>
+          <p:cNvSpPr/>
+          <p:nvPr/>
+        </p:nvSpPr>
+        <p:spPr>
+          <a:xfrm>
+            <a:off x="1280160" y="5349240"/>
+            <a:ext cx="5120640" cy="548640"/>
+          </a:xfrm>
+          <a:prstGeom prst="rect">
+            <a:avLst/>
+          </a:prstGeom>
+          <a:noFill/>
+          <a:ln/>
+        </p:spPr>
+        <p:txBody>
+          <a:bodyPr wrap="square" rtlCol="0" anchor="ctr"/>
+          <a:lstStyle/>
+          <a:p>
+            <a:pPr indent="0" marL="0">
+              <a:buNone/>
+            </a:pPr>
+            <a:r>
+              <a:rPr lang="en-US" sz="1550" dirty="0">
+                <a:solidFill>
+                  <a:srgbClr val="E7E9FF"/>
+                </a:solidFill>
+                <a:latin typeface="Noto Sans KR" pitchFamily="34" charset="0"/>
+                <a:ea typeface="Noto Sans KR" pitchFamily="34" charset="-122"/>
+                <a:cs typeface="Noto Sans KR" pitchFamily="34" charset="-120"/>
+              </a:rPr>
+              <a:t>쇼다운 → 칩 정산 → 다음 핸드 자동 시작</a:t>
+            </a:r>
+            <a:endParaRPr lang="en-US" sz="1550" dirty="0"/>
+          </a:p>
+        </p:txBody>
+      </p:sp>
+      <p:sp>
+        <p:nvSpPr>
+          <p:cNvPr id="23" name="Shape 20"/>
+          <p:cNvSpPr/>
+          <p:nvPr/>
+        </p:nvSpPr>
+        <p:spPr>
+          <a:xfrm>
+            <a:off x="6766560" y="1600200"/>
+            <a:ext cx="4846320" cy="4480560"/>
+          </a:xfrm>
+          <a:prstGeom prst="roundRect">
+            <a:avLst>
+              <a:gd name="adj" fmla="val 2449"/>
+            </a:avLst>
+          </a:prstGeom>
+          <a:solidFill>
+            <a:srgbClr val="111120"/>
+          </a:solidFill>
+          <a:ln w="12700">
+            <a:solidFill>
+              <a:srgbClr val="22D3EE"/>
+            </a:solidFill>
+            <a:prstDash val="solid"/>
+          </a:ln>
+        </p:spPr>
+      </p:sp>
+      <p:sp>
+        <p:nvSpPr>
+          <p:cNvPr id="24" name="Text 21"/>
+          <p:cNvSpPr/>
+          <p:nvPr/>
+        </p:nvSpPr>
+        <p:spPr>
+          <a:xfrm>
+            <a:off x="6995160" y="1737360"/>
+            <a:ext cx="4389120" cy="365760"/>
+          </a:xfrm>
+          <a:prstGeom prst="rect">
+            <a:avLst/>
+          </a:prstGeom>
+          <a:noFill/>
+          <a:ln/>
+        </p:spPr>
+        <p:txBody>
+          <a:bodyPr wrap="square" rtlCol="0" anchor="ctr"/>
+          <a:lstStyle/>
+          <a:p>
+            <a:pPr indent="0" marL="0">
+              <a:buNone/>
+            </a:pPr>
+            <a:r>
+              <a:rPr lang="en-US" sz="1300" b="1" spc="200" kern="0" dirty="0">
+                <a:solidFill>
+                  <a:srgbClr val="22D3EE"/>
+                </a:solidFill>
+                <a:latin typeface="Noto Sans KR" pitchFamily="34" charset="0"/>
+                <a:ea typeface="Noto Sans KR" pitchFamily="34" charset="-122"/>
+                <a:cs typeface="Noto Sans KR" pitchFamily="34" charset="-120"/>
+              </a:rPr>
+              <a:t>접속 주소 &amp; 체크리스트</a:t>
+            </a:r>
+            <a:endParaRPr lang="en-US" sz="1300" dirty="0"/>
+          </a:p>
+        </p:txBody>
+      </p:sp>
+      <p:sp>
+        <p:nvSpPr>
+          <p:cNvPr id="25" name="Text 22"/>
+          <p:cNvSpPr/>
+          <p:nvPr/>
+        </p:nvSpPr>
+        <p:spPr>
+          <a:xfrm>
+            <a:off x="6995160" y="2103120"/>
+            <a:ext cx="4389120" cy="3794760"/>
+          </a:xfrm>
+          <a:prstGeom prst="rect">
+            <a:avLst/>
+          </a:prstGeom>
+          <a:noFill/>
+          <a:ln/>
+        </p:spPr>
+        <p:txBody>
+          <a:bodyPr wrap="square" rtlCol="0" anchor="t"/>
+          <a:lstStyle/>
+          <a:p>
+            <a:pPr indent="0" marL="0">
+              <a:lnSpc>
+                <a:spcPct val="135000"/>
+              </a:lnSpc>
+              <a:buNone/>
+            </a:pPr>
+            <a:r>
+              <a:rPr lang="en-US" sz="1450" dirty="0">
+                <a:solidFill>
+                  <a:srgbClr val="E7E9FF"/>
+                </a:solidFill>
+                <a:latin typeface="Noto Sans KR" pitchFamily="34" charset="0"/>
+                <a:ea typeface="Noto Sans KR" pitchFamily="34" charset="-122"/>
+                <a:cs typeface="Noto Sans KR" pitchFamily="34" charset="-120"/>
+              </a:rPr>
+              <a:t>http://holdem-client-026951011097.s3-website.ap-northeast-2.amazonaws.com</a:t>
+            </a:r>
+            <a:endParaRPr lang="en-US" sz="1450" dirty="0"/>
+          </a:p>
+          <a:p>
+            <a:pPr indent="0" marL="0">
+              <a:lnSpc>
+                <a:spcPct val="135000"/>
+              </a:lnSpc>
+              <a:buNone/>
+            </a:pPr>
+            <a:endParaRPr lang="en-US" sz="1450" dirty="0"/>
+          </a:p>
+          <a:p>
+            <a:pPr indent="0" marL="0">
+              <a:lnSpc>
+                <a:spcPct val="135000"/>
+              </a:lnSpc>
+              <a:buNone/>
+            </a:pPr>
+            <a:r>
+              <a:rPr lang="en-US" sz="1450" dirty="0">
+                <a:solidFill>
+                  <a:srgbClr val="E7E9FF"/>
+                </a:solidFill>
+                <a:latin typeface="Noto Sans KR" pitchFamily="34" charset="0"/>
+                <a:ea typeface="Noto Sans KR" pitchFamily="34" charset="-122"/>
+                <a:cs typeface="Noto Sans KR" pitchFamily="34" charset="-120"/>
+              </a:rPr>
+              <a:t>(백업: 로컬 데모 — localhost:5173)</a:t>
+            </a:r>
+            <a:endParaRPr lang="en-US" sz="1450" dirty="0"/>
+          </a:p>
+          <a:p>
+            <a:pPr indent="0" marL="0">
+              <a:lnSpc>
+                <a:spcPct val="135000"/>
+              </a:lnSpc>
+              <a:buNone/>
+            </a:pPr>
+            <a:endParaRPr lang="en-US" sz="1450" dirty="0"/>
+          </a:p>
+          <a:p>
+            <a:pPr indent="0" marL="0">
+              <a:lnSpc>
+                <a:spcPct val="135000"/>
+              </a:lnSpc>
+              <a:buNone/>
+            </a:pPr>
+            <a:r>
+              <a:rPr lang="en-US" sz="1450" dirty="0">
+                <a:solidFill>
+                  <a:srgbClr val="E7E9FF"/>
+                </a:solidFill>
+                <a:latin typeface="Noto Sans KR" pitchFamily="34" charset="0"/>
+                <a:ea typeface="Noto Sans KR" pitchFamily="34" charset="-122"/>
+                <a:cs typeface="Noto Sans KR" pitchFamily="34" charset="-120"/>
+              </a:rPr>
+              <a:t>발표 전 체크리스트</a:t>
+            </a:r>
+            <a:endParaRPr lang="en-US" sz="1450" dirty="0"/>
+          </a:p>
+          <a:p>
+            <a:pPr indent="0" marL="0">
+              <a:lnSpc>
+                <a:spcPct val="135000"/>
+              </a:lnSpc>
+              <a:buNone/>
+            </a:pPr>
+            <a:r>
+              <a:rPr lang="en-US" sz="1450" dirty="0">
+                <a:solidFill>
+                  <a:srgbClr val="E7E9FF"/>
+                </a:solidFill>
+                <a:latin typeface="Noto Sans KR" pitchFamily="34" charset="0"/>
+                <a:ea typeface="Noto Sans KR" pitchFamily="34" charset="-122"/>
+                <a:cs typeface="Noto Sans KR" pitchFamily="34" charset="-120"/>
+              </a:rPr>
+              <a:t>• ASG desired 2로 켜두기 (~5분)</a:t>
+            </a:r>
+            <a:endParaRPr lang="en-US" sz="1450" dirty="0"/>
+          </a:p>
+          <a:p>
+            <a:pPr indent="0" marL="0">
+              <a:lnSpc>
+                <a:spcPct val="135000"/>
+              </a:lnSpc>
+              <a:buNone/>
+            </a:pPr>
+            <a:r>
+              <a:rPr lang="en-US" sz="1450" dirty="0">
+                <a:solidFill>
+                  <a:srgbClr val="E7E9FF"/>
+                </a:solidFill>
+                <a:latin typeface="Noto Sans KR" pitchFamily="34" charset="0"/>
+                <a:ea typeface="Noto Sans KR" pitchFamily="34" charset="-122"/>
+                <a:cs typeface="Noto Sans KR" pitchFamily="34" charset="-120"/>
+              </a:rPr>
+              <a:t>• ALB 헬스체크 green 확인</a:t>
+            </a:r>
+            <a:endParaRPr lang="en-US" sz="1450" dirty="0"/>
+          </a:p>
+          <a:p>
+            <a:pPr indent="0" marL="0">
+              <a:lnSpc>
+                <a:spcPct val="135000"/>
+              </a:lnSpc>
+              <a:buNone/>
+            </a:pPr>
+            <a:r>
+              <a:rPr lang="en-US" sz="1450" dirty="0">
+                <a:solidFill>
+                  <a:srgbClr val="E7E9FF"/>
+                </a:solidFill>
+                <a:latin typeface="Noto Sans KR" pitchFamily="34" charset="0"/>
+                <a:ea typeface="Noto Sans KR" pitchFamily="34" charset="-122"/>
+                <a:cs typeface="Noto Sans KR" pitchFamily="34" charset="-120"/>
+              </a:rPr>
+              <a:t>• 프론트 S3 배포 완료 확인</a:t>
+            </a:r>
+            <a:endParaRPr lang="en-US" sz="1450" dirty="0"/>
+          </a:p>
+        </p:txBody>
+      </p:sp>
+    </p:spTree>
+  </p:cSld>
+  <p:clrMapOvr>
+    <a:masterClrMapping/>
+  </p:clrMapOvr>
+</p:sld>
+</file>
+
+<file path=ppt/slides/slide15.xml><?xml version="1.0" encoding="utf-8"?>
+<p:sld xmlns:a="http://schemas.openxmlformats.org/drawingml/2006/main" xmlns:r="http://schemas.openxmlformats.org/officeDocument/2006/relationships" xmlns:p="http://schemas.openxmlformats.org/presentationml/2006/main">
+  <p:cSld name="Slide 15">
+    <p:bg>
+      <p:bgPr>
+        <a:solidFill>
+          <a:srgbClr val="0B0B16"/>
+        </a:solidFill>
+      </p:bgPr>
+    </p:bg>
+    <p:spTree>
+      <p:nvGrpSpPr>
+        <p:cNvPr id="1" name=""/>
+        <p:cNvGrpSpPr/>
+        <p:nvPr/>
+      </p:nvGrpSpPr>
+      <p:grpSpPr>
+        <a:xfrm>
+          <a:off x="0" y="0"/>
+          <a:ext cx="0" cy="0"/>
+          <a:chOff x="0" y="0"/>
+          <a:chExt cx="0" cy="0"/>
+        </a:xfrm>
+      </p:grpSpPr>
+      <p:sp>
+        <p:nvSpPr>
+          <p:cNvPr id="3" name="Text 0"/>
+          <p:cNvSpPr/>
+          <p:nvPr/>
+        </p:nvSpPr>
+        <p:spPr>
+          <a:xfrm>
+            <a:off x="640080" y="320040"/>
+            <a:ext cx="10058400" cy="365760"/>
+          </a:xfrm>
+          <a:prstGeom prst="rect">
+            <a:avLst/>
+          </a:prstGeom>
+          <a:noFill/>
+          <a:ln/>
+        </p:spPr>
+        <p:txBody>
+          <a:bodyPr wrap="square" rtlCol="0" anchor="ctr"/>
+          <a:lstStyle/>
+          <a:p>
+            <a:pPr indent="0" marL="0">
+              <a:buNone/>
+            </a:pPr>
+            <a:r>
+              <a:rPr lang="en-US" sz="1300" b="1" spc="400" kern="0" dirty="0">
+                <a:solidFill>
+                  <a:srgbClr val="22D3EE"/>
+                </a:solidFill>
+                <a:latin typeface="Noto Sans KR" pitchFamily="34" charset="0"/>
+                <a:ea typeface="Noto Sans KR" pitchFamily="34" charset="-122"/>
+                <a:cs typeface="Noto Sans KR" pitchFamily="34" charset="-120"/>
+              </a:rPr>
+              <a:t>13 — COST &amp; LESSONS</a:t>
+            </a:r>
+            <a:endParaRPr lang="en-US" sz="1300" dirty="0"/>
+          </a:p>
+        </p:txBody>
+      </p:sp>
+      <p:sp>
+        <p:nvSpPr>
+          <p:cNvPr id="4" name="Text 1"/>
+          <p:cNvSpPr/>
+          <p:nvPr/>
+        </p:nvSpPr>
+        <p:spPr>
+          <a:xfrm>
+            <a:off x="640080" y="685800"/>
+            <a:ext cx="10972800" cy="731520"/>
+          </a:xfrm>
+          <a:prstGeom prst="rect">
+            <a:avLst/>
+          </a:prstGeom>
+          <a:noFill/>
+          <a:ln/>
+        </p:spPr>
+        <p:txBody>
+          <a:bodyPr wrap="square" rtlCol="0" anchor="ctr"/>
+          <a:lstStyle/>
+          <a:p>
+            <a:pPr indent="0" marL="0">
+              <a:buNone/>
+            </a:pPr>
+            <a:r>
+              <a:rPr lang="en-US" sz="3000" b="1" dirty="0">
+                <a:solidFill>
+                  <a:srgbClr val="E7E9FF"/>
+                </a:solidFill>
+                <a:latin typeface="Noto Sans KR" pitchFamily="34" charset="0"/>
+                <a:ea typeface="Noto Sans KR" pitchFamily="34" charset="-122"/>
+                <a:cs typeface="Noto Sans KR" pitchFamily="34" charset="-120"/>
+              </a:rPr>
               <a:t>비용과 배운 점</a:t>
             </a:r>
             <a:endParaRPr lang="en-US" sz="3000" dirty="0"/>
@@ -4448,7 +5183,7 @@
       </p:sp>
       <p:graphicFrame>
         <p:nvGraphicFramePr>
-          <p:cNvPr id="15" name="Table 0"/>
+          <p:cNvPr id="16" name="Table 0"/>
           <p:cNvGraphicFramePr>
             <a:graphicFrameLocks noGrp="1"/>
           </p:cNvGraphicFramePr>
@@ -9280,7 +10015,7 @@
                 <a:ea typeface="Noto Sans KR" pitchFamily="34" charset="-122"/>
                 <a:cs typeface="Noto Sans KR" pitchFamily="34" charset="-120"/>
               </a:rPr>
-              <a:t>08 — AUTO SCALING</a:t>
+              <a:t>08 — STORAGE</a:t>
             </a:r>
             <a:endParaRPr lang="en-US" sz="1300" dirty="0"/>
           </a:p>
@@ -9319,7 +10054,7 @@
                 <a:ea typeface="Noto Sans KR" pitchFamily="34" charset="-122"/>
                 <a:cs typeface="Noto Sans KR" pitchFamily="34" charset="-120"/>
               </a:rPr>
-              <a:t>2단 Auto Scaling</a:t>
+              <a:t>S3 — 정적 호스팅과 게임 히스토리</a:t>
             </a:r>
             <a:endParaRPr lang="en-US" sz="3000" dirty="0"/>
           </a:p>
@@ -9334,11 +10069,226 @@
         <p:spPr>
           <a:xfrm>
             <a:off x="640080" y="1645920"/>
-            <a:ext cx="5394960" cy="2103120"/>
+            <a:ext cx="5394960" cy="4480560"/>
           </a:xfrm>
           <a:prstGeom prst="roundRect">
             <a:avLst>
-              <a:gd name="adj" fmla="val 5217"/>
+              <a:gd name="adj" fmla="val 2449"/>
+            </a:avLst>
+          </a:prstGeom>
+          <a:solidFill>
+            <a:srgbClr val="111120"/>
+          </a:solidFill>
+          <a:ln w="12700">
+            <a:solidFill>
+              <a:srgbClr val="F59E0B"/>
+            </a:solidFill>
+            <a:prstDash val="solid"/>
+          </a:ln>
+        </p:spPr>
+      </p:sp>
+      <p:sp>
+        <p:nvSpPr>
+          <p:cNvPr id="6" name="Text 3"/>
+          <p:cNvSpPr/>
+          <p:nvPr/>
+        </p:nvSpPr>
+        <p:spPr>
+          <a:xfrm>
+            <a:off x="868680" y="1783080"/>
+            <a:ext cx="4937760" cy="365760"/>
+          </a:xfrm>
+          <a:prstGeom prst="rect">
+            <a:avLst/>
+          </a:prstGeom>
+          <a:noFill/>
+          <a:ln/>
+        </p:spPr>
+        <p:txBody>
+          <a:bodyPr wrap="square" rtlCol="0" anchor="ctr"/>
+          <a:lstStyle/>
+          <a:p>
+            <a:pPr indent="0" marL="0">
+              <a:buNone/>
+            </a:pPr>
+            <a:r>
+              <a:rPr lang="en-US" sz="1300" b="1" spc="200" kern="0" dirty="0">
+                <a:solidFill>
+                  <a:srgbClr val="F59E0B"/>
+                </a:solidFill>
+                <a:latin typeface="Noto Sans KR" pitchFamily="34" charset="0"/>
+                <a:ea typeface="Noto Sans KR" pitchFamily="34" charset="-122"/>
+                <a:cs typeface="Noto Sans KR" pitchFamily="34" charset="-120"/>
+              </a:rPr>
+              <a:t>버킷 A — React 정적 호스팅</a:t>
+            </a:r>
+            <a:endParaRPr lang="en-US" sz="1300" dirty="0"/>
+          </a:p>
+        </p:txBody>
+      </p:sp>
+      <p:sp>
+        <p:nvSpPr>
+          <p:cNvPr id="7" name="Text 4"/>
+          <p:cNvSpPr/>
+          <p:nvPr/>
+        </p:nvSpPr>
+        <p:spPr>
+          <a:xfrm>
+            <a:off x="868680" y="2148840"/>
+            <a:ext cx="4937760" cy="3794760"/>
+          </a:xfrm>
+          <a:prstGeom prst="rect">
+            <a:avLst/>
+          </a:prstGeom>
+          <a:noFill/>
+          <a:ln/>
+        </p:spPr>
+        <p:txBody>
+          <a:bodyPr wrap="square" rtlCol="0" anchor="t"/>
+          <a:lstStyle/>
+          <a:p>
+            <a:pPr indent="0" marL="0">
+              <a:lnSpc>
+                <a:spcPct val="135000"/>
+              </a:lnSpc>
+              <a:buNone/>
+            </a:pPr>
+            <a:r>
+              <a:rPr lang="en-US" sz="1450" dirty="0">
+                <a:solidFill>
+                  <a:srgbClr val="E7E9FF"/>
+                </a:solidFill>
+                <a:latin typeface="Noto Sans KR" pitchFamily="34" charset="0"/>
+                <a:ea typeface="Noto Sans KR" pitchFamily="34" charset="-122"/>
+                <a:cs typeface="Noto Sans KR" pitchFamily="34" charset="-120"/>
+              </a:rPr>
+              <a:t>• 웹서버 없이 S3 정적 웹사이트 호스팅만으로 프론트엔드 서빙</a:t>
+            </a:r>
+            <a:endParaRPr lang="en-US" sz="1450" dirty="0"/>
+          </a:p>
+          <a:p>
+            <a:pPr indent="0" marL="0">
+              <a:lnSpc>
+                <a:spcPct val="135000"/>
+              </a:lnSpc>
+              <a:buNone/>
+            </a:pPr>
+            <a:endParaRPr lang="en-US" sz="1450" dirty="0"/>
+          </a:p>
+          <a:p>
+            <a:pPr indent="0" marL="0">
+              <a:lnSpc>
+                <a:spcPct val="135000"/>
+              </a:lnSpc>
+              <a:buNone/>
+            </a:pPr>
+            <a:r>
+              <a:rPr lang="en-US" sz="1450" dirty="0">
+                <a:solidFill>
+                  <a:srgbClr val="E7E9FF"/>
+                </a:solidFill>
+                <a:latin typeface="Noto Sans KR" pitchFamily="34" charset="0"/>
+                <a:ea typeface="Noto Sans KR" pitchFamily="34" charset="-122"/>
+                <a:cs typeface="Noto Sans KR" pitchFamily="34" charset="-120"/>
+              </a:rPr>
+              <a:t>• 버킷 정책으로 s3:GetObject만 퍼블릭 허용</a:t>
+            </a:r>
+            <a:endParaRPr lang="en-US" sz="1450" dirty="0"/>
+          </a:p>
+          <a:p>
+            <a:pPr indent="0" marL="0">
+              <a:lnSpc>
+                <a:spcPct val="135000"/>
+              </a:lnSpc>
+              <a:buNone/>
+            </a:pPr>
+            <a:endParaRPr lang="en-US" sz="1450" dirty="0"/>
+          </a:p>
+          <a:p>
+            <a:pPr indent="0" marL="0">
+              <a:lnSpc>
+                <a:spcPct val="135000"/>
+              </a:lnSpc>
+              <a:buNone/>
+            </a:pPr>
+            <a:r>
+              <a:rPr lang="en-US" sz="1450" dirty="0">
+                <a:solidFill>
+                  <a:srgbClr val="E7E9FF"/>
+                </a:solidFill>
+                <a:latin typeface="Noto Sans KR" pitchFamily="34" charset="0"/>
+                <a:ea typeface="Noto Sans KR" pitchFamily="34" charset="-122"/>
+                <a:cs typeface="Noto Sans KR" pitchFamily="34" charset="-120"/>
+              </a:rPr>
+              <a:t>• 빌드 시 ALB 주소 주입:</a:t>
+            </a:r>
+            <a:endParaRPr lang="en-US" sz="1450" dirty="0"/>
+          </a:p>
+          <a:p>
+            <a:pPr indent="0" marL="0">
+              <a:lnSpc>
+                <a:spcPct val="135000"/>
+              </a:lnSpc>
+              <a:buNone/>
+            </a:pPr>
+            <a:r>
+              <a:rPr lang="en-US" sz="1450" dirty="0">
+                <a:solidFill>
+                  <a:srgbClr val="E7E9FF"/>
+                </a:solidFill>
+                <a:latin typeface="Noto Sans KR" pitchFamily="34" charset="0"/>
+                <a:ea typeface="Noto Sans KR" pitchFamily="34" charset="-122"/>
+                <a:cs typeface="Noto Sans KR" pitchFamily="34" charset="-120"/>
+              </a:rPr>
+              <a:t>  VITE_WS_URL=ws://ALB… npm run build</a:t>
+            </a:r>
+            <a:endParaRPr lang="en-US" sz="1450" dirty="0"/>
+          </a:p>
+          <a:p>
+            <a:pPr indent="0" marL="0">
+              <a:lnSpc>
+                <a:spcPct val="135000"/>
+              </a:lnSpc>
+              <a:buNone/>
+            </a:pPr>
+            <a:endParaRPr lang="en-US" sz="1450" dirty="0"/>
+          </a:p>
+          <a:p>
+            <a:pPr indent="0" marL="0">
+              <a:lnSpc>
+                <a:spcPct val="135000"/>
+              </a:lnSpc>
+              <a:buNone/>
+            </a:pPr>
+            <a:r>
+              <a:rPr lang="en-US" sz="1450" dirty="0">
+                <a:solidFill>
+                  <a:srgbClr val="E7E9FF"/>
+                </a:solidFill>
+                <a:latin typeface="Noto Sans KR" pitchFamily="34" charset="0"/>
+                <a:ea typeface="Noto Sans KR" pitchFamily="34" charset="-122"/>
+                <a:cs typeface="Noto Sans KR" pitchFamily="34" charset="-120"/>
+              </a:rPr>
+              <a:t>• 배포 = aws s3 sync dist/ s3://… --delete 한 줄</a:t>
+            </a:r>
+            <a:endParaRPr lang="en-US" sz="1450" dirty="0"/>
+          </a:p>
+        </p:txBody>
+      </p:sp>
+      <p:sp>
+        <p:nvSpPr>
+          <p:cNvPr id="8" name="Shape 5"/>
+          <p:cNvSpPr/>
+          <p:nvPr/>
+        </p:nvSpPr>
+        <p:spPr>
+          <a:xfrm>
+            <a:off x="6309360" y="1645920"/>
+            <a:ext cx="5394960" cy="4480560"/>
+          </a:xfrm>
+          <a:prstGeom prst="roundRect">
+            <a:avLst>
+              <a:gd name="adj" fmla="val 2449"/>
             </a:avLst>
           </a:prstGeom>
           <a:solidFill>
@@ -9354,161 +10304,13 @@
       </p:sp>
       <p:sp>
         <p:nvSpPr>
-          <p:cNvPr id="6" name="Text 3"/>
-          <p:cNvSpPr/>
-          <p:nvPr/>
-        </p:nvSpPr>
-        <p:spPr>
-          <a:xfrm>
-            <a:off x="868680" y="1783080"/>
-            <a:ext cx="4937760" cy="365760"/>
-          </a:xfrm>
-          <a:prstGeom prst="rect">
-            <a:avLst/>
-          </a:prstGeom>
-          <a:noFill/>
-          <a:ln/>
-        </p:spPr>
-        <p:txBody>
-          <a:bodyPr wrap="square" rtlCol="0" anchor="ctr"/>
-          <a:lstStyle/>
-          <a:p>
-            <a:pPr indent="0" marL="0">
-              <a:buNone/>
-            </a:pPr>
-            <a:r>
-              <a:rPr lang="en-US" sz="1300" b="1" spc="200" kern="0" dirty="0">
-                <a:solidFill>
-                  <a:srgbClr val="22D3EE"/>
-                </a:solidFill>
-                <a:latin typeface="Noto Sans KR" pitchFamily="34" charset="0"/>
-                <a:ea typeface="Noto Sans KR" pitchFamily="34" charset="-122"/>
-                <a:cs typeface="Noto Sans KR" pitchFamily="34" charset="-120"/>
-              </a:rPr>
-              <a:t>① 서비스 레벨 (App Auto Scaling)</a:t>
-            </a:r>
-            <a:endParaRPr lang="en-US" sz="1300" dirty="0"/>
-          </a:p>
-        </p:txBody>
-      </p:sp>
-      <p:sp>
-        <p:nvSpPr>
-          <p:cNvPr id="7" name="Text 4"/>
-          <p:cNvSpPr/>
-          <p:nvPr/>
-        </p:nvSpPr>
-        <p:spPr>
-          <a:xfrm>
-            <a:off x="868680" y="2148840"/>
-            <a:ext cx="4937760" cy="1417320"/>
-          </a:xfrm>
-          <a:prstGeom prst="rect">
-            <a:avLst/>
-          </a:prstGeom>
-          <a:noFill/>
-          <a:ln/>
-        </p:spPr>
-        <p:txBody>
-          <a:bodyPr wrap="square" rtlCol="0" anchor="t"/>
-          <a:lstStyle/>
-          <a:p>
-            <a:pPr indent="0" marL="0">
-              <a:lnSpc>
-                <a:spcPct val="135000"/>
-              </a:lnSpc>
-              <a:buNone/>
-            </a:pPr>
-            <a:r>
-              <a:rPr lang="en-US" sz="1450" dirty="0">
-                <a:solidFill>
-                  <a:srgbClr val="E7E9FF"/>
-                </a:solidFill>
-                <a:latin typeface="Noto Sans KR" pitchFamily="34" charset="0"/>
-                <a:ea typeface="Noto Sans KR" pitchFamily="34" charset="-122"/>
-                <a:cs typeface="Noto Sans KR" pitchFamily="34" charset="-120"/>
-              </a:rPr>
-              <a:t>• ECS Service 태스크 수: 2 ~ 8개</a:t>
-            </a:r>
-            <a:endParaRPr lang="en-US" sz="1450" dirty="0"/>
-          </a:p>
-          <a:p>
-            <a:pPr indent="0" marL="0">
-              <a:lnSpc>
-                <a:spcPct val="135000"/>
-              </a:lnSpc>
-              <a:buNone/>
-            </a:pPr>
-            <a:r>
-              <a:rPr lang="en-US" sz="1450" dirty="0">
-                <a:solidFill>
-                  <a:srgbClr val="E7E9FF"/>
-                </a:solidFill>
-                <a:latin typeface="Noto Sans KR" pitchFamily="34" charset="0"/>
-                <a:ea typeface="Noto Sans KR" pitchFamily="34" charset="-122"/>
-                <a:cs typeface="Noto Sans KR" pitchFamily="34" charset="-120"/>
-              </a:rPr>
-              <a:t>• CPU 70% 타깃 트래킹</a:t>
-            </a:r>
-            <a:endParaRPr lang="en-US" sz="1450" dirty="0"/>
-          </a:p>
-          <a:p>
-            <a:pPr indent="0" marL="0">
-              <a:lnSpc>
-                <a:spcPct val="135000"/>
-              </a:lnSpc>
-              <a:buNone/>
-            </a:pPr>
-            <a:r>
-              <a:rPr lang="en-US" sz="1450" dirty="0">
-                <a:solidFill>
-                  <a:srgbClr val="E7E9FF"/>
-                </a:solidFill>
-                <a:latin typeface="Noto Sans KR" pitchFamily="34" charset="0"/>
-                <a:ea typeface="Noto Sans KR" pitchFamily="34" charset="-122"/>
-                <a:cs typeface="Noto Sans KR" pitchFamily="34" charset="-120"/>
-              </a:rPr>
-              <a:t>• scale-out 60s / scale-in 300s 쿨다운</a:t>
-            </a:r>
-            <a:endParaRPr lang="en-US" sz="1450" dirty="0"/>
-          </a:p>
-        </p:txBody>
-      </p:sp>
-      <p:sp>
-        <p:nvSpPr>
-          <p:cNvPr id="8" name="Shape 5"/>
-          <p:cNvSpPr/>
-          <p:nvPr/>
-        </p:nvSpPr>
-        <p:spPr>
-          <a:xfrm>
-            <a:off x="640080" y="3931920"/>
-            <a:ext cx="5394960" cy="2194560"/>
-          </a:xfrm>
-          <a:prstGeom prst="roundRect">
-            <a:avLst>
-              <a:gd name="adj" fmla="val 5000"/>
-            </a:avLst>
-          </a:prstGeom>
-          <a:solidFill>
-            <a:srgbClr val="111120"/>
-          </a:solidFill>
-          <a:ln w="12700">
-            <a:solidFill>
-              <a:srgbClr val="A78BFA"/>
-            </a:solidFill>
-            <a:prstDash val="solid"/>
-          </a:ln>
-        </p:spPr>
-      </p:sp>
-      <p:sp>
-        <p:nvSpPr>
           <p:cNvPr id="9" name="Text 6"/>
           <p:cNvSpPr/>
           <p:nvPr/>
         </p:nvSpPr>
         <p:spPr>
           <a:xfrm>
-            <a:off x="868680" y="4069080"/>
+            <a:off x="6537960" y="1783080"/>
             <a:ext cx="4937760" cy="365760"/>
           </a:xfrm>
           <a:prstGeom prst="rect">
@@ -9527,13 +10329,13 @@
             <a:r>
               <a:rPr lang="en-US" sz="1300" b="1" spc="200" kern="0" dirty="0">
                 <a:solidFill>
-                  <a:srgbClr val="A78BFA"/>
-                </a:solidFill>
-                <a:latin typeface="Noto Sans KR" pitchFamily="34" charset="0"/>
-                <a:ea typeface="Noto Sans KR" pitchFamily="34" charset="-122"/>
-                <a:cs typeface="Noto Sans KR" pitchFamily="34" charset="-120"/>
-              </a:rPr>
-              <a:t>② 인프라 레벨 (Capacity Provider)</a:t>
+                  <a:srgbClr val="22D3EE"/>
+                </a:solidFill>
+                <a:latin typeface="Noto Sans KR" pitchFamily="34" charset="0"/>
+                <a:ea typeface="Noto Sans KR" pitchFamily="34" charset="-122"/>
+                <a:cs typeface="Noto Sans KR" pitchFamily="34" charset="-120"/>
+              </a:rPr>
+              <a:t>버킷 B — 게임 히스토리</a:t>
             </a:r>
             <a:endParaRPr lang="en-US" sz="1300" dirty="0"/>
           </a:p>
@@ -9547,8 +10349,8 @@
         </p:nvSpPr>
         <p:spPr>
           <a:xfrm>
-            <a:off x="868680" y="4434840"/>
-            <a:ext cx="4937760" cy="1508760"/>
+            <a:off x="6537960" y="2148840"/>
+            <a:ext cx="4937760" cy="3794760"/>
           </a:xfrm>
           <a:prstGeom prst="rect">
             <a:avLst/>
@@ -9575,7 +10377,7 @@
                 <a:ea typeface="Noto Sans KR" pitchFamily="34" charset="-122"/>
                 <a:cs typeface="Noto Sans KR" pitchFamily="34" charset="-120"/>
               </a:rPr>
-              <a:t>• ASG: t3.small 2 ~ 4대</a:t>
+              <a:t>• 게임 종료 시 결과를 games/{game_id}.json으로 저장</a:t>
             </a:r>
             <a:endParaRPr lang="en-US" sz="1450" dirty="0"/>
           </a:p>
@@ -9595,7 +10397,7 @@
                 <a:ea typeface="Noto Sans KR" pitchFamily="34" charset="-122"/>
                 <a:cs typeface="Noto Sans KR" pitchFamily="34" charset="-120"/>
               </a:rPr>
-              <a:t>• 타깃 capacity 80% — 태스크가 못 들어가면 EC2 자동 증설</a:t>
+              <a:t>  (승자, 플레이어별 최종 칩, 종료 시각)</a:t>
             </a:r>
             <a:endParaRPr lang="en-US" sz="1450" dirty="0"/>
           </a:p>
@@ -9606,6 +10408,15 @@
               </a:lnSpc>
               <a:buNone/>
             </a:pPr>
+            <a:endParaRPr lang="en-US" sz="1450" dirty="0"/>
+          </a:p>
+          <a:p>
+            <a:pPr indent="0" marL="0">
+              <a:lnSpc>
+                <a:spcPct val="135000"/>
+              </a:lnSpc>
+              <a:buNone/>
+            </a:pPr>
             <a:r>
               <a:rPr lang="en-US" sz="1450" dirty="0">
                 <a:solidFill>
@@ -9615,98 +10426,10 @@
                 <a:ea typeface="Noto Sans KR" pitchFamily="34" charset="-122"/>
                 <a:cs typeface="Noto Sans KR" pitchFamily="34" charset="-120"/>
               </a:rPr>
-              <a:t>• 관리형 스케일링: ECS가 ASG를 직접 조정</a:t>
+              <a:t>• Task Role에는 이 버킷 PutObject 권한만 부여 (최소 권한)</a:t>
             </a:r>
             <a:endParaRPr lang="en-US" sz="1450" dirty="0"/>
           </a:p>
-        </p:txBody>
-      </p:sp>
-      <p:sp>
-        <p:nvSpPr>
-          <p:cNvPr id="11" name="Shape 8"/>
-          <p:cNvSpPr/>
-          <p:nvPr/>
-        </p:nvSpPr>
-        <p:spPr>
-          <a:xfrm>
-            <a:off x="6309360" y="1645920"/>
-            <a:ext cx="5394960" cy="4480560"/>
-          </a:xfrm>
-          <a:prstGeom prst="roundRect">
-            <a:avLst>
-              <a:gd name="adj" fmla="val 2449"/>
-            </a:avLst>
-          </a:prstGeom>
-          <a:solidFill>
-            <a:srgbClr val="111120"/>
-          </a:solidFill>
-          <a:ln w="12700">
-            <a:solidFill>
-              <a:srgbClr val="34D399"/>
-            </a:solidFill>
-            <a:prstDash val="solid"/>
-          </a:ln>
-        </p:spPr>
-      </p:sp>
-      <p:sp>
-        <p:nvSpPr>
-          <p:cNvPr id="12" name="Text 9"/>
-          <p:cNvSpPr/>
-          <p:nvPr/>
-        </p:nvSpPr>
-        <p:spPr>
-          <a:xfrm>
-            <a:off x="6537960" y="1783080"/>
-            <a:ext cx="4937760" cy="365760"/>
-          </a:xfrm>
-          <a:prstGeom prst="rect">
-            <a:avLst/>
-          </a:prstGeom>
-          <a:noFill/>
-          <a:ln/>
-        </p:spPr>
-        <p:txBody>
-          <a:bodyPr wrap="square" rtlCol="0" anchor="ctr"/>
-          <a:lstStyle/>
-          <a:p>
-            <a:pPr indent="0" marL="0">
-              <a:buNone/>
-            </a:pPr>
-            <a:r>
-              <a:rPr lang="en-US" sz="1300" b="1" spc="200" kern="0" dirty="0">
-                <a:solidFill>
-                  <a:srgbClr val="34D399"/>
-                </a:solidFill>
-                <a:latin typeface="Noto Sans KR" pitchFamily="34" charset="0"/>
-                <a:ea typeface="Noto Sans KR" pitchFamily="34" charset="-122"/>
-                <a:cs typeface="Noto Sans KR" pitchFamily="34" charset="-120"/>
-              </a:rPr>
-              <a:t>동작 흐름</a:t>
-            </a:r>
-            <a:endParaRPr lang="en-US" sz="1300" dirty="0"/>
-          </a:p>
-        </p:txBody>
-      </p:sp>
-      <p:sp>
-        <p:nvSpPr>
-          <p:cNvPr id="13" name="Text 10"/>
-          <p:cNvSpPr/>
-          <p:nvPr/>
-        </p:nvSpPr>
-        <p:spPr>
-          <a:xfrm>
-            <a:off x="6537960" y="2148840"/>
-            <a:ext cx="4937760" cy="3794760"/>
-          </a:xfrm>
-          <a:prstGeom prst="rect">
-            <a:avLst/>
-          </a:prstGeom>
-          <a:noFill/>
-          <a:ln/>
-        </p:spPr>
-        <p:txBody>
-          <a:bodyPr wrap="square" rtlCol="0" anchor="t"/>
-          <a:lstStyle/>
           <a:p>
             <a:pPr indent="0" marL="0">
               <a:lnSpc>
@@ -9714,6 +10437,15 @@
               </a:lnSpc>
               <a:buNone/>
             </a:pPr>
+            <a:endParaRPr lang="en-US" sz="1450" dirty="0"/>
+          </a:p>
+          <a:p>
+            <a:pPr indent="0" marL="0">
+              <a:lnSpc>
+                <a:spcPct val="135000"/>
+              </a:lnSpc>
+              <a:buNone/>
+            </a:pPr>
             <a:r>
               <a:rPr lang="en-US" sz="1450" dirty="0">
                 <a:solidFill>
@@ -9723,7 +10455,7 @@
                 <a:ea typeface="Noto Sans KR" pitchFamily="34" charset="-122"/>
                 <a:cs typeface="Noto Sans KR" pitchFamily="34" charset="-120"/>
               </a:rPr>
-              <a:t>트래픽 증가</a:t>
+              <a:t>• 저장 실패해도 게임 흐름은 막지 않음 (비동기 + 로깅)</a:t>
             </a:r>
             <a:endParaRPr lang="en-US" sz="1450" dirty="0"/>
           </a:p>
@@ -9734,6 +10466,15 @@
               </a:lnSpc>
               <a:buNone/>
             </a:pPr>
+            <a:endParaRPr lang="en-US" sz="1450" dirty="0"/>
+          </a:p>
+          <a:p>
+            <a:pPr indent="0" marL="0">
+              <a:lnSpc>
+                <a:spcPct val="135000"/>
+              </a:lnSpc>
+              <a:buNone/>
+            </a:pPr>
             <a:r>
               <a:rPr lang="en-US" sz="1450" dirty="0">
                 <a:solidFill>
@@ -9743,116 +10484,7 @@
                 <a:ea typeface="Noto Sans KR" pitchFamily="34" charset="-122"/>
                 <a:cs typeface="Noto Sans KR" pitchFamily="34" charset="-120"/>
               </a:rPr>
-              <a:t>→ 태스크 CPU 70% 초과</a:t>
-            </a:r>
-            <a:endParaRPr lang="en-US" sz="1450" dirty="0"/>
-          </a:p>
-          <a:p>
-            <a:pPr indent="0" marL="0">
-              <a:lnSpc>
-                <a:spcPct val="135000"/>
-              </a:lnSpc>
-              <a:buNone/>
-            </a:pPr>
-            <a:r>
-              <a:rPr lang="en-US" sz="1450" dirty="0">
-                <a:solidFill>
-                  <a:srgbClr val="E7E9FF"/>
-                </a:solidFill>
-                <a:latin typeface="Noto Sans KR" pitchFamily="34" charset="0"/>
-                <a:ea typeface="Noto Sans KR" pitchFamily="34" charset="-122"/>
-                <a:cs typeface="Noto Sans KR" pitchFamily="34" charset="-120"/>
-              </a:rPr>
-              <a:t>→ 태스크 증설 (서비스 레벨)</a:t>
-            </a:r>
-            <a:endParaRPr lang="en-US" sz="1450" dirty="0"/>
-          </a:p>
-          <a:p>
-            <a:pPr indent="0" marL="0">
-              <a:lnSpc>
-                <a:spcPct val="135000"/>
-              </a:lnSpc>
-              <a:buNone/>
-            </a:pPr>
-            <a:r>
-              <a:rPr lang="en-US" sz="1450" dirty="0">
-                <a:solidFill>
-                  <a:srgbClr val="E7E9FF"/>
-                </a:solidFill>
-                <a:latin typeface="Noto Sans KR" pitchFamily="34" charset="0"/>
-                <a:ea typeface="Noto Sans KR" pitchFamily="34" charset="-122"/>
-                <a:cs typeface="Noto Sans KR" pitchFamily="34" charset="-120"/>
-              </a:rPr>
-              <a:t>→ EC2에 빈 자리 부족</a:t>
-            </a:r>
-            <a:endParaRPr lang="en-US" sz="1450" dirty="0"/>
-          </a:p>
-          <a:p>
-            <a:pPr indent="0" marL="0">
-              <a:lnSpc>
-                <a:spcPct val="135000"/>
-              </a:lnSpc>
-              <a:buNone/>
-            </a:pPr>
-            <a:r>
-              <a:rPr lang="en-US" sz="1450" dirty="0">
-                <a:solidFill>
-                  <a:srgbClr val="E7E9FF"/>
-                </a:solidFill>
-                <a:latin typeface="Noto Sans KR" pitchFamily="34" charset="0"/>
-                <a:ea typeface="Noto Sans KR" pitchFamily="34" charset="-122"/>
-                <a:cs typeface="Noto Sans KR" pitchFamily="34" charset="-120"/>
-              </a:rPr>
-              <a:t>→ EC2 증설 (Capacity Provider)</a:t>
-            </a:r>
-            <a:endParaRPr lang="en-US" sz="1450" dirty="0"/>
-          </a:p>
-          <a:p>
-            <a:pPr indent="0" marL="0">
-              <a:lnSpc>
-                <a:spcPct val="135000"/>
-              </a:lnSpc>
-              <a:buNone/>
-            </a:pPr>
-            <a:endParaRPr lang="en-US" sz="1450" dirty="0"/>
-          </a:p>
-          <a:p>
-            <a:pPr indent="0" marL="0">
-              <a:lnSpc>
-                <a:spcPct val="135000"/>
-              </a:lnSpc>
-              <a:buNone/>
-            </a:pPr>
-            <a:r>
-              <a:rPr lang="en-US" sz="1450" dirty="0">
-                <a:solidFill>
-                  <a:srgbClr val="E7E9FF"/>
-                </a:solidFill>
-                <a:latin typeface="Noto Sans KR" pitchFamily="34" charset="0"/>
-                <a:ea typeface="Noto Sans KR" pitchFamily="34" charset="-122"/>
-                <a:cs typeface="Noto Sans KR" pitchFamily="34" charset="-120"/>
-              </a:rPr>
-              <a:t>반대로 한가하면 역순 축소</a:t>
-            </a:r>
-            <a:endParaRPr lang="en-US" sz="1450" dirty="0"/>
-          </a:p>
-          <a:p>
-            <a:pPr indent="0" marL="0">
-              <a:lnSpc>
-                <a:spcPct val="135000"/>
-              </a:lnSpc>
-              <a:buNone/>
-            </a:pPr>
-            <a:r>
-              <a:rPr lang="en-US" sz="1450" dirty="0">
-                <a:solidFill>
-                  <a:srgbClr val="E7E9FF"/>
-                </a:solidFill>
-                <a:latin typeface="Noto Sans KR" pitchFamily="34" charset="0"/>
-                <a:ea typeface="Noto Sans KR" pitchFamily="34" charset="-122"/>
-                <a:cs typeface="Noto Sans KR" pitchFamily="34" charset="-120"/>
-              </a:rPr>
-              <a:t>실습 중에는 비용 절약을 위해 desired 0으로 내려두기도</a:t>
+              <a:t>• Redis는 "현재 상태", S3는 "영구 기록" — 핫/콜드 분리</a:t>
             </a:r>
             <a:endParaRPr lang="en-US" sz="1450" dirty="0"/>
           </a:p>

</xml_diff>